<commit_message>
Rework lessons deck per review: modeling lessons only, numbers-first
Drop the 'unmodeled majority' (other/deduction errors) slide and all
real-world/data-semantics claims; plain titles; add a tuning slide
(engine pairing, mtry, subsample, eta findings); every remaining claim
carries a measurement from our runs. 14 slides.

Co-Authored-By: Claude Fable 5 <noreply@anthropic.com>
</commit_message>
<xml_diff>
--- a/lessons_getting_more_signal_from_snap_qc_data.pptx
+++ b/lessons_getting_more_signal_from_snap_qc_data.pptx
@@ -22,8 +22,6 @@
     <p:sldId id="290" r:id="rId41"/>
     <p:sldId id="291" r:id="rId42"/>
     <p:sldId id="292" r:id="rId43"/>
-    <p:sldId id="293" r:id="rId44"/>
-    <p:sldId id="294" r:id="rId45"/>
   </p:sldIdLst>
   <p:sldSz cx="9144000" cy="5143500" type="screen16x9"/>
   <p:notesSz cx="5143500" cy="9144000"/>
@@ -7725,7 +7723,7 @@
           <a:p>
             <a:r>
               <a:rPr sz="2200" b="1"/>
-              <a:t>Getting more signal out of SNAP QC data</a:t>
+              <a:t>Getting more signal out of SNAP QC data: modeling lessons</a:t>
             </a:r>
           </a:p>
         </p:txBody>
@@ -7759,7 +7757,7 @@
             </a:pPr>
             <a:r>
               <a:rPr sz="1200"/>
-              <a:t>Lessons from building and rebuilding an error-mining pipeline on the public QC files.</a:t>
+              <a:t>What we learned from building, tuning, and stress-testing an error-mining pipeline on the public QC files.</a:t>
             </a:r>
           </a:p>
         </p:txBody>
@@ -7771,7 +7769,7 @@
           </a:pPr>
           <a:r>
             <a:rPr sz="1200"/>
-            <a:t>Lessons from building and rebuilding an error-mining pipeline on the public QC files.</a:t>
+            <a:t>What we learned from building, tuning, and stress-testing an error-mining pipeline on the public QC files.</a:t>
           </a:r>
         </a:p>
       </p:sp>
@@ -7783,7 +7781,7 @@
         </a:pPr>
         <a:r>
           <a:rPr sz="1200"/>
-          <a:t>Lessons from building and rebuilding an error-mining pipeline on the public QC files.</a:t>
+          <a:t>What we learned from building, tuning, and stress-testing an error-mining pipeline on the public QC files.</a:t>
         </a:r>
       </a:p>
     </p:spTree>
@@ -7828,7 +7826,7 @@
           <a:p>
             <a:r>
               <a:rPr sz="2200" b="1"/>
-              <a:t>Where these lessons come from</a:t>
+              <a:t>What we ran</a:t>
             </a:r>
           </a:p>
         </p:txBody>
@@ -7862,7 +7860,7 @@
             </a:pPr>
             <a:r>
               <a:rPr sz="1200"/>
-              <a:t>- We mine the public SNAP QC files for interpretable rules that flag high-risk cases for review (or safely exclude low-risk ones).</a:t>
+              <a:t>- Task: mine interpretable rules that flag high-error-risk cases; judge every configuration on a year of data it never saw (train 2022+2024, test 2023).</a:t>
             </a:r>
           </a:p>
         </p:txBody>
@@ -7874,7 +7872,7 @@
           </a:pPr>
           <a:r>
             <a:rPr sz="1200"/>
-            <a:t>- We mine the public SNAP QC files for interpretable rules that flag high-risk cases for review (or safely exclude low-risk ones).</a:t>
+            <a:t>- Task: mine interpretable rules that flag high-error-risk cases; judge every configuration on a year of data it never saw (train 2022+2024, test 2023).</a:t>
           </a:r>
         </a:p>
       </p:sp>
@@ -7886,7 +7884,7 @@
         </a:pPr>
         <a:r>
           <a:rPr sz="1200"/>
-          <a:t>- We mine the public SNAP QC files for interpretable rules that flag high-risk cases for review (or safely exclude low-risk ones).</a:t>
+          <a:t>- Task: mine interpretable rules that flag high-error-risk cases; judge every configuration on a year of data it never saw (train 2022+2024, test 2023).</a:t>
         </a:r>
       </a:p>
       <p:sp>
@@ -7913,7 +7911,7 @@
           <a:p>
             <a:r>
               <a:rPr sz="1000" i="1"/>
-              <a:t>Lessons from the SNAP QC error-mining project - July 2026</a:t>
+              <a:t>SNAP QC modeling lessons - July 2026</a:t>
             </a:r>
           </a:p>
         </p:txBody>
@@ -7960,7 +7958,7 @@
           <a:p>
             <a:r>
               <a:rPr sz="2200" b="1"/>
-              <a:t>Know what your data cannot see</a:t>
+              <a:t>Two data-build choices changed results more than any tuning</a:t>
             </a:r>
           </a:p>
         </p:txBody>
@@ -7994,7 +7992,7 @@
             </a:pPr>
             <a:r>
               <a:rPr sz="1200"/>
-              <a:t>- The public QC files EXCLUDE cases found ineligible - which are 100%-of-benefit errors. The technical documentation quantifies the exclusions; almost nobody reads those counts.</a:t>
+              <a:t>- Cases whose review found a second error element did not fit our single-error reconstruction and were being dropped: 31% of all above-threshold error cases. Keeping them (with a flag) raised qualifying rules from 3,741 to 11,018 at the same filter - more error data tightens every statistical bound.</a:t>
             </a:r>
           </a:p>
         </p:txBody>
@@ -8006,7 +8004,7 @@
           </a:pPr>
           <a:r>
             <a:rPr sz="1200"/>
-            <a:t>- The public QC files EXCLUDE cases found ineligible - which are 100%-of-benefit errors. The technical documentation quantifies the exclusions; almost nobody reads those counts.</a:t>
+            <a:t>- Cases whose review found a second error element did not fit our single-error reconstruction and were being dropped: 31% of all above-threshold error cases. Keeping them (with a flag) raised qualifying rules from 3,741 to 11,018 at the same filter - more error data tightens every statistical bound.</a:t>
           </a:r>
         </a:p>
       </p:sp>
@@ -8018,7 +8016,7 @@
         </a:pPr>
         <a:r>
           <a:rPr sz="1200"/>
-          <a:t>- The public QC files EXCLUDE cases found ineligible - which are 100%-of-benefit errors. The technical documentation quantifies the exclusions; almost nobody reads those counts.</a:t>
+          <a:t>- Cases whose review found a second error element did not fit our single-error reconstruction and were being dropped: 31% of all above-threshold error cases. Keeping them (with a flag) raised qualifying rules from 3,741 to 11,018 at the same filter - more error data tightens every statistical bound.</a:t>
         </a:r>
       </a:p>
       <p:sp>
@@ -8045,7 +8043,139 @@
           <a:p>
             <a:r>
               <a:rPr sz="1000" i="1"/>
-              <a:t>Lessons from the SNAP QC error-mining project - July 2026</a:t>
+              <a:t>SNAP QC modeling lessons - July 2026</a:t>
+            </a:r>
+          </a:p>
+        </p:txBody>
+      </p:sp>
+    </p:spTree>
+  </p:cSld>
+  <p:clrMapOvr>
+    <a:masterClrMapping/>
+  </p:clrMapOvr>
+</p:sld>
+</file>
+
+<file path=ppt/slides/slide26.xml><?xml version="1.0" encoding="utf-8"?>
+<p:sld xmlns:a="http://schemas.openxmlformats.org/drawingml/2006/main" xmlns:p="http://schemas.openxmlformats.org/presentationml/2006/main" xmlns:r="http://schemas.openxmlformats.org/officeDocument/2006/relationships">
+  <p:cSld>
+    <p:spTree>
+      <p:nvGrpSpPr>
+        <p:cNvPr id="1" name=""/>
+        <p:cNvGrpSpPr/>
+        <p:nvPr/>
+      </p:nvGrpSpPr>
+      <p:grpSpPr/>
+      <p:sp>
+        <p:nvSpPr>
+          <p:cNvPr id="2" name="TextBox 1"/>
+          <p:cNvSpPr txBox="1"/>
+          <p:nvPr/>
+        </p:nvSpPr>
+        <p:spPr>
+          <a:xfrm>
+            <a:off x="400000" y="200000"/>
+            <a:ext cx="8344000" cy="600000"/>
+          </a:xfrm>
+          <a:prstGeom prst="rect">
+            <a:avLst/>
+          </a:prstGeom>
+          <a:noFill/>
+        </p:spPr>
+        <p:txBody>
+          <a:bodyPr wrap="none">
+            <a:spAutoFit/>
+          </a:bodyPr>
+          <a:lstStyle/>
+          <a:p>
+            <a:r>
+              <a:rPr sz="2200" b="1"/>
+              <a:t>Check how much of the error population your data can see</a:t>
+            </a:r>
+          </a:p>
+        </p:txBody>
+      </p:sp>
+      <p:sp>
+        <p:nvSpPr>
+          <p:cNvPr id="4" name="TextBox 3"/>
+          <p:cNvSpPr txBox="1"/>
+          <p:nvPr/>
+        </p:nvSpPr>
+        <p:spPr>
+          <a:xfrm>
+            <a:off x="400000" y="760000"/>
+            <a:ext cx="8344000" cy="430000"/>
+          </a:xfrm>
+          <a:prstGeom prst="rect">
+            <a:avLst/>
+          </a:prstGeom>
+          <a:noFill/>
+        </p:spPr>
+        <p:txBody>
+          <a:bodyPr wrap="square">
+            <a:spAutoFit/>
+          </a:bodyPr>
+          <a:lstStyle/>
+          <a:p>
+            <a:pPr>
+              <a:spcAft>
+                <a:spcPts val="400"/>
+              </a:spcAft>
+            </a:pPr>
+            <a:r>
+              <a:rPr sz="1200"/>
+              <a:t>- We reconciled the public files against the QC technical documentation's exclusion counts, per state and year (2022-24).</a:t>
+            </a:r>
+          </a:p>
+        </p:txBody>
+        <a:p>
+          <a:pPr>
+            <a:spcAft>
+              <a:spcPts val="400"/>
+            </a:spcAft>
+          </a:pPr>
+          <a:r>
+            <a:rPr sz="1200"/>
+            <a:t>- We reconciled the public files against the QC technical documentation's exclusion counts, per state and year (2022-24).</a:t>
+          </a:r>
+        </a:p>
+      </p:sp>
+      <a:p>
+        <a:pPr>
+          <a:spcAft>
+            <a:spcPts val="400"/>
+          </a:spcAft>
+        </a:pPr>
+        <a:r>
+          <a:rPr sz="1200"/>
+          <a:t>- We reconciled the public files against the QC technical documentation's exclusion counts, per state and year (2022-24).</a:t>
+        </a:r>
+      </a:p>
+      <p:sp>
+        <p:nvSpPr>
+          <p:cNvPr id="3" name="TextBox 2"/>
+          <p:cNvSpPr txBox="1"/>
+          <p:nvPr/>
+        </p:nvSpPr>
+        <p:spPr>
+          <a:xfrm>
+            <a:off x="400000" y="4723500"/>
+            <a:ext cx="3200000" cy="320000"/>
+          </a:xfrm>
+          <a:prstGeom prst="rect">
+            <a:avLst/>
+          </a:prstGeom>
+          <a:noFill/>
+        </p:spPr>
+        <p:txBody>
+          <a:bodyPr wrap="none">
+            <a:spAutoFit/>
+          </a:bodyPr>
+          <a:lstStyle/>
+          <a:p>
+            <a:r>
+              <a:rPr sz="1000" i="1"/>
+              <a:t>SNAP QC modeling lessons - July 2026</a:t>
             </a:r>
           </a:p>
         </p:txBody>
@@ -8059,7 +8189,7 @@
           <p:nvPr/>
         </p:nvGraphicFramePr>
         <p:xfrm>
-          <a:off x="1600200" y="2752344"/>
+          <a:off x="1600200" y="2240280"/>
           <a:ext cx="5943600" cy="1755648"/>
         </p:xfrm>
         <a:graphic>
@@ -8093,7 +8223,7 @@
                     <a:p>
                       <a:r>
                         <a:rPr sz="1200" b="1"/>
-                        <a:t>visible share of errors</a:t>
+                        <a:t>visible share of error cases</a:t>
                       </a:r>
                     </a:p>
                   </a:txBody>
@@ -8252,138 +8382,6 @@
 </p:sld>
 </file>
 
-<file path=ppt/slides/slide26.xml><?xml version="1.0" encoding="utf-8"?>
-<p:sld xmlns:a="http://schemas.openxmlformats.org/drawingml/2006/main" xmlns:p="http://schemas.openxmlformats.org/presentationml/2006/main" xmlns:r="http://schemas.openxmlformats.org/officeDocument/2006/relationships">
-  <p:cSld>
-    <p:spTree>
-      <p:nvGrpSpPr>
-        <p:cNvPr id="1" name=""/>
-        <p:cNvGrpSpPr/>
-        <p:nvPr/>
-      </p:nvGrpSpPr>
-      <p:grpSpPr/>
-      <p:sp>
-        <p:nvSpPr>
-          <p:cNvPr id="2" name="TextBox 1"/>
-          <p:cNvSpPr txBox="1"/>
-          <p:nvPr/>
-        </p:nvSpPr>
-        <p:spPr>
-          <a:xfrm>
-            <a:off x="400000" y="200000"/>
-            <a:ext cx="8344000" cy="600000"/>
-          </a:xfrm>
-          <a:prstGeom prst="rect">
-            <a:avLst/>
-          </a:prstGeom>
-          <a:noFill/>
-        </p:spPr>
-        <p:txBody>
-          <a:bodyPr wrap="none">
-            <a:spAutoFit/>
-          </a:bodyPr>
-          <a:lstStyle/>
-          <a:p>
-            <a:r>
-              <a:rPr sz="2200" b="1"/>
-              <a:t>Missing usually means 'not claimed', not 'unknown'</a:t>
-            </a:r>
-          </a:p>
-        </p:txBody>
-      </p:sp>
-      <p:sp>
-        <p:nvSpPr>
-          <p:cNvPr id="4" name="TextBox 3"/>
-          <p:cNvSpPr txBox="1"/>
-          <p:nvPr/>
-        </p:nvSpPr>
-        <p:spPr>
-          <a:xfrm>
-            <a:off x="400000" y="760000"/>
-            <a:ext cx="8344000" cy="430000"/>
-          </a:xfrm>
-          <a:prstGeom prst="rect">
-            <a:avLst/>
-          </a:prstGeom>
-          <a:noFill/>
-        </p:spPr>
-        <p:txBody>
-          <a:bodyPr wrap="square">
-            <a:spAutoFit/>
-          </a:bodyPr>
-          <a:lstStyle/>
-          <a:p>
-            <a:pPr>
-              <a:spcAft>
-                <a:spcPts val="400"/>
-              </a:spcAft>
-            </a:pPr>
-            <a:r>
-              <a:rPr sz="1200"/>
-              <a:t>- Deduction fields (dependent care, medical, child support, homeless) are blank when the household didn't claim the deduction. Dropping rows with blanks silently deletes real, clean cases.</a:t>
-            </a:r>
-          </a:p>
-        </p:txBody>
-        <a:p>
-          <a:pPr>
-            <a:spcAft>
-              <a:spcPts val="400"/>
-            </a:spcAft>
-          </a:pPr>
-          <a:r>
-            <a:rPr sz="1200"/>
-            <a:t>- Deduction fields (dependent care, medical, child support, homeless) are blank when the household didn't claim the deduction. Dropping rows with blanks silently deletes real, clean cases.</a:t>
-          </a:r>
-        </a:p>
-      </p:sp>
-      <a:p>
-        <a:pPr>
-          <a:spcAft>
-            <a:spcPts val="400"/>
-          </a:spcAft>
-        </a:pPr>
-        <a:r>
-          <a:rPr sz="1200"/>
-          <a:t>- Deduction fields (dependent care, medical, child support, homeless) are blank when the household didn't claim the deduction. Dropping rows with blanks silently deletes real, clean cases.</a:t>
-        </a:r>
-      </a:p>
-      <p:sp>
-        <p:nvSpPr>
-          <p:cNvPr id="3" name="TextBox 2"/>
-          <p:cNvSpPr txBox="1"/>
-          <p:nvPr/>
-        </p:nvSpPr>
-        <p:spPr>
-          <a:xfrm>
-            <a:off x="400000" y="4723500"/>
-            <a:ext cx="3200000" cy="320000"/>
-          </a:xfrm>
-          <a:prstGeom prst="rect">
-            <a:avLst/>
-          </a:prstGeom>
-          <a:noFill/>
-        </p:spPr>
-        <p:txBody>
-          <a:bodyPr wrap="none">
-            <a:spAutoFit/>
-          </a:bodyPr>
-          <a:lstStyle/>
-          <a:p>
-            <a:r>
-              <a:rPr sz="1000" i="1"/>
-              <a:t>Lessons from the SNAP QC error-mining project - July 2026</a:t>
-            </a:r>
-          </a:p>
-        </p:txBody>
-      </p:sp>
-    </p:spTree>
-  </p:cSld>
-  <p:clrMapOvr>
-    <a:masterClrMapping/>
-  </p:clrMapOvr>
-</p:sld>
-</file>
-
 <file path=ppt/slides/slide27.xml><?xml version="1.0" encoding="utf-8"?>
 <p:sld xmlns:a="http://schemas.openxmlformats.org/drawingml/2006/main" xmlns:p="http://schemas.openxmlformats.org/presentationml/2006/main" xmlns:r="http://schemas.openxmlformats.org/officeDocument/2006/relationships">
   <p:cSld>
@@ -8418,7 +8416,7 @@
           <a:p>
             <a:r>
               <a:rPr sz="2200" b="1"/>
-              <a:t>Don't drop cases you can't fully reconcile - flag them</a:t>
+              <a:t>Selecting rules on raw training precision delivered half of it</a:t>
             </a:r>
           </a:p>
         </p:txBody>
@@ -8452,7 +8450,7 @@
             </a:pPr>
             <a:r>
               <a:rPr sz="1200"/>
-              <a:t>- QC reviews can find MULTIPLE errors in one case. Cases with a second error element didn't fit our single-error reconstruction, so an early version dropped them: 31% of all error cases, silently.</a:t>
+              <a:t>- Our 'train precision &gt;= 0.20' shortlist delivered ~0.10 on the held-out year. Before any selection, train precision was nearly unbiased for holdout (median gap -0.003, r = 0.83); rules selected on the HOLDOUT &gt;= 0.20 showed median train precision 0.116.</a:t>
             </a:r>
           </a:p>
         </p:txBody>
@@ -8464,7 +8462,7 @@
           </a:pPr>
           <a:r>
             <a:rPr sz="1200"/>
-            <a:t>- QC reviews can find MULTIPLE errors in one case. Cases with a second error element didn't fit our single-error reconstruction, so an early version dropped them: 31% of all error cases, silently.</a:t>
+            <a:t>- Our 'train precision &gt;= 0.20' shortlist delivered ~0.10 on the held-out year. Before any selection, train precision was nearly unbiased for holdout (median gap -0.003, r = 0.83); rules selected on the HOLDOUT &gt;= 0.20 showed median train precision 0.116.</a:t>
           </a:r>
         </a:p>
       </p:sp>
@@ -8476,7 +8474,7 @@
         </a:pPr>
         <a:r>
           <a:rPr sz="1200"/>
-          <a:t>- QC reviews can find MULTIPLE errors in one case. Cases with a second error element didn't fit our single-error reconstruction, so an early version dropped them: 31% of all error cases, silently.</a:t>
+          <a:t>- Our 'train precision &gt;= 0.20' shortlist delivered ~0.10 on the held-out year. Before any selection, train precision was nearly unbiased for holdout (median gap -0.003, r = 0.83); rules selected on the HOLDOUT &gt;= 0.20 showed median train precision 0.116.</a:t>
         </a:r>
       </a:p>
       <p:sp>
@@ -8503,11 +8501,35 @@
           <a:p>
             <a:r>
               <a:rPr sz="1000" i="1"/>
-              <a:t>Lessons from the SNAP QC error-mining project - July 2026</a:t>
+              <a:t>SNAP QC modeling lessons - July 2026</a:t>
             </a:r>
           </a:p>
         </p:txBody>
       </p:sp>
+      <p:pic>
+        <p:nvPicPr>
+          <p:cNvPr id="5" name="Picture 4" descr="image.png"/>
+          <p:cNvPicPr>
+            <a:picLocks noChangeAspect="1"/>
+          </p:cNvPicPr>
+          <p:nvPr/>
+        </p:nvPicPr>
+        <p:blipFill>
+          <a:blip r:embed="rId2"/>
+          <a:stretch>
+            <a:fillRect/>
+          </a:stretch>
+        </p:blipFill>
+        <p:spPr>
+          <a:xfrm>
+            <a:off x="3511296" y="2496312"/>
+            <a:ext cx="2121407" cy="2121407"/>
+          </a:xfrm>
+          <a:prstGeom prst="rect">
+            <a:avLst/>
+          </a:prstGeom>
+        </p:spPr>
+      </p:pic>
     </p:spTree>
   </p:cSld>
   <p:clrMapOvr>
@@ -8550,7 +8572,7 @@
           <a:p>
             <a:r>
               <a:rPr sz="2200" b="1"/>
-              <a:t>Rebuild derived datasets from the script, never by hand</a:t>
+              <a:t>Filter on a lower confidence bound of training precision</a:t>
             </a:r>
           </a:p>
         </p:txBody>
@@ -8584,7 +8606,7 @@
             </a:pPr>
             <a:r>
               <a:rPr sz="1200"/>
-              <a:t>- Our modelling frame was once saved by hand from an interactive session. It silently descended from a version with the multi-error drop still active - and every result for weeks was mined on 69% of the true errors.</a:t>
+              <a:t>- Keep a rule only if the one-sided 99% Wilson lower bound of its training precision clears the floor. At matched delivered precision (~0.20), lower-bound selection caught 12.8% of errors vs 8.2% for raw-precision selection.</a:t>
             </a:r>
           </a:p>
         </p:txBody>
@@ -8596,7 +8618,7 @@
           </a:pPr>
           <a:r>
             <a:rPr sz="1200"/>
-            <a:t>- Our modelling frame was once saved by hand from an interactive session. It silently descended from a version with the multi-error drop still active - and every result for weeks was mined on 69% of the true errors.</a:t>
+            <a:t>- Keep a rule only if the one-sided 99% Wilson lower bound of its training precision clears the floor. At matched delivered precision (~0.20), lower-bound selection caught 12.8% of errors vs 8.2% for raw-precision selection.</a:t>
           </a:r>
         </a:p>
       </p:sp>
@@ -8608,7 +8630,7 @@
         </a:pPr>
         <a:r>
           <a:rPr sz="1200"/>
-          <a:t>- Our modelling frame was once saved by hand from an interactive session. It silently descended from a version with the multi-error drop still active - and every result for weeks was mined on 69% of the true errors.</a:t>
+          <a:t>- Keep a rule only if the one-sided 99% Wilson lower bound of its training precision clears the floor. At matched delivered precision (~0.20), lower-bound selection caught 12.8% of errors vs 8.2% for raw-precision selection.</a:t>
         </a:r>
       </a:p>
       <p:sp>
@@ -8635,11 +8657,35 @@
           <a:p>
             <a:r>
               <a:rPr sz="1000" i="1"/>
-              <a:t>Lessons from the SNAP QC error-mining project - July 2026</a:t>
+              <a:t>SNAP QC modeling lessons - July 2026</a:t>
             </a:r>
           </a:p>
         </p:txBody>
       </p:sp>
+      <p:pic>
+        <p:nvPicPr>
+          <p:cNvPr id="5" name="Picture 4" descr="image.png"/>
+          <p:cNvPicPr>
+            <a:picLocks noChangeAspect="1"/>
+          </p:cNvPicPr>
+          <p:nvPr/>
+        </p:nvPicPr>
+        <p:blipFill>
+          <a:blip r:embed="rId2"/>
+          <a:stretch>
+            <a:fillRect/>
+          </a:stretch>
+        </p:blipFill>
+        <p:spPr>
+          <a:xfrm>
+            <a:off x="3295690" y="2752344"/>
+            <a:ext cx="2552619" cy="1865375"/>
+          </a:xfrm>
+          <a:prstGeom prst="rect">
+            <a:avLst/>
+          </a:prstGeom>
+        </p:spPr>
+      </p:pic>
     </p:spTree>
   </p:cSld>
   <p:clrMapOvr>
@@ -8682,7 +8728,7 @@
           <a:p>
             <a:r>
               <a:rPr sz="2200" b="1"/>
-              <a:t>Screening many candidates on raw performance selects lucky ones</a:t>
+              <a:t>Bigger ensembles widen the menu, not the frontier</a:t>
             </a:r>
           </a:p>
         </p:txBody>
@@ -8716,7 +8762,7 @@
             </a:pPr>
             <a:r>
               <a:rPr sz="1200"/>
-              <a:t>- Generate 100,000 candidate rules and keep those with the best measured precision, and you mostly keep rules that got lucky: our 'train precision &gt;= 0.20' shortlist delivered only ~0.10 on a year it had never seen.</a:t>
+              <a:t>- 1000-round/1000-tree ensembles traced the SAME precision-recall frontier as small ones - but produced several times more distinct rules clearing any given floor (~2.6-5x the filtered inventory).</a:t>
             </a:r>
           </a:p>
         </p:txBody>
@@ -8728,7 +8774,7 @@
           </a:pPr>
           <a:r>
             <a:rPr sz="1200"/>
-            <a:t>- Generate 100,000 candidate rules and keep those with the best measured precision, and you mostly keep rules that got lucky: our 'train precision &gt;= 0.20' shortlist delivered only ~0.10 on a year it had never seen.</a:t>
+            <a:t>- 1000-round/1000-tree ensembles traced the SAME precision-recall frontier as small ones - but produced several times more distinct rules clearing any given floor (~2.6-5x the filtered inventory).</a:t>
           </a:r>
         </a:p>
       </p:sp>
@@ -8740,7 +8786,7 @@
         </a:pPr>
         <a:r>
           <a:rPr sz="1200"/>
-          <a:t>- Generate 100,000 candidate rules and keep those with the best measured precision, and you mostly keep rules that got lucky: our 'train precision &gt;= 0.20' shortlist delivered only ~0.10 on a year it had never seen.</a:t>
+          <a:t>- 1000-round/1000-tree ensembles traced the SAME precision-recall frontier as small ones - but produced several times more distinct rules clearing any given floor (~2.6-5x the filtered inventory).</a:t>
         </a:r>
       </a:p>
       <p:sp>
@@ -8767,7 +8813,7 @@
           <a:p>
             <a:r>
               <a:rPr sz="1000" i="1"/>
-              <a:t>Lessons from the SNAP QC error-mining project - July 2026</a:t>
+              <a:t>SNAP QC modeling lessons - July 2026</a:t>
             </a:r>
           </a:p>
         </p:txBody>
@@ -8788,8 +8834,8 @@
         </p:blipFill>
         <p:spPr>
           <a:xfrm>
-            <a:off x="3639312" y="2752344"/>
-            <a:ext cx="1865375" cy="1865375"/>
+            <a:off x="2670048" y="2240280"/>
+            <a:ext cx="3803903" cy="2377439"/>
           </a:xfrm>
           <a:prstGeom prst="rect">
             <a:avLst/>
@@ -9380,7 +9426,7 @@
           <a:p>
             <a:r>
               <a:rPr sz="2200" b="1"/>
-              <a:t>Filter on a lower confidence bound, not the point estimate</a:t>
+              <a:t>Tuning: what moved held-out performance and what didn't</a:t>
             </a:r>
           </a:p>
         </p:txBody>
@@ -9414,7 +9460,7 @@
             </a:pPr>
             <a:r>
               <a:rPr sz="1200"/>
-              <a:t>- Keep a candidate only if the LOWER end of its precision confidence interval clears your bar. Small-sample lucky streaks fail this test automatically; well-supported patterns pass.</a:t>
+              <a:t>- Engine PAIRING mattered: xgboost + random forest (ranger) beat either engine alone and beat bagged-CART + ranger, everything else held equal.</a:t>
             </a:r>
           </a:p>
         </p:txBody>
@@ -9426,7 +9472,7 @@
           </a:pPr>
           <a:r>
             <a:rPr sz="1200"/>
-            <a:t>- Keep a candidate only if the LOWER end of its precision confidence interval clears your bar. Small-sample lucky streaks fail this test automatically; well-supported patterns pass.</a:t>
+            <a:t>- Engine PAIRING mattered: xgboost + random forest (ranger) beat either engine alone and beat bagged-CART + ranger, everything else held equal.</a:t>
           </a:r>
         </a:p>
       </p:sp>
@@ -9438,7 +9484,7 @@
         </a:pPr>
         <a:r>
           <a:rPr sz="1200"/>
-          <a:t>- Keep a candidate only if the LOWER end of its precision confidence interval clears your bar. Small-sample lucky streaks fail this test automatically; well-supported patterns pass.</a:t>
+          <a:t>- Engine PAIRING mattered: xgboost + random forest (ranger) beat either engine alone and beat bagged-CART + ranger, everything else held equal.</a:t>
         </a:r>
       </a:p>
       <p:sp>
@@ -9465,7 +9511,7 @@
           <a:p>
             <a:r>
               <a:rPr sz="1000" i="1"/>
-              <a:t>Lessons from the SNAP QC error-mining project - July 2026</a:t>
+              <a:t>SNAP QC modeling lessons - July 2026</a:t>
             </a:r>
           </a:p>
         </p:txBody>
@@ -9486,8 +9532,8 @@
         </p:blipFill>
         <p:spPr>
           <a:xfrm>
-            <a:off x="2945330" y="2240280"/>
-            <a:ext cx="3253338" cy="2377439"/>
+            <a:off x="3208237" y="2496312"/>
+            <a:ext cx="2727524" cy="2121407"/>
           </a:xfrm>
           <a:prstGeom prst="rect">
             <a:avLst/>
@@ -9536,7 +9582,7 @@
           <a:p>
             <a:r>
               <a:rPr sz="2200" b="1"/>
-              <a:t>Generate aggressively; let statistics do the vetoing</a:t>
+              <a:t>Score rules against all error types, not just the mined type</a:t>
             </a:r>
           </a:p>
         </p:txBody>
@@ -9570,7 +9616,7 @@
             </a:pPr>
             <a:r>
               <a:rPr sz="1200"/>
-              <a:t>- Bigger ensembles (1000 trees instead of 100) do not trace a better precision-recall frontier - but they find several times more DISTINCT patterns at every quality bar.</a:t>
+              <a:t>- Rules mined for one error type also flag cases carrying other types. Scored only against the mined type, our earned-income rules measured 8% precision on the held-out year; scored against any above-threshold error on the same flags, 19%.</a:t>
             </a:r>
           </a:p>
         </p:txBody>
@@ -9582,7 +9628,7 @@
           </a:pPr>
           <a:r>
             <a:rPr sz="1200"/>
-            <a:t>- Bigger ensembles (1000 trees instead of 100) do not trace a better precision-recall frontier - but they find several times more DISTINCT patterns at every quality bar.</a:t>
+            <a:t>- Rules mined for one error type also flag cases carrying other types. Scored only against the mined type, our earned-income rules measured 8% precision on the held-out year; scored against any above-threshold error on the same flags, 19%.</a:t>
           </a:r>
         </a:p>
       </p:sp>
@@ -9594,7 +9640,7 @@
         </a:pPr>
         <a:r>
           <a:rPr sz="1200"/>
-          <a:t>- Bigger ensembles (1000 trees instead of 100) do not trace a better precision-recall frontier - but they find several times more DISTINCT patterns at every quality bar.</a:t>
+          <a:t>- Rules mined for one error type also flag cases carrying other types. Scored only against the mined type, our earned-income rules measured 8% precision on the held-out year; scored against any above-threshold error on the same flags, 19%.</a:t>
         </a:r>
       </a:p>
       <p:sp>
@@ -9621,7 +9667,7 @@
           <a:p>
             <a:r>
               <a:rPr sz="1000" i="1"/>
-              <a:t>Lessons from the SNAP QC error-mining project - July 2026</a:t>
+              <a:t>SNAP QC modeling lessons - July 2026</a:t>
             </a:r>
           </a:p>
         </p:txBody>
@@ -9642,8 +9688,8 @@
         </p:blipFill>
         <p:spPr>
           <a:xfrm>
-            <a:off x="2874873" y="2496312"/>
-            <a:ext cx="3394252" cy="2121407"/>
+            <a:off x="2450592" y="2496312"/>
+            <a:ext cx="4242815" cy="2121407"/>
           </a:xfrm>
           <a:prstGeom prst="rect">
             <a:avLst/>
@@ -9692,7 +9738,7 @@
           <a:p>
             <a:r>
               <a:rPr sz="2200" b="1"/>
-              <a:t>Count every error you catch, not just the kind you looked for</a:t>
+              <a:t>Split by coarse household-size strata (1 / 2-3 / 4+)</a:t>
             </a:r>
           </a:p>
         </p:txBody>
@@ -9726,7 +9772,7 @@
             </a:pPr>
             <a:r>
               <a:rPr sz="1200"/>
-              <a:t>- A rule built to find earned-income errors also flags cases carrying other error types - and those reviews succeed too.</a:t>
+              <a:t>- Household-size strata 1 / 2-3 / 4+ beat pooled modeling on recall reach and filtered inventory (~5x); a 5-way split was worse on the same test year.</a:t>
             </a:r>
           </a:p>
         </p:txBody>
@@ -9738,7 +9784,7 @@
           </a:pPr>
           <a:r>
             <a:rPr sz="1200"/>
-            <a:t>- A rule built to find earned-income errors also flags cases carrying other error types - and those reviews succeed too.</a:t>
+            <a:t>- Household-size strata 1 / 2-3 / 4+ beat pooled modeling on recall reach and filtered inventory (~5x); a 5-way split was worse on the same test year.</a:t>
           </a:r>
         </a:p>
       </p:sp>
@@ -9750,7 +9796,7 @@
         </a:pPr>
         <a:r>
           <a:rPr sz="1200"/>
-          <a:t>- A rule built to find earned-income errors also flags cases carrying other error types - and those reviews succeed too.</a:t>
+          <a:t>- Household-size strata 1 / 2-3 / 4+ beat pooled modeling on recall reach and filtered inventory (~5x); a 5-way split was worse on the same test year.</a:t>
         </a:r>
       </a:p>
       <p:sp>
@@ -9777,7 +9823,7 @@
           <a:p>
             <a:r>
               <a:rPr sz="1000" i="1"/>
-              <a:t>Lessons from the SNAP QC error-mining project - July 2026</a:t>
+              <a:t>SNAP QC modeling lessons - July 2026</a:t>
             </a:r>
           </a:p>
         </p:txBody>
@@ -9798,8 +9844,8 @@
         </p:blipFill>
         <p:spPr>
           <a:xfrm>
-            <a:off x="2450592" y="2496312"/>
-            <a:ext cx="4242815" cy="2121407"/>
+            <a:off x="2836302" y="2496312"/>
+            <a:ext cx="3471394" cy="2121407"/>
           </a:xfrm>
           <a:prstGeom prst="rect">
             <a:avLst/>
@@ -9848,7 +9894,7 @@
           <a:p>
             <a:r>
               <a:rPr sz="2200" b="1"/>
-              <a:t>Look for the unmodeled majority</a:t>
+              <a:t>At state scale, confidence bounds alone were not enough</a:t>
             </a:r>
           </a:p>
         </p:txBody>
@@ -9882,7 +9928,7 @@
             </a:pPr>
             <a:r>
               <a:rPr sz="1200"/>
-              <a:t>- Errors in deductions, shelter costs, and household composition ('other' errors) are the LARGEST category - 2,007 of 4,460 above-threshold errors in 2023 - and years of prior work never modeled them because they seemed heterogeneous.</a:t>
+              <a:t>- Mining directly on one state's data (~2,000-3,000 cases/year), rules passing the same 99% lower-bound filter with small support had median HOLDOUT precision of zero at support &gt;= 5.</a:t>
             </a:r>
           </a:p>
         </p:txBody>
@@ -9894,7 +9940,7 @@
           </a:pPr>
           <a:r>
             <a:rPr sz="1200"/>
-            <a:t>- Errors in deductions, shelter costs, and household composition ('other' errors) are the LARGEST category - 2,007 of 4,460 above-threshold errors in 2023 - and years of prior work never modeled them because they seemed heterogeneous.</a:t>
+            <a:t>- Mining directly on one state's data (~2,000-3,000 cases/year), rules passing the same 99% lower-bound filter with small support had median HOLDOUT precision of zero at support &gt;= 5.</a:t>
           </a:r>
         </a:p>
       </p:sp>
@@ -9906,7 +9952,7 @@
         </a:pPr>
         <a:r>
           <a:rPr sz="1200"/>
-          <a:t>- Errors in deductions, shelter costs, and household composition ('other' errors) are the LARGEST category - 2,007 of 4,460 above-threshold errors in 2023 - and years of prior work never modeled them because they seemed heterogeneous.</a:t>
+          <a:t>- Mining directly on one state's data (~2,000-3,000 cases/year), rules passing the same 99% lower-bound filter with small support had median HOLDOUT precision of zero at support &gt;= 5.</a:t>
         </a:r>
       </a:p>
       <p:sp>
@@ -9933,35 +9979,11 @@
           <a:p>
             <a:r>
               <a:rPr sz="1000" i="1"/>
-              <a:t>Lessons from the SNAP QC error-mining project - July 2026</a:t>
+              <a:t>SNAP QC modeling lessons - July 2026</a:t>
             </a:r>
           </a:p>
         </p:txBody>
       </p:sp>
-      <p:pic>
-        <p:nvPicPr>
-          <p:cNvPr id="5" name="Picture 4" descr="image.png"/>
-          <p:cNvPicPr>
-            <a:picLocks noChangeAspect="1"/>
-          </p:cNvPicPr>
-          <p:nvPr/>
-        </p:nvPicPr>
-        <p:blipFill>
-          <a:blip r:embed="rId2"/>
-          <a:stretch>
-            <a:fillRect/>
-          </a:stretch>
-        </p:blipFill>
-        <p:spPr>
-          <a:xfrm>
-            <a:off x="2450592" y="2496312"/>
-            <a:ext cx="4242815" cy="2121407"/>
-          </a:xfrm>
-          <a:prstGeom prst="rect">
-            <a:avLst/>
-          </a:prstGeom>
-        </p:spPr>
-      </p:pic>
     </p:spTree>
   </p:cSld>
   <p:clrMapOvr>
@@ -10004,7 +10026,7 @@
           <a:p>
             <a:r>
               <a:rPr sz="2200" b="1"/>
-              <a:t>Split by structure - but split coarsely</a:t>
+              <a:t>For thin states, same-era neighbor data beat more own-state data</a:t>
             </a:r>
           </a:p>
         </p:txBody>
@@ -10038,7 +10060,7 @@
             </a:pPr>
             <a:r>
               <a:rPr sz="1200"/>
-              <a:t>- Household size changes which variables mean what (income per member, deduction scales), so we model size groups 1 / 2-3 / 4+ separately. Coarse splits kept enough data per group; a 5-way split performed worse.</a:t>
+              <a:t>- Louisiana's own 2022-24 mining collapsed on holdout. Adding its 2017-19 data made it WORSE (median holdout precision fell to zero).</a:t>
             </a:r>
           </a:p>
         </p:txBody>
@@ -10050,7 +10072,7 @@
           </a:pPr>
           <a:r>
             <a:rPr sz="1200"/>
-            <a:t>- Household size changes which variables mean what (income per member, deduction scales), so we model size groups 1 / 2-3 / 4+ separately. Coarse splits kept enough data per group; a 5-way split performed worse.</a:t>
+            <a:t>- Louisiana's own 2022-24 mining collapsed on holdout. Adding its 2017-19 data made it WORSE (median holdout precision fell to zero).</a:t>
           </a:r>
         </a:p>
       </p:sp>
@@ -10062,7 +10084,7 @@
         </a:pPr>
         <a:r>
           <a:rPr sz="1200"/>
-          <a:t>- Household size changes which variables mean what (income per member, deduction scales), so we model size groups 1 / 2-3 / 4+ separately. Coarse splits kept enough data per group; a 5-way split performed worse.</a:t>
+          <a:t>- Louisiana's own 2022-24 mining collapsed on holdout. Adding its 2017-19 data made it WORSE (median holdout precision fell to zero).</a:t>
         </a:r>
       </a:p>
       <p:sp>
@@ -10089,35 +10111,11 @@
           <a:p>
             <a:r>
               <a:rPr sz="1000" i="1"/>
-              <a:t>Lessons from the SNAP QC error-mining project - July 2026</a:t>
+              <a:t>SNAP QC modeling lessons - July 2026</a:t>
             </a:r>
           </a:p>
         </p:txBody>
       </p:sp>
-      <p:pic>
-        <p:nvPicPr>
-          <p:cNvPr id="5" name="Picture 4" descr="image.png"/>
-          <p:cNvPicPr>
-            <a:picLocks noChangeAspect="1"/>
-          </p:cNvPicPr>
-          <p:nvPr/>
-        </p:nvPicPr>
-        <p:blipFill>
-          <a:blip r:embed="rId2"/>
-          <a:stretch>
-            <a:fillRect/>
-          </a:stretch>
-        </p:blipFill>
-        <p:spPr>
-          <a:xfrm>
-            <a:off x="3284524" y="3008376"/>
-            <a:ext cx="2574950" cy="1609343"/>
-          </a:xfrm>
-          <a:prstGeom prst="rect">
-            <a:avLst/>
-          </a:prstGeom>
-        </p:spPr>
-      </p:pic>
     </p:spTree>
   </p:cSld>
   <p:clrMapOvr>
@@ -10160,7 +10158,7 @@
           <a:p>
             <a:r>
               <a:rPr sz="2200" b="1"/>
-              <a:t>Small samples need hard support floors, not just confidence bounds</a:t>
+              <a:t>Current work: choosing donor states by measured similarity</a:t>
             </a:r>
           </a:p>
         </p:txBody>
@@ -10194,7 +10192,7 @@
             </a:pPr>
             <a:r>
               <a:rPr sz="1200"/>
-              <a:t>- At national scale (100k+ cases), a stringent lower-bound filter alone controls selection noise. At single-state scale it did NOT: rules selected with the bound but tiny support had median holdout precision of ZERO.</a:t>
+              <a:t>- We compute state similarity from the QC microdata itself, two ways: which risk patterns fire in a state's caseload (weighting rarely-firing patterns more heavily), and de facto policy-option profiles (categorical eligibility, reporting system, certification periods, deduction structures - all readable off the microdata, per era).</a:t>
             </a:r>
           </a:p>
         </p:txBody>
@@ -10206,7 +10204,7 @@
           </a:pPr>
           <a:r>
             <a:rPr sz="1200"/>
-            <a:t>- At national scale (100k+ cases), a stringent lower-bound filter alone controls selection noise. At single-state scale it did NOT: rules selected with the bound but tiny support had median holdout precision of ZERO.</a:t>
+            <a:t>- We compute state similarity from the QC microdata itself, two ways: which risk patterns fire in a state's caseload (weighting rarely-firing patterns more heavily), and de facto policy-option profiles (categorical eligibility, reporting system, certification periods, deduction structures - all readable off the microdata, per era).</a:t>
           </a:r>
         </a:p>
       </p:sp>
@@ -10218,7 +10216,7 @@
         </a:pPr>
         <a:r>
           <a:rPr sz="1200"/>
-          <a:t>- At national scale (100k+ cases), a stringent lower-bound filter alone controls selection noise. At single-state scale it did NOT: rules selected with the bound but tiny support had median holdout precision of ZERO.</a:t>
+          <a:t>- We compute state similarity from the QC microdata itself, two ways: which risk patterns fire in a state's caseload (weighting rarely-firing patterns more heavily), and de facto policy-option profiles (categorical eligibility, reporting system, certification periods, deduction structures - all readable off the microdata, per era).</a:t>
         </a:r>
       </a:p>
       <p:sp>
@@ -10245,7 +10243,7 @@
           <a:p>
             <a:r>
               <a:rPr sz="1000" i="1"/>
-              <a:t>Lessons from the SNAP QC error-mining project - July 2026</a:t>
+              <a:t>SNAP QC modeling lessons - July 2026</a:t>
             </a:r>
           </a:p>
         </p:txBody>
@@ -10292,7 +10290,7 @@
           <a:p>
             <a:r>
               <a:rPr sz="2200" b="1"/>
-              <a:t>Match eras: recent similar data beats more mixed-era data</a:t>
+              <a:t>Takeaways</a:t>
             </a:r>
           </a:p>
         </p:txBody>
@@ -10326,7 +10324,7 @@
             </a:pPr>
             <a:r>
               <a:rPr sz="1200"/>
-              <a:t>- For a state with weak local signal (Louisiana), pooling its own data across 2017-19 + 2022-24 made things WORSE (median holdout precision fell to zero) - error-generating processes drift with policy changes.</a:t>
+              <a:t>- Reconcile your build against the raw files before tuning anything: our two data-build fixes moved results more than any hyperparameter.</a:t>
             </a:r>
           </a:p>
         </p:txBody>
@@ -10338,7 +10336,7 @@
           </a:pPr>
           <a:r>
             <a:rPr sz="1200"/>
-            <a:t>- For a state with weak local signal (Louisiana), pooling its own data across 2017-19 + 2022-24 made things WORSE (median holdout precision fell to zero) - error-generating processes drift with policy changes.</a:t>
+            <a:t>- Reconcile your build against the raw files before tuning anything: our two data-build fixes moved results more than any hyperparameter.</a:t>
           </a:r>
         </a:p>
       </p:sp>
@@ -10350,7 +10348,7 @@
         </a:pPr>
         <a:r>
           <a:rPr sz="1200"/>
-          <a:t>- For a state with weak local signal (Louisiana), pooling its own data across 2017-19 + 2022-24 made things WORSE (median holdout precision fell to zero) - error-generating processes drift with policy changes.</a:t>
+          <a:t>- Reconcile your build against the raw files before tuning anything: our two data-build fixes moved results more than any hyperparameter.</a:t>
         </a:r>
       </a:p>
       <p:sp>
@@ -10377,271 +10375,7 @@
           <a:p>
             <a:r>
               <a:rPr sz="1000" i="1"/>
-              <a:t>Lessons from the SNAP QC error-mining project - July 2026</a:t>
-            </a:r>
-          </a:p>
-        </p:txBody>
-      </p:sp>
-    </p:spTree>
-  </p:cSld>
-  <p:clrMapOvr>
-    <a:masterClrMapping/>
-  </p:clrMapOvr>
-</p:sld>
-</file>
-
-<file path=ppt/slides/slide37.xml><?xml version="1.0" encoding="utf-8"?>
-<p:sld xmlns:a="http://schemas.openxmlformats.org/drawingml/2006/main" xmlns:p="http://schemas.openxmlformats.org/presentationml/2006/main" xmlns:r="http://schemas.openxmlformats.org/officeDocument/2006/relationships">
-  <p:cSld>
-    <p:spTree>
-      <p:nvGrpSpPr>
-        <p:cNvPr id="1" name=""/>
-        <p:cNvGrpSpPr/>
-        <p:nvPr/>
-      </p:nvGrpSpPr>
-      <p:grpSpPr/>
-      <p:sp>
-        <p:nvSpPr>
-          <p:cNvPr id="2" name="TextBox 1"/>
-          <p:cNvSpPr txBox="1"/>
-          <p:nvPr/>
-        </p:nvSpPr>
-        <p:spPr>
-          <a:xfrm>
-            <a:off x="400000" y="200000"/>
-            <a:ext cx="8344000" cy="600000"/>
-          </a:xfrm>
-          <a:prstGeom prst="rect">
-            <a:avLst/>
-          </a:prstGeom>
-          <a:noFill/>
-        </p:spPr>
-        <p:txBody>
-          <a:bodyPr wrap="none">
-            <a:spAutoFit/>
-          </a:bodyPr>
-          <a:lstStyle/>
-          <a:p>
-            <a:r>
-              <a:rPr sz="2200" b="1"/>
-              <a:t>The microdata already documents each state's policy choices</a:t>
-            </a:r>
-          </a:p>
-        </p:txBody>
-      </p:sp>
-      <p:sp>
-        <p:nvSpPr>
-          <p:cNvPr id="4" name="TextBox 3"/>
-          <p:cNvSpPr txBox="1"/>
-          <p:nvPr/>
-        </p:nvSpPr>
-        <p:spPr>
-          <a:xfrm>
-            <a:off x="400000" y="760000"/>
-            <a:ext cx="8344000" cy="430000"/>
-          </a:xfrm>
-          <a:prstGeom prst="rect">
-            <a:avLst/>
-          </a:prstGeom>
-          <a:noFill/>
-        </p:spPr>
-        <p:txBody>
-          <a:bodyPr wrap="square">
-            <a:spAutoFit/>
-          </a:bodyPr>
-          <a:lstStyle/>
-          <a:p>
-            <a:pPr>
-              <a:spcAft>
-                <a:spcPts val="400"/>
-              </a:spcAft>
-            </a:pPr>
-            <a:r>
-              <a:rPr sz="1200"/>
-              <a:t>- Key policy options - broad-based categorical eligibility, reporting systems, certification periods, standard medical deduction, standard utility allowances, SSI CAP - are all readable off the QC microdata itself, per state and era.</a:t>
-            </a:r>
-          </a:p>
-        </p:txBody>
-        <a:p>
-          <a:pPr>
-            <a:spcAft>
-              <a:spcPts val="400"/>
-            </a:spcAft>
-          </a:pPr>
-          <a:r>
-            <a:rPr sz="1200"/>
-            <a:t>- Key policy options - broad-based categorical eligibility, reporting systems, certification periods, standard medical deduction, standard utility allowances, SSI CAP - are all readable off the QC microdata itself, per state and era.</a:t>
-          </a:r>
-        </a:p>
-      </p:sp>
-      <a:p>
-        <a:pPr>
-          <a:spcAft>
-            <a:spcPts val="400"/>
-          </a:spcAft>
-        </a:pPr>
-        <a:r>
-          <a:rPr sz="1200"/>
-          <a:t>- Key policy options - broad-based categorical eligibility, reporting systems, certification periods, standard medical deduction, standard utility allowances, SSI CAP - are all readable off the QC microdata itself, per state and era.</a:t>
-        </a:r>
-      </a:p>
-      <p:sp>
-        <p:nvSpPr>
-          <p:cNvPr id="3" name="TextBox 2"/>
-          <p:cNvSpPr txBox="1"/>
-          <p:nvPr/>
-        </p:nvSpPr>
-        <p:spPr>
-          <a:xfrm>
-            <a:off x="400000" y="4723500"/>
-            <a:ext cx="3200000" cy="320000"/>
-          </a:xfrm>
-          <a:prstGeom prst="rect">
-            <a:avLst/>
-          </a:prstGeom>
-          <a:noFill/>
-        </p:spPr>
-        <p:txBody>
-          <a:bodyPr wrap="none">
-            <a:spAutoFit/>
-          </a:bodyPr>
-          <a:lstStyle/>
-          <a:p>
-            <a:r>
-              <a:rPr sz="1000" i="1"/>
-              <a:t>Lessons from the SNAP QC error-mining project - July 2026</a:t>
-            </a:r>
-          </a:p>
-        </p:txBody>
-      </p:sp>
-    </p:spTree>
-  </p:cSld>
-  <p:clrMapOvr>
-    <a:masterClrMapping/>
-  </p:clrMapOvr>
-</p:sld>
-</file>
-
-<file path=ppt/slides/slide38.xml><?xml version="1.0" encoding="utf-8"?>
-<p:sld xmlns:a="http://schemas.openxmlformats.org/drawingml/2006/main" xmlns:p="http://schemas.openxmlformats.org/presentationml/2006/main" xmlns:r="http://schemas.openxmlformats.org/officeDocument/2006/relationships">
-  <p:cSld>
-    <p:spTree>
-      <p:nvGrpSpPr>
-        <p:cNvPr id="1" name=""/>
-        <p:cNvGrpSpPr/>
-        <p:nvPr/>
-      </p:nvGrpSpPr>
-      <p:grpSpPr/>
-      <p:sp>
-        <p:nvSpPr>
-          <p:cNvPr id="2" name="TextBox 1"/>
-          <p:cNvSpPr txBox="1"/>
-          <p:nvPr/>
-        </p:nvSpPr>
-        <p:spPr>
-          <a:xfrm>
-            <a:off x="400000" y="200000"/>
-            <a:ext cx="8344000" cy="600000"/>
-          </a:xfrm>
-          <a:prstGeom prst="rect">
-            <a:avLst/>
-          </a:prstGeom>
-          <a:noFill/>
-        </p:spPr>
-        <p:txBody>
-          <a:bodyPr wrap="none">
-            <a:spAutoFit/>
-          </a:bodyPr>
-          <a:lstStyle/>
-          <a:p>
-            <a:r>
-              <a:rPr sz="2200" b="1"/>
-              <a:t>Takeaways</a:t>
-            </a:r>
-          </a:p>
-        </p:txBody>
-      </p:sp>
-      <p:sp>
-        <p:nvSpPr>
-          <p:cNvPr id="4" name="TextBox 3"/>
-          <p:cNvSpPr txBox="1"/>
-          <p:nvPr/>
-        </p:nvSpPr>
-        <p:spPr>
-          <a:xfrm>
-            <a:off x="400000" y="760000"/>
-            <a:ext cx="8344000" cy="430000"/>
-          </a:xfrm>
-          <a:prstGeom prst="rect">
-            <a:avLst/>
-          </a:prstGeom>
-          <a:noFill/>
-        </p:spPr>
-        <p:txBody>
-          <a:bodyPr wrap="square">
-            <a:spAutoFit/>
-          </a:bodyPr>
-          <a:lstStyle/>
-          <a:p>
-            <a:pPr>
-              <a:spcAft>
-                <a:spcPts val="400"/>
-              </a:spcAft>
-            </a:pPr>
-            <a:r>
-              <a:rPr sz="1200"/>
-              <a:t>- Data first: measure what your data cannot see, read missingness semantics, keep hard cases with flags, and make scripts - not hands - produce datasets.</a:t>
-            </a:r>
-          </a:p>
-        </p:txBody>
-        <a:p>
-          <a:pPr>
-            <a:spcAft>
-              <a:spcPts val="400"/>
-            </a:spcAft>
-          </a:pPr>
-          <a:r>
-            <a:rPr sz="1200"/>
-            <a:t>- Data first: measure what your data cannot see, read missingness semantics, keep hard cases with flags, and make scripts - not hands - produce datasets.</a:t>
-          </a:r>
-        </a:p>
-      </p:sp>
-      <a:p>
-        <a:pPr>
-          <a:spcAft>
-            <a:spcPts val="400"/>
-          </a:spcAft>
-        </a:pPr>
-        <a:r>
-          <a:rPr sz="1200"/>
-          <a:t>- Data first: measure what your data cannot see, read missingness semantics, keep hard cases with flags, and make scripts - not hands - produce datasets.</a:t>
-        </a:r>
-      </a:p>
-      <p:sp>
-        <p:nvSpPr>
-          <p:cNvPr id="3" name="TextBox 2"/>
-          <p:cNvSpPr txBox="1"/>
-          <p:nvPr/>
-        </p:nvSpPr>
-        <p:spPr>
-          <a:xfrm>
-            <a:off x="400000" y="4723500"/>
-            <a:ext cx="3200000" cy="320000"/>
-          </a:xfrm>
-          <a:prstGeom prst="rect">
-            <a:avLst/>
-          </a:prstGeom>
-          <a:noFill/>
-        </p:spPr>
-        <p:txBody>
-          <a:bodyPr wrap="none">
-            <a:spAutoFit/>
-          </a:bodyPr>
-          <a:lstStyle/>
-          <a:p>
-            <a:r>
-              <a:rPr sz="1000" i="1"/>
-              <a:t>Lessons from the SNAP QC error-mining project - July 2026</a:t>
+              <a:t>SNAP QC modeling lessons - July 2026</a:t>
             </a:r>
           </a:p>
         </p:txBody>
@@ -10655,7 +10389,7 @@
       </a:pPr>
       <a:r>
         <a:rPr sz="1200"/>
-        <a:t>- Data first: measure what your data cannot see, read missingness semantics, keep hard cases with flags, and make scripts - not hands - produce datasets.</a:t>
+        <a:t>- Reconcile your build against the raw files before tuning anything: our two data-build fixes moved results more than any hyperparameter.</a:t>
       </a:r>
     </a:p>
   </p:cSld>

</xml_diff>

<commit_message>
Lessons deck: add rule-overlap evidence to data-build slide; fix bullet bug
Slide 3 now shows the rebuild preserved rule content (93% survive: 63%
shifted cutpoints, 29% coverage-overlap, 1% exact; 7% dropped; new rules
not concentrated on restored cases, 34% vs 32%). Also fixes a builder bug
that silently dropped every bullet after the first on all slides
(paragraphs were inserted as siblings of txBody, not of the paragraph).

Co-Authored-By: Claude Fable 5 <noreply@anthropic.com>
</commit_message>
<xml_diff>
--- a/lessons_getting_more_signal_from_snap_qc_data.pptx
+++ b/lessons_getting_more_signal_from_snap_qc_data.pptx
@@ -7760,30 +7760,30 @@
               <a:t>What we learned from building, tuning, and stress-testing an error-mining pipeline on the public QC files.</a:t>
             </a:r>
           </a:p>
+          <a:p>
+            <a:pPr>
+              <a:spcAft>
+                <a:spcPts val="400"/>
+              </a:spcAft>
+            </a:pPr>
+            <a:r>
+              <a:rPr sz="1200"/>
+              <a:t>Every claim below is backed by a measurement from our own runs - configurations tried head-to-head on held-out years.</a:t>
+            </a:r>
+          </a:p>
+          <a:p>
+            <a:pPr>
+              <a:spcAft>
+                <a:spcPts val="400"/>
+              </a:spcAft>
+            </a:pPr>
+            <a:r>
+              <a:rPr sz="1200"/>
+              <a:t>Code and full evidence: https://github.com/giannella/snap_qc (modeling_findings.md)</a:t>
+            </a:r>
+          </a:p>
         </p:txBody>
-        <a:p>
-          <a:pPr>
-            <a:spcAft>
-              <a:spcPts val="400"/>
-            </a:spcAft>
-          </a:pPr>
-          <a:r>
-            <a:rPr sz="1200"/>
-            <a:t>What we learned from building, tuning, and stress-testing an error-mining pipeline on the public QC files.</a:t>
-          </a:r>
-        </a:p>
       </p:sp>
-      <a:p>
-        <a:pPr>
-          <a:spcAft>
-            <a:spcPts val="400"/>
-          </a:spcAft>
-        </a:pPr>
-        <a:r>
-          <a:rPr sz="1200"/>
-          <a:t>What we learned from building, tuning, and stress-testing an error-mining pipeline on the public QC files.</a:t>
-        </a:r>
-      </a:p>
     </p:spTree>
   </p:cSld>
   <p:clrMapOvr>
@@ -7863,30 +7863,30 @@
               <a:t>- Task: mine interpretable rules that flag high-error-risk cases; judge every configuration on a year of data it never saw (train 2022+2024, test 2023).</a:t>
             </a:r>
           </a:p>
+          <a:p>
+            <a:pPr>
+              <a:spcAft>
+                <a:spcPts val="400"/>
+              </a:spcAft>
+            </a:pPr>
+            <a:r>
+              <a:rPr sz="1200"/>
+              <a:t>- Compared head-to-head: tree engines and their pairings, ensemble sizes, learning rates, subsampling, tree depth, split randomness, stratification schemes, selection statistics, filter stringencies, and state-level deployment strategies.</a:t>
+            </a:r>
+          </a:p>
+          <a:p>
+            <a:pPr>
+              <a:spcAft>
+                <a:spcPts val="400"/>
+              </a:spcAft>
+            </a:pPr>
+            <a:r>
+              <a:rPr sz="1200"/>
+              <a:t>- The lessons below are the settings and practices that moved held-out performance - and the ones that didn't.</a:t>
+            </a:r>
+          </a:p>
         </p:txBody>
-        <a:p>
-          <a:pPr>
-            <a:spcAft>
-              <a:spcPts val="400"/>
-            </a:spcAft>
-          </a:pPr>
-          <a:r>
-            <a:rPr sz="1200"/>
-            <a:t>- Task: mine interpretable rules that flag high-error-risk cases; judge every configuration on a year of data it never saw (train 2022+2024, test 2023).</a:t>
-          </a:r>
-        </a:p>
       </p:sp>
-      <a:p>
-        <a:pPr>
-          <a:spcAft>
-            <a:spcPts val="400"/>
-          </a:spcAft>
-        </a:pPr>
-        <a:r>
-          <a:rPr sz="1200"/>
-          <a:t>- Task: mine interpretable rules that flag high-error-risk cases; judge every configuration on a year of data it never saw (train 2022+2024, test 2023).</a:t>
-        </a:r>
-      </a:p>
       <p:sp>
         <p:nvSpPr>
           <p:cNvPr id="3" name="TextBox 2"/>
@@ -7995,30 +7995,52 @@
               <a:t>- Cases whose review found a second error element did not fit our single-error reconstruction and were being dropped: 31% of all above-threshold error cases. Keeping them (with a flag) raised qualifying rules from 3,741 to 11,018 at the same filter - more error data tightens every statistical bound.</a:t>
             </a:r>
           </a:p>
+          <a:p>
+            <a:pPr>
+              <a:spcAft>
+                <a:spcPts val="400"/>
+              </a:spcAft>
+            </a:pPr>
+            <a:r>
+              <a:rPr sz="1200"/>
+              <a:t>- The fix did not rewrite the rules' content: 93% of the previous rule set survived the rebuild - 63% as the same variables and directions with shifted cutpoints, 29% matched by a new rule flagging a highly overlapping case set (Jaccard &gt;= 0.5 on the test year), 1% exact; only 7% dropped with no counterpart.</a:t>
+            </a:r>
+          </a:p>
+          <a:p>
+            <a:pPr>
+              <a:spcAft>
+                <a:spcPts val="400"/>
+              </a:spcAft>
+            </a:pPr>
+            <a:r>
+              <a:rPr sz="1200"/>
+              <a:t>- Nor did the restored cases add a new pattern type: brand-new rules' catches were 34% restored-case vs a 32% base - the gain was statistical power, not different signal.</a:t>
+            </a:r>
+          </a:p>
+          <a:p>
+            <a:pPr>
+              <a:spcAft>
+                <a:spcPts val="400"/>
+              </a:spcAft>
+            </a:pPr>
+            <a:r>
+              <a:rPr sz="1200"/>
+              <a:t>- Rows with blank optional-deduction fields were also being dropped: ~16% of Washington's caseload. Zero-filling with an imputed-flag kept them.</a:t>
+            </a:r>
+          </a:p>
+          <a:p>
+            <a:pPr>
+              <a:spcAft>
+                <a:spcPts val="400"/>
+              </a:spcAft>
+            </a:pPr>
+            <a:r>
+              <a:rPr sz="1200"/>
+              <a:t>- Both defects were invisible in model metrics and found only by reconciling row and error counts against the raw files, state by state. We now diff mined-rule sets across data builds (exact / shifted / overlapping / dropped / new) to audit any data change.</a:t>
+            </a:r>
+          </a:p>
         </p:txBody>
-        <a:p>
-          <a:pPr>
-            <a:spcAft>
-              <a:spcPts val="400"/>
-            </a:spcAft>
-          </a:pPr>
-          <a:r>
-            <a:rPr sz="1200"/>
-            <a:t>- Cases whose review found a second error element did not fit our single-error reconstruction and were being dropped: 31% of all above-threshold error cases. Keeping them (with a flag) raised qualifying rules from 3,741 to 11,018 at the same filter - more error data tightens every statistical bound.</a:t>
-          </a:r>
-        </a:p>
       </p:sp>
-      <a:p>
-        <a:pPr>
-          <a:spcAft>
-            <a:spcPts val="400"/>
-          </a:spcAft>
-        </a:pPr>
-        <a:r>
-          <a:rPr sz="1200"/>
-          <a:t>- Cases whose review found a second error element did not fit our single-error reconstruction and were being dropped: 31% of all above-threshold error cases. Keeping them (with a flag) raised qualifying rules from 3,741 to 11,018 at the same filter - more error data tightens every statistical bound.</a:t>
-        </a:r>
-      </a:p>
       <p:sp>
         <p:nvSpPr>
           <p:cNvPr id="3" name="TextBox 2"/>
@@ -8127,30 +8149,30 @@
               <a:t>- We reconciled the public files against the QC technical documentation's exclusion counts, per state and year (2022-24).</a:t>
             </a:r>
           </a:p>
+          <a:p>
+            <a:pPr>
+              <a:spcAft>
+                <a:spcPts val="400"/>
+              </a:spcAft>
+            </a:pPr>
+            <a:r>
+              <a:rPr sz="1200"/>
+              <a:t>- The public files' share of each state's error cases ranges from 43% to 81% - the excluded cases are the ineligible determinations.</a:t>
+            </a:r>
+          </a:p>
+          <a:p>
+            <a:pPr>
+              <a:spcAft>
+                <a:spcPts val="400"/>
+              </a:spcAft>
+            </a:pPr>
+            <a:r>
+              <a:rPr sz="1200"/>
+              <a:t>- This bounds what any public-data model can deliver per state; we quote it alongside every state result.</a:t>
+            </a:r>
+          </a:p>
         </p:txBody>
-        <a:p>
-          <a:pPr>
-            <a:spcAft>
-              <a:spcPts val="400"/>
-            </a:spcAft>
-          </a:pPr>
-          <a:r>
-            <a:rPr sz="1200"/>
-            <a:t>- We reconciled the public files against the QC technical documentation's exclusion counts, per state and year (2022-24).</a:t>
-          </a:r>
-        </a:p>
       </p:sp>
-      <a:p>
-        <a:pPr>
-          <a:spcAft>
-            <a:spcPts val="400"/>
-          </a:spcAft>
-        </a:pPr>
-        <a:r>
-          <a:rPr sz="1200"/>
-          <a:t>- We reconciled the public files against the QC technical documentation's exclusion counts, per state and year (2022-24).</a:t>
-        </a:r>
-      </a:p>
       <p:sp>
         <p:nvSpPr>
           <p:cNvPr id="3" name="TextBox 2"/>
@@ -8453,30 +8475,30 @@
               <a:t>- Our 'train precision &gt;= 0.20' shortlist delivered ~0.10 on the held-out year. Before any selection, train precision was nearly unbiased for holdout (median gap -0.003, r = 0.83); rules selected on the HOLDOUT &gt;= 0.20 showed median train precision 0.116.</a:t>
             </a:r>
           </a:p>
+          <a:p>
+            <a:pPr>
+              <a:spcAft>
+                <a:spcPts val="400"/>
+              </a:spcAft>
+            </a:pPr>
+            <a:r>
+              <a:rPr sz="1200"/>
+              <a:t>- So the decay is selection noise (regression to the mean), not overfitting or year drift - the same rules held ~3.9x lift on 2018-19 vs ~3.5x on 2023.</a:t>
+            </a:r>
+          </a:p>
+          <a:p>
+            <a:pPr>
+              <a:spcAft>
+                <a:spcPts val="400"/>
+              </a:spcAft>
+            </a:pPr>
+            <a:r>
+              <a:rPr sz="1200"/>
+              <a:t>- Any 'generate many candidates, keep the best-measured' step has this problem, whatever the model class.</a:t>
+            </a:r>
+          </a:p>
         </p:txBody>
-        <a:p>
-          <a:pPr>
-            <a:spcAft>
-              <a:spcPts val="400"/>
-            </a:spcAft>
-          </a:pPr>
-          <a:r>
-            <a:rPr sz="1200"/>
-            <a:t>- Our 'train precision &gt;= 0.20' shortlist delivered ~0.10 on the held-out year. Before any selection, train precision was nearly unbiased for holdout (median gap -0.003, r = 0.83); rules selected on the HOLDOUT &gt;= 0.20 showed median train precision 0.116.</a:t>
-          </a:r>
-        </a:p>
       </p:sp>
-      <a:p>
-        <a:pPr>
-          <a:spcAft>
-            <a:spcPts val="400"/>
-          </a:spcAft>
-        </a:pPr>
-        <a:r>
-          <a:rPr sz="1200"/>
-          <a:t>- Our 'train precision &gt;= 0.20' shortlist delivered ~0.10 on the held-out year. Before any selection, train precision was nearly unbiased for holdout (median gap -0.003, r = 0.83); rules selected on the HOLDOUT &gt;= 0.20 showed median train precision 0.116.</a:t>
-        </a:r>
-      </a:p>
       <p:sp>
         <p:nvSpPr>
           <p:cNvPr id="3" name="TextBox 2"/>
@@ -8609,30 +8631,30 @@
               <a:t>- Keep a rule only if the one-sided 99% Wilson lower bound of its training precision clears the floor. At matched delivered precision (~0.20), lower-bound selection caught 12.8% of errors vs 8.2% for raw-precision selection.</a:t>
             </a:r>
           </a:p>
+          <a:p>
+            <a:pPr>
+              <a:spcAft>
+                <a:spcPts val="400"/>
+              </a:spcAft>
+            </a:pPr>
+            <a:r>
+              <a:rPr sz="1200"/>
+              <a:t>- Same rule pool, measured three ways: raw floors overpromise even after a lower-bound gate (floor 0.50 delivers 0.34); lower-bound floors deliver at or above their number (floor 0.30 delivers 0.38, floor 0.40 delivers 0.51).</a:t>
+            </a:r>
+          </a:p>
+          <a:p>
+            <a:pPr>
+              <a:spcAft>
+                <a:spcPts val="400"/>
+              </a:spcAft>
+            </a:pPr>
+            <a:r>
+              <a:rPr sz="1200"/>
+              <a:t>- The lower bound is the only selection statistic we tested whose value survives contact with a new year.</a:t>
+            </a:r>
+          </a:p>
         </p:txBody>
-        <a:p>
-          <a:pPr>
-            <a:spcAft>
-              <a:spcPts val="400"/>
-            </a:spcAft>
-          </a:pPr>
-          <a:r>
-            <a:rPr sz="1200"/>
-            <a:t>- Keep a rule only if the one-sided 99% Wilson lower bound of its training precision clears the floor. At matched delivered precision (~0.20), lower-bound selection caught 12.8% of errors vs 8.2% for raw-precision selection.</a:t>
-          </a:r>
-        </a:p>
       </p:sp>
-      <a:p>
-        <a:pPr>
-          <a:spcAft>
-            <a:spcPts val="400"/>
-          </a:spcAft>
-        </a:pPr>
-        <a:r>
-          <a:rPr sz="1200"/>
-          <a:t>- Keep a rule only if the one-sided 99% Wilson lower bound of its training precision clears the floor. At matched delivered precision (~0.20), lower-bound selection caught 12.8% of errors vs 8.2% for raw-precision selection.</a:t>
-        </a:r>
-      </a:p>
       <p:sp>
         <p:nvSpPr>
           <p:cNvPr id="3" name="TextBox 2"/>
@@ -8765,30 +8787,30 @@
               <a:t>- 1000-round/1000-tree ensembles traced the SAME precision-recall frontier as small ones - but produced several times more distinct rules clearing any given floor (~2.6-5x the filtered inventory).</a:t>
             </a:r>
           </a:p>
+          <a:p>
+            <a:pPr>
+              <a:spcAft>
+                <a:spcPts val="400"/>
+              </a:spcAft>
+            </a:pPr>
+            <a:r>
+              <a:rPr sz="1200"/>
+              <a:t>- That inventory is what states use: reviewers veto rules they distrust and need substitutes.</a:t>
+            </a:r>
+          </a:p>
+          <a:p>
+            <a:pPr>
+              <a:spcAft>
+                <a:spcPts val="400"/>
+              </a:spcAft>
+            </a:pPr>
+            <a:r>
+              <a:rPr sz="1200"/>
+              <a:t>- The stringent lower-bound filter is what keeps large pools safe: it removes the extra selection noise that more candidates would otherwise inject.</a:t>
+            </a:r>
+          </a:p>
         </p:txBody>
-        <a:p>
-          <a:pPr>
-            <a:spcAft>
-              <a:spcPts val="400"/>
-            </a:spcAft>
-          </a:pPr>
-          <a:r>
-            <a:rPr sz="1200"/>
-            <a:t>- 1000-round/1000-tree ensembles traced the SAME precision-recall frontier as small ones - but produced several times more distinct rules clearing any given floor (~2.6-5x the filtered inventory).</a:t>
-          </a:r>
-        </a:p>
       </p:sp>
-      <a:p>
-        <a:pPr>
-          <a:spcAft>
-            <a:spcPts val="400"/>
-          </a:spcAft>
-        </a:pPr>
-        <a:r>
-          <a:rPr sz="1200"/>
-          <a:t>- 1000-round/1000-tree ensembles traced the SAME precision-recall frontier as small ones - but produced several times more distinct rules clearing any given floor (~2.6-5x the filtered inventory).</a:t>
-        </a:r>
-      </a:p>
       <p:sp>
         <p:nvSpPr>
           <p:cNvPr id="3" name="TextBox 2"/>
@@ -9463,30 +9485,30 @@
               <a:t>- Engine PAIRING mattered: xgboost + random forest (ranger) beat either engine alone and beat bagged-CART + ranger, everything else held equal.</a:t>
             </a:r>
           </a:p>
+          <a:p>
+            <a:pPr>
+              <a:spcAft>
+                <a:spcPts val="400"/>
+              </a:spcAft>
+            </a:pPr>
+            <a:r>
+              <a:rPr sz="1200"/>
+              <a:t>- Within engines: mtry = 2 beat mtry = 1 across the frontier; subsampling 15-30% of data per tree was a plateau (we use 20%); slow learning (eta 0.02, 1000 rounds) beat fast; depth 4 sufficed.</a:t>
+            </a:r>
+          </a:p>
+          <a:p>
+            <a:pPr>
+              <a:spcAft>
+                <a:spcPts val="400"/>
+              </a:spcAft>
+            </a:pPr>
+            <a:r>
+              <a:rPr sz="1200"/>
+              <a:t>- Most other knobs did not move the frontier - we verified by varying one setting at a time around the final configuration.</a:t>
+            </a:r>
+          </a:p>
         </p:txBody>
-        <a:p>
-          <a:pPr>
-            <a:spcAft>
-              <a:spcPts val="400"/>
-            </a:spcAft>
-          </a:pPr>
-          <a:r>
-            <a:rPr sz="1200"/>
-            <a:t>- Engine PAIRING mattered: xgboost + random forest (ranger) beat either engine alone and beat bagged-CART + ranger, everything else held equal.</a:t>
-          </a:r>
-        </a:p>
       </p:sp>
-      <a:p>
-        <a:pPr>
-          <a:spcAft>
-            <a:spcPts val="400"/>
-          </a:spcAft>
-        </a:pPr>
-        <a:r>
-          <a:rPr sz="1200"/>
-          <a:t>- Engine PAIRING mattered: xgboost + random forest (ranger) beat either engine alone and beat bagged-CART + ranger, everything else held equal.</a:t>
-        </a:r>
-      </a:p>
       <p:sp>
         <p:nvSpPr>
           <p:cNvPr id="3" name="TextBox 2"/>
@@ -9619,30 +9641,30 @@
               <a:t>- Rules mined for one error type also flag cases carrying other types. Scored only against the mined type, our earned-income rules measured 8% precision on the held-out year; scored against any above-threshold error on the same flags, 19%.</a:t>
             </a:r>
           </a:p>
+          <a:p>
+            <a:pPr>
+              <a:spcAft>
+                <a:spcPts val="400"/>
+              </a:spcAft>
+            </a:pPr>
+            <a:r>
+              <a:rPr sz="1200"/>
+              <a:t>- The gap was similar across frames (~2x). Reporting only the narrow metric understates what reviewers would actually find.</a:t>
+            </a:r>
+          </a:p>
+          <a:p>
+            <a:pPr>
+              <a:spcAft>
+                <a:spcPts val="400"/>
+              </a:spcAft>
+            </a:pPr>
+            <a:r>
+              <a:rPr sz="1200"/>
+              <a:t>- We now compute both in every run (dashed vs solid below).</a:t>
+            </a:r>
+          </a:p>
         </p:txBody>
-        <a:p>
-          <a:pPr>
-            <a:spcAft>
-              <a:spcPts val="400"/>
-            </a:spcAft>
-          </a:pPr>
-          <a:r>
-            <a:rPr sz="1200"/>
-            <a:t>- Rules mined for one error type also flag cases carrying other types. Scored only against the mined type, our earned-income rules measured 8% precision on the held-out year; scored against any above-threshold error on the same flags, 19%.</a:t>
-          </a:r>
-        </a:p>
       </p:sp>
-      <a:p>
-        <a:pPr>
-          <a:spcAft>
-            <a:spcPts val="400"/>
-          </a:spcAft>
-        </a:pPr>
-        <a:r>
-          <a:rPr sz="1200"/>
-          <a:t>- Rules mined for one error type also flag cases carrying other types. Scored only against the mined type, our earned-income rules measured 8% precision on the held-out year; scored against any above-threshold error on the same flags, 19%.</a:t>
-        </a:r>
-      </a:p>
       <p:sp>
         <p:nvSpPr>
           <p:cNvPr id="3" name="TextBox 2"/>
@@ -9775,30 +9797,30 @@
               <a:t>- Household-size strata 1 / 2-3 / 4+ beat pooled modeling on recall reach and filtered inventory (~5x); a 5-way split was worse on the same test year.</a:t>
             </a:r>
           </a:p>
+          <a:p>
+            <a:pPr>
+              <a:spcAft>
+                <a:spcPts val="400"/>
+              </a:spcAft>
+            </a:pPr>
+            <a:r>
+              <a:rPr sz="1200"/>
+              <a:t>- Adding an elderly/disabled STRATUM on top bought nothing: an indicator variable achieved the same held-out frontier and the same coverage of those households - we checked coverage parity explicitly.</a:t>
+            </a:r>
+          </a:p>
+          <a:p>
+            <a:pPr>
+              <a:spcAft>
+                <a:spcPts val="400"/>
+              </a:spcAft>
+            </a:pPr>
+            <a:r>
+              <a:rPr sz="1200"/>
+              <a:t>- We test 'new stratum vs new variable' empirically before adding strata; strata cost data and the variable usually suffices.</a:t>
+            </a:r>
+          </a:p>
         </p:txBody>
-        <a:p>
-          <a:pPr>
-            <a:spcAft>
-              <a:spcPts val="400"/>
-            </a:spcAft>
-          </a:pPr>
-          <a:r>
-            <a:rPr sz="1200"/>
-            <a:t>- Household-size strata 1 / 2-3 / 4+ beat pooled modeling on recall reach and filtered inventory (~5x); a 5-way split was worse on the same test year.</a:t>
-          </a:r>
-        </a:p>
       </p:sp>
-      <a:p>
-        <a:pPr>
-          <a:spcAft>
-            <a:spcPts val="400"/>
-          </a:spcAft>
-        </a:pPr>
-        <a:r>
-          <a:rPr sz="1200"/>
-          <a:t>- Household-size strata 1 / 2-3 / 4+ beat pooled modeling on recall reach and filtered inventory (~5x); a 5-way split was worse on the same test year.</a:t>
-        </a:r>
-      </a:p>
       <p:sp>
         <p:nvSpPr>
           <p:cNvPr id="3" name="TextBox 2"/>
@@ -9931,30 +9953,30 @@
               <a:t>- Mining directly on one state's data (~2,000-3,000 cases/year), rules passing the same 99% lower-bound filter with small support had median HOLDOUT precision of zero at support &gt;= 5.</a:t>
             </a:r>
           </a:p>
+          <a:p>
+            <a:pPr>
+              <a:spcAft>
+                <a:spcPts val="400"/>
+              </a:spcAft>
+            </a:pPr>
+            <a:r>
+              <a:rPr sz="1200"/>
+              <a:t>- Requiring each rule to flag &gt;= 30 training cases changed the failure mode from collapse to gentle deflation (~1/3 below training estimates).</a:t>
+            </a:r>
+          </a:p>
+          <a:p>
+            <a:pPr>
+              <a:spcAft>
+                <a:spcPts val="400"/>
+              </a:spcAft>
+            </a:pPr>
+            <a:r>
+              <a:rPr sz="1200"/>
+              <a:t>- National scale hides this: with 100k+ cases the bound rarely admits tiny-support rules in the first place.</a:t>
+            </a:r>
+          </a:p>
         </p:txBody>
-        <a:p>
-          <a:pPr>
-            <a:spcAft>
-              <a:spcPts val="400"/>
-            </a:spcAft>
-          </a:pPr>
-          <a:r>
-            <a:rPr sz="1200"/>
-            <a:t>- Mining directly on one state's data (~2,000-3,000 cases/year), rules passing the same 99% lower-bound filter with small support had median HOLDOUT precision of zero at support &gt;= 5.</a:t>
-          </a:r>
-        </a:p>
       </p:sp>
-      <a:p>
-        <a:pPr>
-          <a:spcAft>
-            <a:spcPts val="400"/>
-          </a:spcAft>
-        </a:pPr>
-        <a:r>
-          <a:rPr sz="1200"/>
-          <a:t>- Mining directly on one state's data (~2,000-3,000 cases/year), rules passing the same 99% lower-bound filter with small support had median HOLDOUT precision of zero at support &gt;= 5.</a:t>
-        </a:r>
-      </a:p>
       <p:sp>
         <p:nvSpPr>
           <p:cNvPr id="3" name="TextBox 2"/>
@@ -10063,30 +10085,30 @@
               <a:t>- Louisiana's own 2022-24 mining collapsed on holdout. Adding its 2017-19 data made it WORSE (median holdout precision fell to zero).</a:t>
             </a:r>
           </a:p>
+          <a:p>
+            <a:pPr>
+              <a:spcAft>
+                <a:spcPts val="400"/>
+              </a:spcAft>
+            </a:pPr>
+            <a:r>
+              <a:rPr sz="1200"/>
+              <a:t>- Training on five similar states' 2022-24 data - never touching Louisiana - delivered 14% precision at 49% of error dollars on Louisiana 2022-24.</a:t>
+            </a:r>
+          </a:p>
+          <a:p>
+            <a:pPr>
+              <a:spcAft>
+                <a:spcPts val="400"/>
+              </a:spcAft>
+            </a:pPr>
+            <a:r>
+              <a:rPr sz="1200"/>
+              <a:t>- Both comparisons used identical engines and filters; the only differences were WHERE and WHEN the training data came from.</a:t>
+            </a:r>
+          </a:p>
         </p:txBody>
-        <a:p>
-          <a:pPr>
-            <a:spcAft>
-              <a:spcPts val="400"/>
-            </a:spcAft>
-          </a:pPr>
-          <a:r>
-            <a:rPr sz="1200"/>
-            <a:t>- Louisiana's own 2022-24 mining collapsed on holdout. Adding its 2017-19 data made it WORSE (median holdout precision fell to zero).</a:t>
-          </a:r>
-        </a:p>
       </p:sp>
-      <a:p>
-        <a:pPr>
-          <a:spcAft>
-            <a:spcPts val="400"/>
-          </a:spcAft>
-        </a:pPr>
-        <a:r>
-          <a:rPr sz="1200"/>
-          <a:t>- Louisiana's own 2022-24 mining collapsed on holdout. Adding its 2017-19 data made it WORSE (median holdout precision fell to zero).</a:t>
-        </a:r>
-      </a:p>
       <p:sp>
         <p:nvSpPr>
           <p:cNvPr id="3" name="TextBox 2"/>
@@ -10195,30 +10217,30 @@
               <a:t>- We compute state similarity from the QC microdata itself, two ways: which risk patterns fire in a state's caseload (weighting rarely-firing patterns more heavily), and de facto policy-option profiles (categorical eligibility, reporting system, certification periods, deduction structures - all readable off the microdata, per era).</a:t>
             </a:r>
           </a:p>
+          <a:p>
+            <a:pPr>
+              <a:spcAft>
+                <a:spcPts val="400"/>
+              </a:spcAft>
+            </a:pPr>
+            <a:r>
+              <a:rPr sz="1200"/>
+              <a:t>- The two definitions, built from different information, agree on Louisiana's 2022-24 donor pool - and reproduce the pool that worked above. Neighbor lists change sharply between 2017-19 and 2022-24, so we compute them per era.</a:t>
+            </a:r>
+          </a:p>
+          <a:p>
+            <a:pPr>
+              <a:spcAft>
+                <a:spcPts val="400"/>
+              </a:spcAft>
+            </a:pPr>
+            <a:r>
+              <a:rPr sz="1200"/>
+              <a:t>- A leave-one-state-out benchmark (12 states x 4 similarity definitions vs national rules) is running now.</a:t>
+            </a:r>
+          </a:p>
         </p:txBody>
-        <a:p>
-          <a:pPr>
-            <a:spcAft>
-              <a:spcPts val="400"/>
-            </a:spcAft>
-          </a:pPr>
-          <a:r>
-            <a:rPr sz="1200"/>
-            <a:t>- We compute state similarity from the QC microdata itself, two ways: which risk patterns fire in a state's caseload (weighting rarely-firing patterns more heavily), and de facto policy-option profiles (categorical eligibility, reporting system, certification periods, deduction structures - all readable off the microdata, per era).</a:t>
-          </a:r>
-        </a:p>
       </p:sp>
-      <a:p>
-        <a:pPr>
-          <a:spcAft>
-            <a:spcPts val="400"/>
-          </a:spcAft>
-        </a:pPr>
-        <a:r>
-          <a:rPr sz="1200"/>
-          <a:t>- We compute state similarity from the QC microdata itself, two ways: which risk patterns fire in a state's caseload (weighting rarely-firing patterns more heavily), and de facto policy-option profiles (categorical eligibility, reporting system, certification periods, deduction structures - all readable off the microdata, per era).</a:t>
-        </a:r>
-      </a:p>
       <p:sp>
         <p:nvSpPr>
           <p:cNvPr id="3" name="TextBox 2"/>
@@ -10327,30 +10349,41 @@
               <a:t>- Reconcile your build against the raw files before tuning anything: our two data-build fixes moved results more than any hyperparameter.</a:t>
             </a:r>
           </a:p>
+          <a:p>
+            <a:pPr>
+              <a:spcAft>
+                <a:spcPts val="400"/>
+              </a:spcAft>
+            </a:pPr>
+            <a:r>
+              <a:rPr sz="1200"/>
+              <a:t>- Select on a lower confidence bound, judge on a held-out year, and add hard support floors when samples are small.</a:t>
+            </a:r>
+          </a:p>
+          <a:p>
+            <a:pPr>
+              <a:spcAft>
+                <a:spcPts val="400"/>
+              </a:spcAft>
+            </a:pPr>
+            <a:r>
+              <a:rPr sz="1200"/>
+              <a:t>- Score against all error types; stratify only where a variable can't do the job; prefer same-era similar data over more mixed data.</a:t>
+            </a:r>
+          </a:p>
+          <a:p>
+            <a:pPr>
+              <a:spcAft>
+                <a:spcPts val="400"/>
+              </a:spcAft>
+            </a:pPr>
+            <a:r>
+              <a:rPr sz="1200"/>
+              <a:t>- Numbers, charts, and code: github.com/giannella/snap_qc</a:t>
+            </a:r>
+          </a:p>
         </p:txBody>
-        <a:p>
-          <a:pPr>
-            <a:spcAft>
-              <a:spcPts val="400"/>
-            </a:spcAft>
-          </a:pPr>
-          <a:r>
-            <a:rPr sz="1200"/>
-            <a:t>- Reconcile your build against the raw files before tuning anything: our two data-build fixes moved results more than any hyperparameter.</a:t>
-          </a:r>
-        </a:p>
       </p:sp>
-      <a:p>
-        <a:pPr>
-          <a:spcAft>
-            <a:spcPts val="400"/>
-          </a:spcAft>
-        </a:pPr>
-        <a:r>
-          <a:rPr sz="1200"/>
-          <a:t>- Reconcile your build against the raw files before tuning anything: our two data-build fixes moved results more than any hyperparameter.</a:t>
-        </a:r>
-      </a:p>
       <p:sp>
         <p:nvSpPr>
           <p:cNvPr id="3" name="TextBox 2"/>
@@ -10381,17 +10414,6 @@
         </p:txBody>
       </p:sp>
     </p:spTree>
-    <a:p>
-      <a:pPr>
-        <a:spcAft>
-          <a:spcPts val="400"/>
-        </a:spcAft>
-      </a:pPr>
-      <a:r>
-        <a:rPr sz="1200"/>
-        <a:t>- Reconcile your build against the raw files before tuning anything: our two data-build fixes moved results more than any hyperparameter.</a:t>
-      </a:r>
-    </a:p>
   </p:cSld>
   <p:clrMapOvr>
     <a:masterClrMapping/>

</xml_diff>

<commit_message>
Reference fixes for methods/ doc moves; replication figure + builder slide
CLAUDE.md, README, log-finding skill, and cross-docs now point at
methods/*.md; add methods/replication_selection_figure.R and its
presentation figure; lessons-deck builder gains the replication slide
(deck rebuild pending - file open in PowerPoint).

Co-Authored-By: Claude Fable 5 <noreply@anthropic.com>
</commit_message>
<xml_diff>
--- a/lessons_getting_more_signal_from_snap_qc_data.pptx
+++ b/lessons_getting_more_signal_from_snap_qc_data.pptx
@@ -22,6 +22,7 @@
     <p:sldId id="290" r:id="rId41"/>
     <p:sldId id="291" r:id="rId42"/>
     <p:sldId id="292" r:id="rId43"/>
+    <p:sldId id="293" r:id="rId44"/>
   </p:sldIdLst>
   <p:sldSz cx="9144000" cy="5143500" type="screen16x9"/>
   <p:notesSz cx="5143500" cy="9144000"/>
@@ -9493,7 +9494,7 @@
             </a:pPr>
             <a:r>
               <a:rPr sz="1200"/>
-              <a:t>- Within engines: mtry = 2 beat mtry = 1 across the frontier; subsampling 15-30% of data per tree was a plateau (we use 20%); slow learning (eta 0.02, 1000 rounds) beat fast; depth 4 sufficed.</a:t>
+              <a:t>- Within engines: mtry = 2 beat mtry = 1 across the frontier; slow learning (eta 0.02, 1000 rounds) beat fast; depth 4 sufficed; subsample barely matters (see the replication on the next slide).</a:t>
             </a:r>
           </a:p>
           <a:p>
@@ -9604,7 +9605,7 @@
           <a:p>
             <a:r>
               <a:rPr sz="2200" b="1"/>
-              <a:t>Score rules against all error types, not just the mined type</a:t>
+              <a:t>Re-test your selection choices on a year that never judged them</a:t>
             </a:r>
           </a:p>
         </p:txBody>
@@ -9638,7 +9639,7 @@
             </a:pPr>
             <a:r>
               <a:rPr sz="1200"/>
-              <a:t>- Rules mined for one error type also flag cases carrying other types. Scored only against the mined type, our earned-income rules measured 8% precision on the held-out year; scored against any above-threshold error on the same flags, 19%.</a:t>
+              <a:t>- Every configuration choice above was judged on the same held-out year (2023), so the selection PROCEDURE itself could be overfit to one year. We re-ran the decisive comparisons with the year roles swapped (train 2022+2023, test 2024), with expected outcomes and failure criteria written down BEFORE the run.</a:t>
             </a:r>
           </a:p>
           <a:p>
@@ -9649,7 +9650,7 @@
             </a:pPr>
             <a:r>
               <a:rPr sz="1200"/>
-              <a:t>- The gap was similar across frames (~2x). Reporting only the narrow metric understates what reviewers would actually find.</a:t>
+              <a:t>- Three of four claims replicated: the engine pairing still leads recall (margin thinner, 2.1pp vs 3pp+), stringency still buys precision monotonically, big ensembles still widen the menu ~7x at ~0.02 precision cost.</a:t>
             </a:r>
           </a:p>
           <a:p>
@@ -9660,7 +9661,7 @@
             </a:pPr>
             <a:r>
               <a:rPr sz="1200"/>
-              <a:t>- We now compute both in every run (dashed vs solid below).</a:t>
+              <a:t>- One claim failed and is retired: 'low subsampling beats high' - on 2024 all nine settings from 0.15 to 0.80 land within 0.005 (right panel). The retraction is what makes the survivors credible: the procedure demonstrably can say no.</a:t>
             </a:r>
           </a:p>
         </p:txBody>
@@ -9696,7 +9697,7 @@
       </p:sp>
       <p:pic>
         <p:nvPicPr>
-          <p:cNvPr id="5" name="Picture 4" descr="image.png"/>
+          <p:cNvPr id="5" name="Picture 4" descr="replication_selection_studies.png"/>
           <p:cNvPicPr>
             <a:picLocks noChangeAspect="1"/>
           </p:cNvPicPr>
@@ -9710,8 +9711,8 @@
         </p:blipFill>
         <p:spPr>
           <a:xfrm>
-            <a:off x="2450592" y="2496312"/>
-            <a:ext cx="4242815" cy="2121407"/>
+            <a:off x="2880360" y="3264408"/>
+            <a:ext cx="3383279" cy="1353311"/>
           </a:xfrm>
           <a:prstGeom prst="rect">
             <a:avLst/>
@@ -9760,7 +9761,7 @@
           <a:p>
             <a:r>
               <a:rPr sz="2200" b="1"/>
-              <a:t>Split by coarse household-size strata (1 / 2-3 / 4+)</a:t>
+              <a:t>Score rules against all error types, not just the mined type</a:t>
             </a:r>
           </a:p>
         </p:txBody>
@@ -9794,7 +9795,7 @@
             </a:pPr>
             <a:r>
               <a:rPr sz="1200"/>
-              <a:t>- Household-size strata 1 / 2-3 / 4+ beat pooled modeling on recall reach and filtered inventory (~5x); a 5-way split was worse on the same test year.</a:t>
+              <a:t>- Rules mined for one error type also flag cases carrying other types. Scored only against the mined type, our earned-income rules measured 8% precision on the held-out year; scored against any above-threshold error on the same flags, 19%.</a:t>
             </a:r>
           </a:p>
           <a:p>
@@ -9805,7 +9806,7 @@
             </a:pPr>
             <a:r>
               <a:rPr sz="1200"/>
-              <a:t>- Adding an elderly/disabled STRATUM on top bought nothing: an indicator variable achieved the same held-out frontier and the same coverage of those households - we checked coverage parity explicitly.</a:t>
+              <a:t>- The gap was similar across frames (~2x). Reporting only the narrow metric understates what reviewers would actually find.</a:t>
             </a:r>
           </a:p>
           <a:p>
@@ -9816,7 +9817,7 @@
             </a:pPr>
             <a:r>
               <a:rPr sz="1200"/>
-              <a:t>- We test 'new stratum vs new variable' empirically before adding strata; strata cost data and the variable usually suffices.</a:t>
+              <a:t>- We now compute both in every run (dashed vs solid below).</a:t>
             </a:r>
           </a:p>
         </p:txBody>
@@ -9866,8 +9867,8 @@
         </p:blipFill>
         <p:spPr>
           <a:xfrm>
-            <a:off x="2836302" y="2496312"/>
-            <a:ext cx="3471394" cy="2121407"/>
+            <a:off x="2450592" y="2496312"/>
+            <a:ext cx="4242815" cy="2121407"/>
           </a:xfrm>
           <a:prstGeom prst="rect">
             <a:avLst/>
@@ -9916,7 +9917,7 @@
           <a:p>
             <a:r>
               <a:rPr sz="2200" b="1"/>
-              <a:t>At state scale, confidence bounds alone were not enough</a:t>
+              <a:t>Split by coarse household-size strata (1 / 2-3 / 4+)</a:t>
             </a:r>
           </a:p>
         </p:txBody>
@@ -9950,7 +9951,7 @@
             </a:pPr>
             <a:r>
               <a:rPr sz="1200"/>
-              <a:t>- Mining directly on one state's data (~2,000-3,000 cases/year), rules passing the same 99% lower-bound filter with small support had median HOLDOUT precision of zero at support &gt;= 5.</a:t>
+              <a:t>- Household-size strata 1 / 2-3 / 4+ beat pooled modeling on recall reach and filtered inventory (~5x); a 5-way split was worse on the same test year.</a:t>
             </a:r>
           </a:p>
           <a:p>
@@ -9961,7 +9962,7 @@
             </a:pPr>
             <a:r>
               <a:rPr sz="1200"/>
-              <a:t>- Requiring each rule to flag &gt;= 30 training cases changed the failure mode from collapse to gentle deflation (~1/3 below training estimates).</a:t>
+              <a:t>- Adding an elderly/disabled STRATUM on top bought nothing: an indicator variable achieved the same held-out frontier and the same coverage of those households - we checked coverage parity explicitly.</a:t>
             </a:r>
           </a:p>
           <a:p>
@@ -9972,7 +9973,7 @@
             </a:pPr>
             <a:r>
               <a:rPr sz="1200"/>
-              <a:t>- National scale hides this: with 100k+ cases the bound rarely admits tiny-support rules in the first place.</a:t>
+              <a:t>- We test 'new stratum vs new variable' empirically before adding strata; strata cost data and the variable usually suffices.</a:t>
             </a:r>
           </a:p>
         </p:txBody>
@@ -10006,6 +10007,30 @@
           </a:p>
         </p:txBody>
       </p:sp>
+      <p:pic>
+        <p:nvPicPr>
+          <p:cNvPr id="5" name="Picture 4" descr="image.png"/>
+          <p:cNvPicPr>
+            <a:picLocks noChangeAspect="1"/>
+          </p:cNvPicPr>
+          <p:nvPr/>
+        </p:nvPicPr>
+        <p:blipFill>
+          <a:blip r:embed="rId2"/>
+          <a:stretch>
+            <a:fillRect/>
+          </a:stretch>
+        </p:blipFill>
+        <p:spPr>
+          <a:xfrm>
+            <a:off x="2836302" y="2496312"/>
+            <a:ext cx="3471394" cy="2121407"/>
+          </a:xfrm>
+          <a:prstGeom prst="rect">
+            <a:avLst/>
+          </a:prstGeom>
+        </p:spPr>
+      </p:pic>
     </p:spTree>
   </p:cSld>
   <p:clrMapOvr>
@@ -10048,7 +10073,7 @@
           <a:p>
             <a:r>
               <a:rPr sz="2200" b="1"/>
-              <a:t>For thin states, same-era neighbor data beat more own-state data</a:t>
+              <a:t>At state scale, confidence bounds alone were not enough</a:t>
             </a:r>
           </a:p>
         </p:txBody>
@@ -10082,7 +10107,7 @@
             </a:pPr>
             <a:r>
               <a:rPr sz="1200"/>
-              <a:t>- Louisiana's own 2022-24 mining collapsed on holdout. Adding its 2017-19 data made it WORSE (median holdout precision fell to zero).</a:t>
+              <a:t>- Mining directly on one state's data (~2,000-3,000 cases/year), rules passing the same 99% lower-bound filter with small support had median HOLDOUT precision of zero at support &gt;= 5.</a:t>
             </a:r>
           </a:p>
           <a:p>
@@ -10093,7 +10118,7 @@
             </a:pPr>
             <a:r>
               <a:rPr sz="1200"/>
-              <a:t>- Training on five similar states' 2022-24 data - never touching Louisiana - delivered 14% precision at 49% of error dollars on Louisiana 2022-24.</a:t>
+              <a:t>- Requiring each rule to flag &gt;= 30 training cases changed the failure mode from collapse to gentle deflation (~1/3 below training estimates).</a:t>
             </a:r>
           </a:p>
           <a:p>
@@ -10104,7 +10129,7 @@
             </a:pPr>
             <a:r>
               <a:rPr sz="1200"/>
-              <a:t>- Both comparisons used identical engines and filters; the only differences were WHERE and WHEN the training data came from.</a:t>
+              <a:t>- National scale hides this: with 100k+ cases the bound rarely admits tiny-support rules in the first place.</a:t>
             </a:r>
           </a:p>
         </p:txBody>
@@ -10180,7 +10205,7 @@
           <a:p>
             <a:r>
               <a:rPr sz="2200" b="1"/>
-              <a:t>Current work: choosing donor states by measured similarity</a:t>
+              <a:t>For thin states, same-era neighbor data beat more own-state data</a:t>
             </a:r>
           </a:p>
         </p:txBody>
@@ -10214,7 +10239,7 @@
             </a:pPr>
             <a:r>
               <a:rPr sz="1200"/>
-              <a:t>- We compute state similarity from the QC microdata itself, two ways: which risk patterns fire in a state's caseload (weighting rarely-firing patterns more heavily), and de facto policy-option profiles (categorical eligibility, reporting system, certification periods, deduction structures - all readable off the microdata, per era).</a:t>
+              <a:t>- Louisiana's own 2022-24 mining collapsed on holdout. Adding its 2017-19 data made it WORSE (median holdout precision fell to zero).</a:t>
             </a:r>
           </a:p>
           <a:p>
@@ -10225,7 +10250,7 @@
             </a:pPr>
             <a:r>
               <a:rPr sz="1200"/>
-              <a:t>- The two definitions, built from different information, agree on Louisiana's 2022-24 donor pool - and reproduce the pool that worked above. Neighbor lists change sharply between 2017-19 and 2022-24, so we compute them per era.</a:t>
+              <a:t>- Training on five similar states' 2022-24 data - never touching Louisiana - delivered 14% precision at 49% of error dollars on Louisiana 2022-24.</a:t>
             </a:r>
           </a:p>
           <a:p>
@@ -10236,7 +10261,7 @@
             </a:pPr>
             <a:r>
               <a:rPr sz="1200"/>
-              <a:t>- A leave-one-state-out benchmark (12 states x 4 similarity definitions vs national rules) is running now.</a:t>
+              <a:t>- Both comparisons used identical engines and filters; the only differences were WHERE and WHEN the training data came from.</a:t>
             </a:r>
           </a:p>
         </p:txBody>
@@ -10279,6 +10304,138 @@
 </file>
 
 <file path=ppt/slides/slide36.xml><?xml version="1.0" encoding="utf-8"?>
+<p:sld xmlns:a="http://schemas.openxmlformats.org/drawingml/2006/main" xmlns:p="http://schemas.openxmlformats.org/presentationml/2006/main" xmlns:r="http://schemas.openxmlformats.org/officeDocument/2006/relationships">
+  <p:cSld>
+    <p:spTree>
+      <p:nvGrpSpPr>
+        <p:cNvPr id="1" name=""/>
+        <p:cNvGrpSpPr/>
+        <p:nvPr/>
+      </p:nvGrpSpPr>
+      <p:grpSpPr/>
+      <p:sp>
+        <p:nvSpPr>
+          <p:cNvPr id="2" name="TextBox 1"/>
+          <p:cNvSpPr txBox="1"/>
+          <p:nvPr/>
+        </p:nvSpPr>
+        <p:spPr>
+          <a:xfrm>
+            <a:off x="400000" y="200000"/>
+            <a:ext cx="8344000" cy="600000"/>
+          </a:xfrm>
+          <a:prstGeom prst="rect">
+            <a:avLst/>
+          </a:prstGeom>
+          <a:noFill/>
+        </p:spPr>
+        <p:txBody>
+          <a:bodyPr wrap="none">
+            <a:spAutoFit/>
+          </a:bodyPr>
+          <a:lstStyle/>
+          <a:p>
+            <a:r>
+              <a:rPr sz="2200" b="1"/>
+              <a:t>Current work: choosing donor states by measured similarity</a:t>
+            </a:r>
+          </a:p>
+        </p:txBody>
+      </p:sp>
+      <p:sp>
+        <p:nvSpPr>
+          <p:cNvPr id="4" name="TextBox 3"/>
+          <p:cNvSpPr txBox="1"/>
+          <p:nvPr/>
+        </p:nvSpPr>
+        <p:spPr>
+          <a:xfrm>
+            <a:off x="400000" y="760000"/>
+            <a:ext cx="8344000" cy="430000"/>
+          </a:xfrm>
+          <a:prstGeom prst="rect">
+            <a:avLst/>
+          </a:prstGeom>
+          <a:noFill/>
+        </p:spPr>
+        <p:txBody>
+          <a:bodyPr wrap="square">
+            <a:spAutoFit/>
+          </a:bodyPr>
+          <a:lstStyle/>
+          <a:p>
+            <a:pPr>
+              <a:spcAft>
+                <a:spcPts val="400"/>
+              </a:spcAft>
+            </a:pPr>
+            <a:r>
+              <a:rPr sz="1200"/>
+              <a:t>- We compute state similarity from the QC microdata itself, two ways: which risk patterns fire in a state's caseload (weighting rarely-firing patterns more heavily), and de facto policy-option profiles (categorical eligibility, reporting system, certification periods, deduction structures - all readable off the microdata, per era).</a:t>
+            </a:r>
+          </a:p>
+          <a:p>
+            <a:pPr>
+              <a:spcAft>
+                <a:spcPts val="400"/>
+              </a:spcAft>
+            </a:pPr>
+            <a:r>
+              <a:rPr sz="1200"/>
+              <a:t>- The two definitions, built from different information, agree on Louisiana's 2022-24 donor pool - and reproduce the pool that worked above. Neighbor lists change sharply between 2017-19 and 2022-24, so we compute them per era.</a:t>
+            </a:r>
+          </a:p>
+          <a:p>
+            <a:pPr>
+              <a:spcAft>
+                <a:spcPts val="400"/>
+              </a:spcAft>
+            </a:pPr>
+            <a:r>
+              <a:rPr sz="1200"/>
+              <a:t>- A leave-one-state-out benchmark (12 states x 4 similarity definitions vs national rules) is running now.</a:t>
+            </a:r>
+          </a:p>
+        </p:txBody>
+      </p:sp>
+      <p:sp>
+        <p:nvSpPr>
+          <p:cNvPr id="3" name="TextBox 2"/>
+          <p:cNvSpPr txBox="1"/>
+          <p:nvPr/>
+        </p:nvSpPr>
+        <p:spPr>
+          <a:xfrm>
+            <a:off x="400000" y="4723500"/>
+            <a:ext cx="3200000" cy="320000"/>
+          </a:xfrm>
+          <a:prstGeom prst="rect">
+            <a:avLst/>
+          </a:prstGeom>
+          <a:noFill/>
+        </p:spPr>
+        <p:txBody>
+          <a:bodyPr wrap="none">
+            <a:spAutoFit/>
+          </a:bodyPr>
+          <a:lstStyle/>
+          <a:p>
+            <a:r>
+              <a:rPr sz="1000" i="1"/>
+              <a:t>SNAP QC modeling lessons - July 2026</a:t>
+            </a:r>
+          </a:p>
+        </p:txBody>
+      </p:sp>
+    </p:spTree>
+  </p:cSld>
+  <p:clrMapOvr>
+    <a:masterClrMapping/>
+  </p:clrMapOvr>
+</p:sld>
+</file>
+
+<file path=ppt/slides/slide37.xml><?xml version="1.0" encoding="utf-8"?>
 <p:sld xmlns:a="http://schemas.openxmlformats.org/drawingml/2006/main" xmlns:p="http://schemas.openxmlformats.org/presentationml/2006/main" xmlns:r="http://schemas.openxmlformats.org/officeDocument/2006/relationships">
   <p:cSld>
     <p:spTree>

</xml_diff>

<commit_message>
Lessons deck: budget-lens slide + rebuilt with updated replication figure
New slide 14 "Evaluate at review budgets, not just statistical floors"
(best-pool PR figure; the 0.20-floor half-caseload trap, budget-filled
medians, the Mississippi floor artifact). Rebuild also picks up the
level-gap subtitle on slide 9 and the methods/ doc path on the title slide.

Co-Authored-By: Claude Fable 5 <noreply@anthropic.com>
</commit_message>
<xml_diff>
--- a/lessons_getting_more_signal_from_snap_qc_data.pptx
+++ b/lessons_getting_more_signal_from_snap_qc_data.pptx
@@ -23,6 +23,7 @@
     <p:sldId id="291" r:id="rId42"/>
     <p:sldId id="292" r:id="rId43"/>
     <p:sldId id="293" r:id="rId44"/>
+    <p:sldId id="294" r:id="rId45"/>
   </p:sldIdLst>
   <p:sldSz cx="9144000" cy="5143500" type="screen16x9"/>
   <p:notesSz cx="5143500" cy="9144000"/>
@@ -7780,7 +7781,7 @@
             </a:pPr>
             <a:r>
               <a:rPr sz="1200"/>
-              <a:t>Code and full evidence: https://github.com/giannella/snap_qc (modeling_findings.md)</a:t>
+              <a:t>Code and full evidence: https://github.com/giannella/snap_qc (methods/modeling_findings.md)</a:t>
             </a:r>
           </a:p>
         </p:txBody>
@@ -10337,6 +10338,162 @@
           <a:p>
             <a:r>
               <a:rPr sz="2200" b="1"/>
+              <a:t>Evaluate at review budgets, not just statistical floors</a:t>
+            </a:r>
+          </a:p>
+        </p:txBody>
+      </p:sp>
+      <p:sp>
+        <p:nvSpPr>
+          <p:cNvPr id="4" name="TextBox 3"/>
+          <p:cNvSpPr txBox="1"/>
+          <p:nvPr/>
+        </p:nvSpPr>
+        <p:spPr>
+          <a:xfrm>
+            <a:off x="400000" y="760000"/>
+            <a:ext cx="8344000" cy="430000"/>
+          </a:xfrm>
+          <a:prstGeom prst="rect">
+            <a:avLst/>
+          </a:prstGeom>
+          <a:noFill/>
+        </p:spPr>
+        <p:txBody>
+          <a:bodyPr wrap="square">
+            <a:spAutoFit/>
+          </a:bodyPr>
+          <a:lstStyle/>
+          <a:p>
+            <a:pPr>
+              <a:spcAft>
+                <a:spcPts val="400"/>
+              </a:spcAft>
+            </a:pPr>
+            <a:r>
+              <a:rPr sz="1200"/>
+              <a:t>- Confidence floors produce whatever workload they produce: on the rebuilt data, the 0.20 floor's rule union flags ~half the caseload (which is how 'catch 79% of error dollars' happens). States plan around review capacity, not floors.</a:t>
+            </a:r>
+          </a:p>
+          <a:p>
+            <a:pPr>
+              <a:spcAft>
+                <a:spcPts val="400"/>
+              </a:spcAft>
+            </a:pPr>
+            <a:r>
+              <a:rPr sz="1200"/>
+              <a:t>- So we also report budget-filled performance: add rules in descending lower-bound order until 5% or 10% of the caseload is flagged. Median across 12 states, out-of-state rules deliver 0.31-0.34 precision catching 12-16% of error dollars at a 5% budget, and 0.25-0.31 catching 22-30% at 10% - against 9-15% base rates.</a:t>
+            </a:r>
+          </a:p>
+          <a:p>
+            <a:pPr>
+              <a:spcAft>
+                <a:spcPts val="400"/>
+              </a:spcAft>
+            </a:pPr>
+            <a:r>
+              <a:rPr sz="1200"/>
+              <a:t>- The budget lens also corrects floor artifacts: Mississippi's transferred rules stopped firing entirely at a 0.30 floor, yet delivered the best 5%-budget precision of any state (0.346) - the rules were fine, the floor wasn't.</a:t>
+            </a:r>
+          </a:p>
+        </p:txBody>
+      </p:sp>
+      <p:sp>
+        <p:nvSpPr>
+          <p:cNvPr id="3" name="TextBox 2"/>
+          <p:cNvSpPr txBox="1"/>
+          <p:nvPr/>
+        </p:nvSpPr>
+        <p:spPr>
+          <a:xfrm>
+            <a:off x="400000" y="4723500"/>
+            <a:ext cx="3200000" cy="320000"/>
+          </a:xfrm>
+          <a:prstGeom prst="rect">
+            <a:avLst/>
+          </a:prstGeom>
+          <a:noFill/>
+        </p:spPr>
+        <p:txBody>
+          <a:bodyPr wrap="none">
+            <a:spAutoFit/>
+          </a:bodyPr>
+          <a:lstStyle/>
+          <a:p>
+            <a:r>
+              <a:rPr sz="1000" i="1"/>
+              <a:t>SNAP QC modeling lessons - July 2026</a:t>
+            </a:r>
+          </a:p>
+        </p:txBody>
+      </p:sp>
+      <p:pic>
+        <p:nvPicPr>
+          <p:cNvPr id="5" name="Picture 4" descr="best_pool_pr_by_budget.png"/>
+          <p:cNvPicPr>
+            <a:picLocks noChangeAspect="1"/>
+          </p:cNvPicPr>
+          <p:nvPr/>
+        </p:nvPicPr>
+        <p:blipFill>
+          <a:blip r:embed="rId2"/>
+          <a:stretch>
+            <a:fillRect/>
+          </a:stretch>
+        </p:blipFill>
+        <p:spPr>
+          <a:xfrm>
+            <a:off x="3626068" y="3520440"/>
+            <a:ext cx="1891862" cy="1097279"/>
+          </a:xfrm>
+          <a:prstGeom prst="rect">
+            <a:avLst/>
+          </a:prstGeom>
+        </p:spPr>
+      </p:pic>
+    </p:spTree>
+  </p:cSld>
+  <p:clrMapOvr>
+    <a:masterClrMapping/>
+  </p:clrMapOvr>
+</p:sld>
+</file>
+
+<file path=ppt/slides/slide37.xml><?xml version="1.0" encoding="utf-8"?>
+<p:sld xmlns:a="http://schemas.openxmlformats.org/drawingml/2006/main" xmlns:p="http://schemas.openxmlformats.org/presentationml/2006/main" xmlns:r="http://schemas.openxmlformats.org/officeDocument/2006/relationships">
+  <p:cSld>
+    <p:spTree>
+      <p:nvGrpSpPr>
+        <p:cNvPr id="1" name=""/>
+        <p:cNvGrpSpPr/>
+        <p:nvPr/>
+      </p:nvGrpSpPr>
+      <p:grpSpPr/>
+      <p:sp>
+        <p:nvSpPr>
+          <p:cNvPr id="2" name="TextBox 1"/>
+          <p:cNvSpPr txBox="1"/>
+          <p:nvPr/>
+        </p:nvSpPr>
+        <p:spPr>
+          <a:xfrm>
+            <a:off x="400000" y="200000"/>
+            <a:ext cx="8344000" cy="600000"/>
+          </a:xfrm>
+          <a:prstGeom prst="rect">
+            <a:avLst/>
+          </a:prstGeom>
+          <a:noFill/>
+        </p:spPr>
+        <p:txBody>
+          <a:bodyPr wrap="none">
+            <a:spAutoFit/>
+          </a:bodyPr>
+          <a:lstStyle/>
+          <a:p>
+            <a:r>
+              <a:rPr sz="2200" b="1"/>
               <a:t>Current work: choosing donor states by measured similarity</a:t>
             </a:r>
           </a:p>
@@ -10435,7 +10592,7 @@
 </p:sld>
 </file>
 
-<file path=ppt/slides/slide37.xml><?xml version="1.0" encoding="utf-8"?>
+<file path=ppt/slides/slide38.xml><?xml version="1.0" encoding="utf-8"?>
 <p:sld xmlns:a="http://schemas.openxmlformats.org/drawingml/2006/main" xmlns:p="http://schemas.openxmlformats.org/presentationml/2006/main" xmlns:r="http://schemas.openxmlformats.org/officeDocument/2006/relationships">
   <p:cSld>
     <p:spTree>

</xml_diff>

<commit_message>
Clearer frozen-list chart labels
'frozen in advance (2022-23)' vs 'sized all at once on 2024' -- the
comparison list is the opportunistic batch fill of the national pool
against the year's full caseload, not an outcome-informed selection.

Co-Authored-By: Claude Fable 5 <noreply@anthropic.com>
</commit_message>
<xml_diff>
--- a/lessons_getting_more_signal_from_snap_qc_data.pptx
+++ b/lessons_getting_more_signal_from_snap_qc_data.pptx
@@ -15482,7 +15482,7 @@
             </a:pPr>
             <a:r>
               <a:rPr sz="1200"/>
-              <a:t>- Freezing costs ~no precision (median 0.288 vs 0.275 for the fill that saw the 2024 caseload); realized workload lands slightly under target (median -0.9pp, worst -4.4pp), so the cost is under-used capacity: ~3pp of error dollars, recoverable by extending deeper into the ranking when under budget.</a:t>
+              <a:t>- Freezing costs ~no precision (median 0.288 vs 0.275 for a list sized all at once against the full 2024 caseload); realized workload lands slightly under target (median -0.9pp, worst -4.4pp), so the cost is under-used capacity: ~3pp of error dollars, recoverable by extending deeper into the ranking when under budget.</a:t>
             </a:r>
           </a:p>
           <a:p>
@@ -15543,8 +15543,8 @@
         </p:blipFill>
         <p:spPr>
           <a:xfrm>
-            <a:off x="3510665" y="2752344"/>
-            <a:ext cx="2122669" cy="1865375"/>
+            <a:off x="3656338" y="3008376"/>
+            <a:ext cx="1831322" cy="1609343"/>
           </a:xfrm>
           <a:prstGeom prst="rect">
             <a:avLst/>

</xml_diff>

<commit_message>
Frozen lists ship with ranked buffer, walked to capacity
- the deliverable is one ranked list per state (core to the budget +
  buffer to 3x depth on the 2022-23 caseload); deployment walks it in
  order while capacity fits -- absorbs both under-firing (Michigan 3.5%
  -> 5.0%) and over-firing (Connecticut 12% -> 10%), outcome-free
- headline metrics are at-capacity: median precision 0.294/0.270 vs
  0.301/0.275 for the full pool applied at once; core-only numbers
  understated deployment (idle capacity) and are kept as diagnostics
- charts: two panels (precision, error dollars), workload column dropped
  (always lands on target); user-approved series labels; deck gets a
  descriptive deliverable slide before the chart slide

Co-Authored-By: Claude Fable 5 <noreply@anthropic.com>
</commit_message>
<xml_diff>
--- a/lessons_getting_more_signal_from_snap_qc_data.pptx
+++ b/lessons_getting_more_signal_from_snap_qc_data.pptx
@@ -31,6 +31,7 @@
     <p:sldId id="299" r:id="rId50"/>
     <p:sldId id="300" r:id="rId51"/>
     <p:sldId id="301" r:id="rId52"/>
+    <p:sldId id="302" r:id="rId53"/>
   </p:sldIdLst>
   <p:sldSz cx="9144000" cy="5143500" type="screen16x9"/>
   <p:notesSz cx="5143500" cy="9144000"/>
@@ -15437,7 +15438,7 @@
           <a:p>
             <a:r>
               <a:rPr sz="2200" b="1"/>
-              <a:t>Freeze each state's list in advance: it costs almost nothing</a:t>
+              <a:t>The deliverable: one ranked rule list per state, walked to capacity</a:t>
             </a:r>
           </a:p>
         </p:txBody>
@@ -15471,7 +15472,7 @@
             </a:pPr>
             <a:r>
               <a:rPr sz="1200"/>
-              <a:t>- The handable deliverable: budget-fill the ranked national list against the state's own 2022-23 caseload (no outcomes needed), freeze the 35-101 contributing rules, deploy unchanged on 2024.</a:t>
+              <a:t>- Built in advance from public data alone: fill the national pool (mined on all states' 2022-23) against the state's own 2022-23 caseload, in confidence order, until the review budget is reached - then keep filling to 3x that depth. The extra rules are ranked BUFFER rules, shipped in the same list.</a:t>
             </a:r>
           </a:p>
           <a:p>
@@ -15482,7 +15483,7 @@
             </a:pPr>
             <a:r>
               <a:rPr sz="1200"/>
-              <a:t>- Freezing costs ~no precision (median 0.288 vs 0.275 for a list sized all at once against the full 2024 caseload); realized workload lands slightly under target (median -0.9pp, worst -4.4pp), so the cost is under-used capacity: ~3pp of error dollars, recoverable by extending deeper into the ranking when under budget.</a:t>
+              <a:t>- To use it, the state activates rules in order, checking only its own flag counts: keep adding while reviews fit capacity. No error outcomes are needed at any step.</a:t>
             </a:r>
           </a:p>
           <a:p>
@@ -15493,7 +15494,18 @@
             </a:pPr>
             <a:r>
               <a:rPr sz="1200"/>
-              <a:t>- All 18 states clear their base rate. Validation recipe for a state: we freeze on public data through the latest year; the state validates on its own newer internal data before relying on it.</a:t>
+              <a:t>- The buffer is what makes the workload land on budget as patterns change: a state never stops reviewing because a list ran dry, and an over-firing list trims the same way. Raw core lists drifted to 2.3-12% of caseload on 2024; the walked lists land at 4.9-5.0% and 9.3-10.0% in all 18 states.</a:t>
+            </a:r>
+          </a:p>
+          <a:p>
+            <a:pPr>
+              <a:spcAft>
+                <a:spcPts val="400"/>
+              </a:spcAft>
+            </a:pPr>
+            <a:r>
+              <a:rPr sz="1200"/>
+              <a:t>- Median rules actually activated: 23 at a 5% budget, 42 at 10%. Validation recipe: we freeze on public data through the latest year; the state validates on its own newer internal data before relying on it.</a:t>
             </a:r>
           </a:p>
         </p:txBody>
@@ -15527,6 +15539,127 @@
           </a:p>
         </p:txBody>
       </p:sp>
+    </p:spTree>
+  </p:cSld>
+  <p:clrMapOvr>
+    <a:masterClrMapping/>
+  </p:clrMapOvr>
+</p:sld>
+</file>
+
+<file path=ppt/slides/slide45.xml><?xml version="1.0" encoding="utf-8"?>
+<p:sld xmlns:a="http://schemas.openxmlformats.org/drawingml/2006/main" xmlns:p="http://schemas.openxmlformats.org/presentationml/2006/main" xmlns:r="http://schemas.openxmlformats.org/officeDocument/2006/relationships">
+  <p:cSld>
+    <p:spTree>
+      <p:nvGrpSpPr>
+        <p:cNvPr id="1" name=""/>
+        <p:cNvGrpSpPr/>
+        <p:nvPr/>
+      </p:nvGrpSpPr>
+      <p:grpSpPr/>
+      <p:sp>
+        <p:nvSpPr>
+          <p:cNvPr id="2" name="TextBox 1"/>
+          <p:cNvSpPr txBox="1"/>
+          <p:nvPr/>
+        </p:nvSpPr>
+        <p:spPr>
+          <a:xfrm>
+            <a:off x="400000" y="200000"/>
+            <a:ext cx="8344000" cy="600000"/>
+          </a:xfrm>
+          <a:prstGeom prst="rect">
+            <a:avLst/>
+          </a:prstGeom>
+          <a:noFill/>
+        </p:spPr>
+        <p:txBody>
+          <a:bodyPr wrap="none">
+            <a:spAutoFit/>
+          </a:bodyPr>
+          <a:lstStyle/>
+          <a:p>
+            <a:r>
+              <a:rPr sz="2200" b="1"/>
+              <a:t>Freeze each state's list in advance: it costs almost nothing</a:t>
+            </a:r>
+          </a:p>
+        </p:txBody>
+      </p:sp>
+      <p:sp>
+        <p:nvSpPr>
+          <p:cNvPr id="4" name="TextBox 3"/>
+          <p:cNvSpPr txBox="1"/>
+          <p:nvPr/>
+        </p:nvSpPr>
+        <p:spPr>
+          <a:xfrm>
+            <a:off x="400000" y="760000"/>
+            <a:ext cx="8344000" cy="430000"/>
+          </a:xfrm>
+          <a:prstGeom prst="rect">
+            <a:avLst/>
+          </a:prstGeom>
+          <a:noFill/>
+        </p:spPr>
+        <p:txBody>
+          <a:bodyPr wrap="square">
+            <a:spAutoFit/>
+          </a:bodyPr>
+          <a:lstStyle/>
+          <a:p>
+            <a:pPr>
+              <a:spcAft>
+                <a:spcPts val="400"/>
+              </a:spcAft>
+            </a:pPr>
+            <a:r>
+              <a:rPr sz="1200"/>
+              <a:t>- The frozen list (built on 2022-23, walked to capacity on 2024) against the full national pool applied at once to the realized 2024 caseload - both at identical review volume.</a:t>
+            </a:r>
+          </a:p>
+          <a:p>
+            <a:pPr>
+              <a:spcAft>
+                <a:spcPts val="400"/>
+              </a:spcAft>
+            </a:pPr>
+            <a:r>
+              <a:rPr sz="1200"/>
+              <a:t>- Median precision 0.294 vs 0.301 (5% budget) and 0.270 vs 0.275 (10%); error dollars 12% vs 16% and 25% vs 25%. All 18 states clear their base rate.</a:t>
+            </a:r>
+          </a:p>
+        </p:txBody>
+      </p:sp>
+      <p:sp>
+        <p:nvSpPr>
+          <p:cNvPr id="3" name="TextBox 2"/>
+          <p:cNvSpPr txBox="1"/>
+          <p:nvPr/>
+        </p:nvSpPr>
+        <p:spPr>
+          <a:xfrm>
+            <a:off x="400000" y="4723500"/>
+            <a:ext cx="3200000" cy="320000"/>
+          </a:xfrm>
+          <a:prstGeom prst="rect">
+            <a:avLst/>
+          </a:prstGeom>
+          <a:noFill/>
+        </p:spPr>
+        <p:txBody>
+          <a:bodyPr wrap="none">
+            <a:spAutoFit/>
+          </a:bodyPr>
+          <a:lstStyle/>
+          <a:p>
+            <a:r>
+              <a:rPr sz="1000" i="1"/>
+              <a:t>SNAP QC modeling lessons - July 2026</a:t>
+            </a:r>
+          </a:p>
+        </p:txBody>
+      </p:sp>
       <p:pic>
         <p:nvPicPr>
           <p:cNvPr id="5" name="Picture 4" descr="frozen_lists_panels_budget10.png"/>
@@ -15543,8 +15676,8 @@
         </p:blipFill>
         <p:spPr>
           <a:xfrm>
-            <a:off x="3656338" y="3008376"/>
-            <a:ext cx="1831322" cy="1609343"/>
+            <a:off x="3073645" y="1984248"/>
+            <a:ext cx="2996709" cy="2633471"/>
           </a:xfrm>
           <a:prstGeom prst="rect">
             <a:avLst/>
@@ -15559,7 +15692,7 @@
 </p:sld>
 </file>
 
-<file path=ppt/slides/slide45.xml><?xml version="1.0" encoding="utf-8"?>
+<file path=ppt/slides/slide46.xml><?xml version="1.0" encoding="utf-8"?>
 <p:sld xmlns:a="http://schemas.openxmlformats.org/drawingml/2006/main" xmlns:p="http://schemas.openxmlformats.org/presentationml/2006/main" xmlns:r="http://schemas.openxmlformats.org/officeDocument/2006/relationships">
   <p:cSld>
     <p:spTree>

</xml_diff>

<commit_message>
Two-regime handoff table + own-pool frozen lists + exported list files
- frozen_own_lists_v2.R: frozen core+buffer lists from each state's own
  mined pool (the second regime), walked to capacity on 2024 -- own-regime
  performance holds (NJ 0.230-0.241, MD 0.371-0.412); own-pool rules are
  broad, so 2-29 rules fill capacity
- two_regime_handoff.csv + deck slide 24: per state x budget, the chosen
  regime and the rules a state is actually handed (13-281) vs typically
  run (2-49)
- frozen_list_experiment_v2.R now exports per-state list files at BOTH
  sizings (frozen_list_<state>_budget05/10.csv); own-pool lists exported
  alongside (frozen_own_list_*)

Co-Authored-By: Claude Fable 5 <noreply@anthropic.com>
</commit_message>
<xml_diff>
--- a/lessons_getting_more_signal_from_snap_qc_data.pptx
+++ b/lessons_getting_more_signal_from_snap_qc_data.pptx
@@ -32,6 +32,7 @@
     <p:sldId id="300" r:id="rId51"/>
     <p:sldId id="301" r:id="rId52"/>
     <p:sldId id="302" r:id="rId53"/>
+    <p:sldId id="303" r:id="rId54"/>
   </p:sldIdLst>
   <p:sldSz cx="9144000" cy="5143500" type="screen16x9"/>
   <p:notesSz cx="5143500" cy="9144000"/>
@@ -15726,6 +15727,1914 @@
           <a:p>
             <a:r>
               <a:rPr sz="2200" b="1"/>
+              <a:t>What a state is handed under the two-regime rule</a:t>
+            </a:r>
+          </a:p>
+        </p:txBody>
+      </p:sp>
+      <p:sp>
+        <p:nvSpPr>
+          <p:cNvPr id="4" name="TextBox 3"/>
+          <p:cNvSpPr txBox="1"/>
+          <p:nvPr/>
+        </p:nvSpPr>
+        <p:spPr>
+          <a:xfrm>
+            <a:off x="400000" y="760000"/>
+            <a:ext cx="8344000" cy="430000"/>
+          </a:xfrm>
+          <a:prstGeom prst="rect">
+            <a:avLst/>
+          </a:prstGeom>
+          <a:noFill/>
+        </p:spPr>
+        <p:txBody>
+          <a:bodyPr wrap="square">
+            <a:spAutoFit/>
+          </a:bodyPr>
+          <a:lstStyle/>
+          <a:p>
+            <a:pPr>
+              <a:spcAft>
+                <a:spcPts val="400"/>
+              </a:spcAft>
+            </a:pPr>
+            <a:r>
+              <a:rPr sz="1200"/>
+              <a:t>- One ranked list per state (core sized to the budget + buffer to 3x depth), from the national pool by default or the state's own mined pool where its own rules win on 2024. 'Typically run' = rules actually activated before 2024 capacity filled.</a:t>
+            </a:r>
+          </a:p>
+        </p:txBody>
+      </p:sp>
+      <p:sp>
+        <p:nvSpPr>
+          <p:cNvPr id="3" name="TextBox 2"/>
+          <p:cNvSpPr txBox="1"/>
+          <p:nvPr/>
+        </p:nvSpPr>
+        <p:spPr>
+          <a:xfrm>
+            <a:off x="400000" y="4723500"/>
+            <a:ext cx="3200000" cy="320000"/>
+          </a:xfrm>
+          <a:prstGeom prst="rect">
+            <a:avLst/>
+          </a:prstGeom>
+          <a:noFill/>
+        </p:spPr>
+        <p:txBody>
+          <a:bodyPr wrap="none">
+            <a:spAutoFit/>
+          </a:bodyPr>
+          <a:lstStyle/>
+          <a:p>
+            <a:r>
+              <a:rPr sz="1000" i="1"/>
+              <a:t>SNAP QC modeling lessons - July 2026</a:t>
+            </a:r>
+          </a:p>
+        </p:txBody>
+      </p:sp>
+      <p:graphicFrame>
+        <p:nvGraphicFramePr>
+          <p:cNvPr id="5" name="Table 4"/>
+          <p:cNvGraphicFramePr>
+            <a:graphicFrameLocks noGrp="1"/>
+          </p:cNvGraphicFramePr>
+          <p:nvPr/>
+        </p:nvGraphicFramePr>
+        <p:xfrm>
+          <a:off x="365760" y="1728216"/>
+          <a:ext cx="8412480" cy="3995928"/>
+        </p:xfrm>
+        <a:graphic>
+          <a:graphicData uri="http://schemas.openxmlformats.org/drawingml/2006/table">
+            <a:tbl>
+              <a:tblPr firstRow="1" bandRow="1">
+                <a:tableStyleId>{5C22544A-7EE6-4342-B048-85BDC9FD1C3A}</a:tableStyleId>
+              </a:tblPr>
+              <a:tblGrid>
+                <a:gridCol w="1201782"/>
+                <a:gridCol w="1201782"/>
+                <a:gridCol w="1201782"/>
+                <a:gridCol w="1201782"/>
+                <a:gridCol w="1201782"/>
+                <a:gridCol w="1201782"/>
+                <a:gridCol w="1201788"/>
+              </a:tblGrid>
+              <a:tr h="210312">
+                <a:tc>
+                  <a:txBody>
+                    <a:bodyPr/>
+                    <a:lstStyle/>
+                    <a:p>
+                      <a:r>
+                        <a:rPr sz="900" b="1"/>
+                        <a:t>state</a:t>
+                      </a:r>
+                    </a:p>
+                  </a:txBody>
+                  <a:tcPr marT="9144" marB="9144"/>
+                </a:tc>
+                <a:tc>
+                  <a:txBody>
+                    <a:bodyPr/>
+                    <a:lstStyle/>
+                    <a:p>
+                      <a:r>
+                        <a:rPr sz="900" b="1"/>
+                        <a:t>regime (5%)</a:t>
+                      </a:r>
+                    </a:p>
+                  </a:txBody>
+                  <a:tcPr marT="9144" marB="9144"/>
+                </a:tc>
+                <a:tc>
+                  <a:txBody>
+                    <a:bodyPr/>
+                    <a:lstStyle/>
+                    <a:p>
+                      <a:r>
+                        <a:rPr sz="900" b="1"/>
+                        <a:t>rules handed (5%)</a:t>
+                      </a:r>
+                    </a:p>
+                  </a:txBody>
+                  <a:tcPr marT="9144" marB="9144"/>
+                </a:tc>
+                <a:tc>
+                  <a:txBody>
+                    <a:bodyPr/>
+                    <a:lstStyle/>
+                    <a:p>
+                      <a:r>
+                        <a:rPr sz="900" b="1"/>
+                        <a:t>typically run (5%)</a:t>
+                      </a:r>
+                    </a:p>
+                  </a:txBody>
+                  <a:tcPr marT="9144" marB="9144"/>
+                </a:tc>
+                <a:tc>
+                  <a:txBody>
+                    <a:bodyPr/>
+                    <a:lstStyle/>
+                    <a:p>
+                      <a:r>
+                        <a:rPr sz="900" b="1"/>
+                        <a:t>regime (10%)</a:t>
+                      </a:r>
+                    </a:p>
+                  </a:txBody>
+                  <a:tcPr marT="9144" marB="9144"/>
+                </a:tc>
+                <a:tc>
+                  <a:txBody>
+                    <a:bodyPr/>
+                    <a:lstStyle/>
+                    <a:p>
+                      <a:r>
+                        <a:rPr sz="900" b="1"/>
+                        <a:t>rules handed (10%)</a:t>
+                      </a:r>
+                    </a:p>
+                  </a:txBody>
+                  <a:tcPr marT="9144" marB="9144"/>
+                </a:tc>
+                <a:tc>
+                  <a:txBody>
+                    <a:bodyPr/>
+                    <a:lstStyle/>
+                    <a:p>
+                      <a:r>
+                        <a:rPr sz="900" b="1"/>
+                        <a:t>typically run (10%)</a:t>
+                      </a:r>
+                    </a:p>
+                  </a:txBody>
+                  <a:tcPr marT="9144" marB="9144"/>
+                </a:tc>
+              </a:tr>
+              <a:tr h="210312">
+                <a:tc>
+                  <a:txBody>
+                    <a:bodyPr/>
+                    <a:lstStyle/>
+                    <a:p>
+                      <a:r>
+                        <a:rPr sz="900" b="0"/>
+                        <a:t>Arizona</a:t>
+                      </a:r>
+                    </a:p>
+                  </a:txBody>
+                  <a:tcPr marT="9144" marB="9144"/>
+                </a:tc>
+                <a:tc>
+                  <a:txBody>
+                    <a:bodyPr/>
+                    <a:lstStyle/>
+                    <a:p>
+                      <a:r>
+                        <a:rPr sz="900" b="0"/>
+                        <a:t>national</a:t>
+                      </a:r>
+                    </a:p>
+                  </a:txBody>
+                  <a:tcPr marT="9144" marB="9144"/>
+                </a:tc>
+                <a:tc>
+                  <a:txBody>
+                    <a:bodyPr/>
+                    <a:lstStyle/>
+                    <a:p>
+                      <a:r>
+                        <a:rPr sz="900" b="0"/>
+                        <a:t>99</a:t>
+                      </a:r>
+                    </a:p>
+                  </a:txBody>
+                  <a:tcPr marT="9144" marB="9144"/>
+                </a:tc>
+                <a:tc>
+                  <a:txBody>
+                    <a:bodyPr/>
+                    <a:lstStyle/>
+                    <a:p>
+                      <a:r>
+                        <a:rPr sz="900" b="0"/>
+                        <a:t>18</a:t>
+                      </a:r>
+                    </a:p>
+                  </a:txBody>
+                  <a:tcPr marT="9144" marB="9144"/>
+                </a:tc>
+                <a:tc>
+                  <a:txBody>
+                    <a:bodyPr/>
+                    <a:lstStyle/>
+                    <a:p>
+                      <a:r>
+                        <a:rPr sz="900" b="0"/>
+                        <a:t>own rules</a:t>
+                      </a:r>
+                    </a:p>
+                  </a:txBody>
+                  <a:tcPr marT="9144" marB="9144"/>
+                </a:tc>
+                <a:tc>
+                  <a:txBody>
+                    <a:bodyPr/>
+                    <a:lstStyle/>
+                    <a:p>
+                      <a:r>
+                        <a:rPr sz="900" b="0"/>
+                        <a:t>147</a:t>
+                      </a:r>
+                    </a:p>
+                  </a:txBody>
+                  <a:tcPr marT="9144" marB="9144"/>
+                </a:tc>
+                <a:tc>
+                  <a:txBody>
+                    <a:bodyPr/>
+                    <a:lstStyle/>
+                    <a:p>
+                      <a:r>
+                        <a:rPr sz="900" b="0"/>
+                        <a:t>29</a:t>
+                      </a:r>
+                    </a:p>
+                  </a:txBody>
+                  <a:tcPr marT="9144" marB="9144"/>
+                </a:tc>
+              </a:tr>
+              <a:tr h="210312">
+                <a:tc>
+                  <a:txBody>
+                    <a:bodyPr/>
+                    <a:lstStyle/>
+                    <a:p>
+                      <a:r>
+                        <a:rPr sz="900" b="0"/>
+                        <a:t>California</a:t>
+                      </a:r>
+                    </a:p>
+                  </a:txBody>
+                  <a:tcPr marT="9144" marB="9144"/>
+                </a:tc>
+                <a:tc>
+                  <a:txBody>
+                    <a:bodyPr/>
+                    <a:lstStyle/>
+                    <a:p>
+                      <a:r>
+                        <a:rPr sz="900" b="0"/>
+                        <a:t>national</a:t>
+                      </a:r>
+                    </a:p>
+                  </a:txBody>
+                  <a:tcPr marT="9144" marB="9144"/>
+                </a:tc>
+                <a:tc>
+                  <a:txBody>
+                    <a:bodyPr/>
+                    <a:lstStyle/>
+                    <a:p>
+                      <a:r>
+                        <a:rPr sz="900" b="0"/>
+                        <a:t>93</a:t>
+                      </a:r>
+                    </a:p>
+                  </a:txBody>
+                  <a:tcPr marT="9144" marB="9144"/>
+                </a:tc>
+                <a:tc>
+                  <a:txBody>
+                    <a:bodyPr/>
+                    <a:lstStyle/>
+                    <a:p>
+                      <a:r>
+                        <a:rPr sz="900" b="0"/>
+                        <a:t>20</a:t>
+                      </a:r>
+                    </a:p>
+                  </a:txBody>
+                  <a:tcPr marT="9144" marB="9144"/>
+                </a:tc>
+                <a:tc>
+                  <a:txBody>
+                    <a:bodyPr/>
+                    <a:lstStyle/>
+                    <a:p>
+                      <a:r>
+                        <a:rPr sz="900" b="0"/>
+                        <a:t>own rules</a:t>
+                      </a:r>
+                    </a:p>
+                  </a:txBody>
+                  <a:tcPr marT="9144" marB="9144"/>
+                </a:tc>
+                <a:tc>
+                  <a:txBody>
+                    <a:bodyPr/>
+                    <a:lstStyle/>
+                    <a:p>
+                      <a:r>
+                        <a:rPr sz="900" b="0"/>
+                        <a:t>81</a:t>
+                      </a:r>
+                    </a:p>
+                  </a:txBody>
+                  <a:tcPr marT="9144" marB="9144"/>
+                </a:tc>
+                <a:tc>
+                  <a:txBody>
+                    <a:bodyPr/>
+                    <a:lstStyle/>
+                    <a:p>
+                      <a:r>
+                        <a:rPr sz="900" b="0"/>
+                        <a:t>14</a:t>
+                      </a:r>
+                    </a:p>
+                  </a:txBody>
+                  <a:tcPr marT="9144" marB="9144"/>
+                </a:tc>
+              </a:tr>
+              <a:tr h="210312">
+                <a:tc>
+                  <a:txBody>
+                    <a:bodyPr/>
+                    <a:lstStyle/>
+                    <a:p>
+                      <a:r>
+                        <a:rPr sz="900" b="0"/>
+                        <a:t>Colorado</a:t>
+                      </a:r>
+                    </a:p>
+                  </a:txBody>
+                  <a:tcPr marT="9144" marB="9144"/>
+                </a:tc>
+                <a:tc>
+                  <a:txBody>
+                    <a:bodyPr/>
+                    <a:lstStyle/>
+                    <a:p>
+                      <a:r>
+                        <a:rPr sz="900" b="0"/>
+                        <a:t>national</a:t>
+                      </a:r>
+                    </a:p>
+                  </a:txBody>
+                  <a:tcPr marT="9144" marB="9144"/>
+                </a:tc>
+                <a:tc>
+                  <a:txBody>
+                    <a:bodyPr/>
+                    <a:lstStyle/>
+                    <a:p>
+                      <a:r>
+                        <a:rPr sz="900" b="0"/>
+                        <a:t>136</a:t>
+                      </a:r>
+                    </a:p>
+                  </a:txBody>
+                  <a:tcPr marT="9144" marB="9144"/>
+                </a:tc>
+                <a:tc>
+                  <a:txBody>
+                    <a:bodyPr/>
+                    <a:lstStyle/>
+                    <a:p>
+                      <a:r>
+                        <a:rPr sz="900" b="0"/>
+                        <a:t>26</a:t>
+                      </a:r>
+                    </a:p>
+                  </a:txBody>
+                  <a:tcPr marT="9144" marB="9144"/>
+                </a:tc>
+                <a:tc>
+                  <a:txBody>
+                    <a:bodyPr/>
+                    <a:lstStyle/>
+                    <a:p>
+                      <a:r>
+                        <a:rPr sz="900" b="0"/>
+                        <a:t>national</a:t>
+                      </a:r>
+                    </a:p>
+                  </a:txBody>
+                  <a:tcPr marT="9144" marB="9144"/>
+                </a:tc>
+                <a:tc>
+                  <a:txBody>
+                    <a:bodyPr/>
+                    <a:lstStyle/>
+                    <a:p>
+                      <a:r>
+                        <a:rPr sz="900" b="0"/>
+                        <a:t>264</a:t>
+                      </a:r>
+                    </a:p>
+                  </a:txBody>
+                  <a:tcPr marT="9144" marB="9144"/>
+                </a:tc>
+                <a:tc>
+                  <a:txBody>
+                    <a:bodyPr/>
+                    <a:lstStyle/>
+                    <a:p>
+                      <a:r>
+                        <a:rPr sz="900" b="0"/>
+                        <a:t>44</a:t>
+                      </a:r>
+                    </a:p>
+                  </a:txBody>
+                  <a:tcPr marT="9144" marB="9144"/>
+                </a:tc>
+              </a:tr>
+              <a:tr h="210312">
+                <a:tc>
+                  <a:txBody>
+                    <a:bodyPr/>
+                    <a:lstStyle/>
+                    <a:p>
+                      <a:r>
+                        <a:rPr sz="900" b="0"/>
+                        <a:t>Connecticut</a:t>
+                      </a:r>
+                    </a:p>
+                  </a:txBody>
+                  <a:tcPr marT="9144" marB="9144"/>
+                </a:tc>
+                <a:tc>
+                  <a:txBody>
+                    <a:bodyPr/>
+                    <a:lstStyle/>
+                    <a:p>
+                      <a:r>
+                        <a:rPr sz="900" b="0"/>
+                        <a:t>own rules</a:t>
+                      </a:r>
+                    </a:p>
+                  </a:txBody>
+                  <a:tcPr marT="9144" marB="9144"/>
+                </a:tc>
+                <a:tc>
+                  <a:txBody>
+                    <a:bodyPr/>
+                    <a:lstStyle/>
+                    <a:p>
+                      <a:r>
+                        <a:rPr sz="900" b="0"/>
+                        <a:t>45</a:t>
+                      </a:r>
+                    </a:p>
+                  </a:txBody>
+                  <a:tcPr marT="9144" marB="9144"/>
+                </a:tc>
+                <a:tc>
+                  <a:txBody>
+                    <a:bodyPr/>
+                    <a:lstStyle/>
+                    <a:p>
+                      <a:r>
+                        <a:rPr sz="900" b="0"/>
+                        <a:t>8</a:t>
+                      </a:r>
+                    </a:p>
+                  </a:txBody>
+                  <a:tcPr marT="9144" marB="9144"/>
+                </a:tc>
+                <a:tc>
+                  <a:txBody>
+                    <a:bodyPr/>
+                    <a:lstStyle/>
+                    <a:p>
+                      <a:r>
+                        <a:rPr sz="900" b="0"/>
+                        <a:t>own rules</a:t>
+                      </a:r>
+                    </a:p>
+                  </a:txBody>
+                  <a:tcPr marT="9144" marB="9144"/>
+                </a:tc>
+                <a:tc>
+                  <a:txBody>
+                    <a:bodyPr/>
+                    <a:lstStyle/>
+                    <a:p>
+                      <a:r>
+                        <a:rPr sz="900" b="0"/>
+                        <a:t>107</a:t>
+                      </a:r>
+                    </a:p>
+                  </a:txBody>
+                  <a:tcPr marT="9144" marB="9144"/>
+                </a:tc>
+                <a:tc>
+                  <a:txBody>
+                    <a:bodyPr/>
+                    <a:lstStyle/>
+                    <a:p>
+                      <a:r>
+                        <a:rPr sz="900" b="0"/>
+                        <a:t>17</a:t>
+                      </a:r>
+                    </a:p>
+                  </a:txBody>
+                  <a:tcPr marT="9144" marB="9144"/>
+                </a:tc>
+              </a:tr>
+              <a:tr h="210312">
+                <a:tc>
+                  <a:txBody>
+                    <a:bodyPr/>
+                    <a:lstStyle/>
+                    <a:p>
+                      <a:r>
+                        <a:rPr sz="900" b="0"/>
+                        <a:t>District of Columbia</a:t>
+                      </a:r>
+                    </a:p>
+                  </a:txBody>
+                  <a:tcPr marT="9144" marB="9144"/>
+                </a:tc>
+                <a:tc>
+                  <a:txBody>
+                    <a:bodyPr/>
+                    <a:lstStyle/>
+                    <a:p>
+                      <a:r>
+                        <a:rPr sz="900" b="0"/>
+                        <a:t>own rules</a:t>
+                      </a:r>
+                    </a:p>
+                  </a:txBody>
+                  <a:tcPr marT="9144" marB="9144"/>
+                </a:tc>
+                <a:tc>
+                  <a:txBody>
+                    <a:bodyPr/>
+                    <a:lstStyle/>
+                    <a:p>
+                      <a:r>
+                        <a:rPr sz="900" b="0"/>
+                        <a:t>31</a:t>
+                      </a:r>
+                    </a:p>
+                  </a:txBody>
+                  <a:tcPr marT="9144" marB="9144"/>
+                </a:tc>
+                <a:tc>
+                  <a:txBody>
+                    <a:bodyPr/>
+                    <a:lstStyle/>
+                    <a:p>
+                      <a:r>
+                        <a:rPr sz="900" b="0"/>
+                        <a:t>5</a:t>
+                      </a:r>
+                    </a:p>
+                  </a:txBody>
+                  <a:tcPr marT="9144" marB="9144"/>
+                </a:tc>
+                <a:tc>
+                  <a:txBody>
+                    <a:bodyPr/>
+                    <a:lstStyle/>
+                    <a:p>
+                      <a:r>
+                        <a:rPr sz="900" b="0"/>
+                        <a:t>own rules</a:t>
+                      </a:r>
+                    </a:p>
+                  </a:txBody>
+                  <a:tcPr marT="9144" marB="9144"/>
+                </a:tc>
+                <a:tc>
+                  <a:txBody>
+                    <a:bodyPr/>
+                    <a:lstStyle/>
+                    <a:p>
+                      <a:r>
+                        <a:rPr sz="900" b="0"/>
+                        <a:t>66</a:t>
+                      </a:r>
+                    </a:p>
+                  </a:txBody>
+                  <a:tcPr marT="9144" marB="9144"/>
+                </a:tc>
+                <a:tc>
+                  <a:txBody>
+                    <a:bodyPr/>
+                    <a:lstStyle/>
+                    <a:p>
+                      <a:r>
+                        <a:rPr sz="900" b="0"/>
+                        <a:t>19</a:t>
+                      </a:r>
+                    </a:p>
+                  </a:txBody>
+                  <a:tcPr marT="9144" marB="9144"/>
+                </a:tc>
+              </a:tr>
+              <a:tr h="210312">
+                <a:tc>
+                  <a:txBody>
+                    <a:bodyPr/>
+                    <a:lstStyle/>
+                    <a:p>
+                      <a:r>
+                        <a:rPr sz="900" b="0"/>
+                        <a:t>Louisiana</a:t>
+                      </a:r>
+                    </a:p>
+                  </a:txBody>
+                  <a:tcPr marT="9144" marB="9144"/>
+                </a:tc>
+                <a:tc>
+                  <a:txBody>
+                    <a:bodyPr/>
+                    <a:lstStyle/>
+                    <a:p>
+                      <a:r>
+                        <a:rPr sz="900" b="0"/>
+                        <a:t>national</a:t>
+                      </a:r>
+                    </a:p>
+                  </a:txBody>
+                  <a:tcPr marT="9144" marB="9144"/>
+                </a:tc>
+                <a:tc>
+                  <a:txBody>
+                    <a:bodyPr/>
+                    <a:lstStyle/>
+                    <a:p>
+                      <a:r>
+                        <a:rPr sz="900" b="0"/>
+                        <a:t>112</a:t>
+                      </a:r>
+                    </a:p>
+                  </a:txBody>
+                  <a:tcPr marT="9144" marB="9144"/>
+                </a:tc>
+                <a:tc>
+                  <a:txBody>
+                    <a:bodyPr/>
+                    <a:lstStyle/>
+                    <a:p>
+                      <a:r>
+                        <a:rPr sz="900" b="0"/>
+                        <a:t>23</a:t>
+                      </a:r>
+                    </a:p>
+                  </a:txBody>
+                  <a:tcPr marT="9144" marB="9144"/>
+                </a:tc>
+                <a:tc>
+                  <a:txBody>
+                    <a:bodyPr/>
+                    <a:lstStyle/>
+                    <a:p>
+                      <a:r>
+                        <a:rPr sz="900" b="0"/>
+                        <a:t>national</a:t>
+                      </a:r>
+                    </a:p>
+                  </a:txBody>
+                  <a:tcPr marT="9144" marB="9144"/>
+                </a:tc>
+                <a:tc>
+                  <a:txBody>
+                    <a:bodyPr/>
+                    <a:lstStyle/>
+                    <a:p>
+                      <a:r>
+                        <a:rPr sz="900" b="0"/>
+                        <a:t>223</a:t>
+                      </a:r>
+                    </a:p>
+                  </a:txBody>
+                  <a:tcPr marT="9144" marB="9144"/>
+                </a:tc>
+                <a:tc>
+                  <a:txBody>
+                    <a:bodyPr/>
+                    <a:lstStyle/>
+                    <a:p>
+                      <a:r>
+                        <a:rPr sz="900" b="0"/>
+                        <a:t>42</a:t>
+                      </a:r>
+                    </a:p>
+                  </a:txBody>
+                  <a:tcPr marT="9144" marB="9144"/>
+                </a:tc>
+              </a:tr>
+              <a:tr h="210312">
+                <a:tc>
+                  <a:txBody>
+                    <a:bodyPr/>
+                    <a:lstStyle/>
+                    <a:p>
+                      <a:r>
+                        <a:rPr sz="900" b="0"/>
+                        <a:t>Maine</a:t>
+                      </a:r>
+                    </a:p>
+                  </a:txBody>
+                  <a:tcPr marT="9144" marB="9144"/>
+                </a:tc>
+                <a:tc>
+                  <a:txBody>
+                    <a:bodyPr/>
+                    <a:lstStyle/>
+                    <a:p>
+                      <a:r>
+                        <a:rPr sz="900" b="0"/>
+                        <a:t>own rules</a:t>
+                      </a:r>
+                    </a:p>
+                  </a:txBody>
+                  <a:tcPr marT="9144" marB="9144"/>
+                </a:tc>
+                <a:tc>
+                  <a:txBody>
+                    <a:bodyPr/>
+                    <a:lstStyle/>
+                    <a:p>
+                      <a:r>
+                        <a:rPr sz="900" b="0"/>
+                        <a:t>58</a:t>
+                      </a:r>
+                    </a:p>
+                  </a:txBody>
+                  <a:tcPr marT="9144" marB="9144"/>
+                </a:tc>
+                <a:tc>
+                  <a:txBody>
+                    <a:bodyPr/>
+                    <a:lstStyle/>
+                    <a:p>
+                      <a:r>
+                        <a:rPr sz="900" b="0"/>
+                        <a:t>7</a:t>
+                      </a:r>
+                    </a:p>
+                  </a:txBody>
+                  <a:tcPr marT="9144" marB="9144"/>
+                </a:tc>
+                <a:tc>
+                  <a:txBody>
+                    <a:bodyPr/>
+                    <a:lstStyle/>
+                    <a:p>
+                      <a:r>
+                        <a:rPr sz="900" b="0"/>
+                        <a:t>national</a:t>
+                      </a:r>
+                    </a:p>
+                  </a:txBody>
+                  <a:tcPr marT="9144" marB="9144"/>
+                </a:tc>
+                <a:tc>
+                  <a:txBody>
+                    <a:bodyPr/>
+                    <a:lstStyle/>
+                    <a:p>
+                      <a:r>
+                        <a:rPr sz="900" b="0"/>
+                        <a:t>276</a:t>
+                      </a:r>
+                    </a:p>
+                  </a:txBody>
+                  <a:tcPr marT="9144" marB="9144"/>
+                </a:tc>
+                <a:tc>
+                  <a:txBody>
+                    <a:bodyPr/>
+                    <a:lstStyle/>
+                    <a:p>
+                      <a:r>
+                        <a:rPr sz="900" b="0"/>
+                        <a:t>42</a:t>
+                      </a:r>
+                    </a:p>
+                  </a:txBody>
+                  <a:tcPr marT="9144" marB="9144"/>
+                </a:tc>
+              </a:tr>
+              <a:tr h="210312">
+                <a:tc>
+                  <a:txBody>
+                    <a:bodyPr/>
+                    <a:lstStyle/>
+                    <a:p>
+                      <a:r>
+                        <a:rPr sz="900" b="0"/>
+                        <a:t>Maryland</a:t>
+                      </a:r>
+                    </a:p>
+                  </a:txBody>
+                  <a:tcPr marT="9144" marB="9144"/>
+                </a:tc>
+                <a:tc>
+                  <a:txBody>
+                    <a:bodyPr/>
+                    <a:lstStyle/>
+                    <a:p>
+                      <a:r>
+                        <a:rPr sz="900" b="0"/>
+                        <a:t>own rules</a:t>
+                      </a:r>
+                    </a:p>
+                  </a:txBody>
+                  <a:tcPr marT="9144" marB="9144"/>
+                </a:tc>
+                <a:tc>
+                  <a:txBody>
+                    <a:bodyPr/>
+                    <a:lstStyle/>
+                    <a:p>
+                      <a:r>
+                        <a:rPr sz="900" b="0"/>
+                        <a:t>13</a:t>
+                      </a:r>
+                    </a:p>
+                  </a:txBody>
+                  <a:tcPr marT="9144" marB="9144"/>
+                </a:tc>
+                <a:tc>
+                  <a:txBody>
+                    <a:bodyPr/>
+                    <a:lstStyle/>
+                    <a:p>
+                      <a:r>
+                        <a:rPr sz="900" b="0"/>
+                        <a:t>4</a:t>
+                      </a:r>
+                    </a:p>
+                  </a:txBody>
+                  <a:tcPr marT="9144" marB="9144"/>
+                </a:tc>
+                <a:tc>
+                  <a:txBody>
+                    <a:bodyPr/>
+                    <a:lstStyle/>
+                    <a:p>
+                      <a:r>
+                        <a:rPr sz="900" b="0"/>
+                        <a:t>own rules</a:t>
+                      </a:r>
+                    </a:p>
+                  </a:txBody>
+                  <a:tcPr marT="9144" marB="9144"/>
+                </a:tc>
+                <a:tc>
+                  <a:txBody>
+                    <a:bodyPr/>
+                    <a:lstStyle/>
+                    <a:p>
+                      <a:r>
+                        <a:rPr sz="900" b="0"/>
+                        <a:t>72</a:t>
+                      </a:r>
+                    </a:p>
+                  </a:txBody>
+                  <a:tcPr marT="9144" marB="9144"/>
+                </a:tc>
+                <a:tc>
+                  <a:txBody>
+                    <a:bodyPr/>
+                    <a:lstStyle/>
+                    <a:p>
+                      <a:r>
+                        <a:rPr sz="900" b="0"/>
+                        <a:t>8</a:t>
+                      </a:r>
+                    </a:p>
+                  </a:txBody>
+                  <a:tcPr marT="9144" marB="9144"/>
+                </a:tc>
+              </a:tr>
+              <a:tr h="210312">
+                <a:tc>
+                  <a:txBody>
+                    <a:bodyPr/>
+                    <a:lstStyle/>
+                    <a:p>
+                      <a:r>
+                        <a:rPr sz="900" b="0"/>
+                        <a:t>Massachusetts</a:t>
+                      </a:r>
+                    </a:p>
+                  </a:txBody>
+                  <a:tcPr marT="9144" marB="9144"/>
+                </a:tc>
+                <a:tc>
+                  <a:txBody>
+                    <a:bodyPr/>
+                    <a:lstStyle/>
+                    <a:p>
+                      <a:r>
+                        <a:rPr sz="900" b="0"/>
+                        <a:t>national</a:t>
+                      </a:r>
+                    </a:p>
+                  </a:txBody>
+                  <a:tcPr marT="9144" marB="9144"/>
+                </a:tc>
+                <a:tc>
+                  <a:txBody>
+                    <a:bodyPr/>
+                    <a:lstStyle/>
+                    <a:p>
+                      <a:r>
+                        <a:rPr sz="900" b="0"/>
+                        <a:t>137</a:t>
+                      </a:r>
+                    </a:p>
+                  </a:txBody>
+                  <a:tcPr marT="9144" marB="9144"/>
+                </a:tc>
+                <a:tc>
+                  <a:txBody>
+                    <a:bodyPr/>
+                    <a:lstStyle/>
+                    <a:p>
+                      <a:r>
+                        <a:rPr sz="900" b="0"/>
+                        <a:t>20</a:t>
+                      </a:r>
+                    </a:p>
+                  </a:txBody>
+                  <a:tcPr marT="9144" marB="9144"/>
+                </a:tc>
+                <a:tc>
+                  <a:txBody>
+                    <a:bodyPr/>
+                    <a:lstStyle/>
+                    <a:p>
+                      <a:r>
+                        <a:rPr sz="900" b="0"/>
+                        <a:t>national</a:t>
+                      </a:r>
+                    </a:p>
+                  </a:txBody>
+                  <a:tcPr marT="9144" marB="9144"/>
+                </a:tc>
+                <a:tc>
+                  <a:txBody>
+                    <a:bodyPr/>
+                    <a:lstStyle/>
+                    <a:p>
+                      <a:r>
+                        <a:rPr sz="900" b="0"/>
+                        <a:t>262</a:t>
+                      </a:r>
+                    </a:p>
+                  </a:txBody>
+                  <a:tcPr marT="9144" marB="9144"/>
+                </a:tc>
+                <a:tc>
+                  <a:txBody>
+                    <a:bodyPr/>
+                    <a:lstStyle/>
+                    <a:p>
+                      <a:r>
+                        <a:rPr sz="900" b="0"/>
+                        <a:t>38</a:t>
+                      </a:r>
+                    </a:p>
+                  </a:txBody>
+                  <a:tcPr marT="9144" marB="9144"/>
+                </a:tc>
+              </a:tr>
+              <a:tr h="210312">
+                <a:tc>
+                  <a:txBody>
+                    <a:bodyPr/>
+                    <a:lstStyle/>
+                    <a:p>
+                      <a:r>
+                        <a:rPr sz="900" b="0"/>
+                        <a:t>Michigan</a:t>
+                      </a:r>
+                    </a:p>
+                  </a:txBody>
+                  <a:tcPr marT="9144" marB="9144"/>
+                </a:tc>
+                <a:tc>
+                  <a:txBody>
+                    <a:bodyPr/>
+                    <a:lstStyle/>
+                    <a:p>
+                      <a:r>
+                        <a:rPr sz="900" b="0"/>
+                        <a:t>national</a:t>
+                      </a:r>
+                    </a:p>
+                  </a:txBody>
+                  <a:tcPr marT="9144" marB="9144"/>
+                </a:tc>
+                <a:tc>
+                  <a:txBody>
+                    <a:bodyPr/>
+                    <a:lstStyle/>
+                    <a:p>
+                      <a:r>
+                        <a:rPr sz="900" b="0"/>
+                        <a:t>125</a:t>
+                      </a:r>
+                    </a:p>
+                  </a:txBody>
+                  <a:tcPr marT="9144" marB="9144"/>
+                </a:tc>
+                <a:tc>
+                  <a:txBody>
+                    <a:bodyPr/>
+                    <a:lstStyle/>
+                    <a:p>
+                      <a:r>
+                        <a:rPr sz="900" b="0"/>
+                        <a:t>25</a:t>
+                      </a:r>
+                    </a:p>
+                  </a:txBody>
+                  <a:tcPr marT="9144" marB="9144"/>
+                </a:tc>
+                <a:tc>
+                  <a:txBody>
+                    <a:bodyPr/>
+                    <a:lstStyle/>
+                    <a:p>
+                      <a:r>
+                        <a:rPr sz="900" b="0"/>
+                        <a:t>national</a:t>
+                      </a:r>
+                    </a:p>
+                  </a:txBody>
+                  <a:tcPr marT="9144" marB="9144"/>
+                </a:tc>
+                <a:tc>
+                  <a:txBody>
+                    <a:bodyPr/>
+                    <a:lstStyle/>
+                    <a:p>
+                      <a:r>
+                        <a:rPr sz="900" b="0"/>
+                        <a:t>238</a:t>
+                      </a:r>
+                    </a:p>
+                  </a:txBody>
+                  <a:tcPr marT="9144" marB="9144"/>
+                </a:tc>
+                <a:tc>
+                  <a:txBody>
+                    <a:bodyPr/>
+                    <a:lstStyle/>
+                    <a:p>
+                      <a:r>
+                        <a:rPr sz="900" b="0"/>
+                        <a:t>42</a:t>
+                      </a:r>
+                    </a:p>
+                  </a:txBody>
+                  <a:tcPr marT="9144" marB="9144"/>
+                </a:tc>
+              </a:tr>
+              <a:tr h="210312">
+                <a:tc>
+                  <a:txBody>
+                    <a:bodyPr/>
+                    <a:lstStyle/>
+                    <a:p>
+                      <a:r>
+                        <a:rPr sz="900" b="0"/>
+                        <a:t>Mississippi</a:t>
+                      </a:r>
+                    </a:p>
+                  </a:txBody>
+                  <a:tcPr marT="9144" marB="9144"/>
+                </a:tc>
+                <a:tc>
+                  <a:txBody>
+                    <a:bodyPr/>
+                    <a:lstStyle/>
+                    <a:p>
+                      <a:r>
+                        <a:rPr sz="900" b="0"/>
+                        <a:t>own rules</a:t>
+                      </a:r>
+                    </a:p>
+                  </a:txBody>
+                  <a:tcPr marT="9144" marB="9144"/>
+                </a:tc>
+                <a:tc>
+                  <a:txBody>
+                    <a:bodyPr/>
+                    <a:lstStyle/>
+                    <a:p>
+                      <a:r>
+                        <a:rPr sz="900" b="0"/>
+                        <a:t>43</a:t>
+                      </a:r>
+                    </a:p>
+                  </a:txBody>
+                  <a:tcPr marT="9144" marB="9144"/>
+                </a:tc>
+                <a:tc>
+                  <a:txBody>
+                    <a:bodyPr/>
+                    <a:lstStyle/>
+                    <a:p>
+                      <a:r>
+                        <a:rPr sz="900" b="0"/>
+                        <a:t>6</a:t>
+                      </a:r>
+                    </a:p>
+                  </a:txBody>
+                  <a:tcPr marT="9144" marB="9144"/>
+                </a:tc>
+                <a:tc>
+                  <a:txBody>
+                    <a:bodyPr/>
+                    <a:lstStyle/>
+                    <a:p>
+                      <a:r>
+                        <a:rPr sz="900" b="0"/>
+                        <a:t>own rules</a:t>
+                      </a:r>
+                    </a:p>
+                  </a:txBody>
+                  <a:tcPr marT="9144" marB="9144"/>
+                </a:tc>
+                <a:tc>
+                  <a:txBody>
+                    <a:bodyPr/>
+                    <a:lstStyle/>
+                    <a:p>
+                      <a:r>
+                        <a:rPr sz="900" b="0"/>
+                        <a:t>107</a:t>
+                      </a:r>
+                    </a:p>
+                  </a:txBody>
+                  <a:tcPr marT="9144" marB="9144"/>
+                </a:tc>
+                <a:tc>
+                  <a:txBody>
+                    <a:bodyPr/>
+                    <a:lstStyle/>
+                    <a:p>
+                      <a:r>
+                        <a:rPr sz="900" b="0"/>
+                        <a:t>20</a:t>
+                      </a:r>
+                    </a:p>
+                  </a:txBody>
+                  <a:tcPr marT="9144" marB="9144"/>
+                </a:tc>
+              </a:tr>
+              <a:tr h="210312">
+                <a:tc>
+                  <a:txBody>
+                    <a:bodyPr/>
+                    <a:lstStyle/>
+                    <a:p>
+                      <a:r>
+                        <a:rPr sz="900" b="0"/>
+                        <a:t>Missouri</a:t>
+                      </a:r>
+                    </a:p>
+                  </a:txBody>
+                  <a:tcPr marT="9144" marB="9144"/>
+                </a:tc>
+                <a:tc>
+                  <a:txBody>
+                    <a:bodyPr/>
+                    <a:lstStyle/>
+                    <a:p>
+                      <a:r>
+                        <a:rPr sz="900" b="0"/>
+                        <a:t>national</a:t>
+                      </a:r>
+                    </a:p>
+                  </a:txBody>
+                  <a:tcPr marT="9144" marB="9144"/>
+                </a:tc>
+                <a:tc>
+                  <a:txBody>
+                    <a:bodyPr/>
+                    <a:lstStyle/>
+                    <a:p>
+                      <a:r>
+                        <a:rPr sz="900" b="0"/>
+                        <a:t>107</a:t>
+                      </a:r>
+                    </a:p>
+                  </a:txBody>
+                  <a:tcPr marT="9144" marB="9144"/>
+                </a:tc>
+                <a:tc>
+                  <a:txBody>
+                    <a:bodyPr/>
+                    <a:lstStyle/>
+                    <a:p>
+                      <a:r>
+                        <a:rPr sz="900" b="0"/>
+                        <a:t>23</a:t>
+                      </a:r>
+                    </a:p>
+                  </a:txBody>
+                  <a:tcPr marT="9144" marB="9144"/>
+                </a:tc>
+                <a:tc>
+                  <a:txBody>
+                    <a:bodyPr/>
+                    <a:lstStyle/>
+                    <a:p>
+                      <a:r>
+                        <a:rPr sz="900" b="0"/>
+                        <a:t>national</a:t>
+                      </a:r>
+                    </a:p>
+                  </a:txBody>
+                  <a:tcPr marT="9144" marB="9144"/>
+                </a:tc>
+                <a:tc>
+                  <a:txBody>
+                    <a:bodyPr/>
+                    <a:lstStyle/>
+                    <a:p>
+                      <a:r>
+                        <a:rPr sz="900" b="0"/>
+                        <a:t>203</a:t>
+                      </a:r>
+                    </a:p>
+                  </a:txBody>
+                  <a:tcPr marT="9144" marB="9144"/>
+                </a:tc>
+                <a:tc>
+                  <a:txBody>
+                    <a:bodyPr/>
+                    <a:lstStyle/>
+                    <a:p>
+                      <a:r>
+                        <a:rPr sz="900" b="0"/>
+                        <a:t>44</a:t>
+                      </a:r>
+                    </a:p>
+                  </a:txBody>
+                  <a:tcPr marT="9144" marB="9144"/>
+                </a:tc>
+              </a:tr>
+              <a:tr h="210312">
+                <a:tc>
+                  <a:txBody>
+                    <a:bodyPr/>
+                    <a:lstStyle/>
+                    <a:p>
+                      <a:r>
+                        <a:rPr sz="900" b="0"/>
+                        <a:t>New Jersey</a:t>
+                      </a:r>
+                    </a:p>
+                  </a:txBody>
+                  <a:tcPr marT="9144" marB="9144"/>
+                </a:tc>
+                <a:tc>
+                  <a:txBody>
+                    <a:bodyPr/>
+                    <a:lstStyle/>
+                    <a:p>
+                      <a:r>
+                        <a:rPr sz="900" b="0"/>
+                        <a:t>own rules</a:t>
+                      </a:r>
+                    </a:p>
+                  </a:txBody>
+                  <a:tcPr marT="9144" marB="9144"/>
+                </a:tc>
+                <a:tc>
+                  <a:txBody>
+                    <a:bodyPr/>
+                    <a:lstStyle/>
+                    <a:p>
+                      <a:r>
+                        <a:rPr sz="900" b="0"/>
+                        <a:t>20</a:t>
+                      </a:r>
+                    </a:p>
+                  </a:txBody>
+                  <a:tcPr marT="9144" marB="9144"/>
+                </a:tc>
+                <a:tc>
+                  <a:txBody>
+                    <a:bodyPr/>
+                    <a:lstStyle/>
+                    <a:p>
+                      <a:r>
+                        <a:rPr sz="900" b="0"/>
+                        <a:t>2</a:t>
+                      </a:r>
+                    </a:p>
+                  </a:txBody>
+                  <a:tcPr marT="9144" marB="9144"/>
+                </a:tc>
+                <a:tc>
+                  <a:txBody>
+                    <a:bodyPr/>
+                    <a:lstStyle/>
+                    <a:p>
+                      <a:r>
+                        <a:rPr sz="900" b="0"/>
+                        <a:t>own rules</a:t>
+                      </a:r>
+                    </a:p>
+                  </a:txBody>
+                  <a:tcPr marT="9144" marB="9144"/>
+                </a:tc>
+                <a:tc>
+                  <a:txBody>
+                    <a:bodyPr/>
+                    <a:lstStyle/>
+                    <a:p>
+                      <a:r>
+                        <a:rPr sz="900" b="0"/>
+                        <a:t>72</a:t>
+                      </a:r>
+                    </a:p>
+                  </a:txBody>
+                  <a:tcPr marT="9144" marB="9144"/>
+                </a:tc>
+                <a:tc>
+                  <a:txBody>
+                    <a:bodyPr/>
+                    <a:lstStyle/>
+                    <a:p>
+                      <a:r>
+                        <a:rPr sz="900" b="0"/>
+                        <a:t>4</a:t>
+                      </a:r>
+                    </a:p>
+                  </a:txBody>
+                  <a:tcPr marT="9144" marB="9144"/>
+                </a:tc>
+              </a:tr>
+              <a:tr h="210312">
+                <a:tc>
+                  <a:txBody>
+                    <a:bodyPr/>
+                    <a:lstStyle/>
+                    <a:p>
+                      <a:r>
+                        <a:rPr sz="900" b="0"/>
+                        <a:t>North Carolina</a:t>
+                      </a:r>
+                    </a:p>
+                  </a:txBody>
+                  <a:tcPr marT="9144" marB="9144"/>
+                </a:tc>
+                <a:tc>
+                  <a:txBody>
+                    <a:bodyPr/>
+                    <a:lstStyle/>
+                    <a:p>
+                      <a:r>
+                        <a:rPr sz="900" b="0"/>
+                        <a:t>national</a:t>
+                      </a:r>
+                    </a:p>
+                  </a:txBody>
+                  <a:tcPr marT="9144" marB="9144"/>
+                </a:tc>
+                <a:tc>
+                  <a:txBody>
+                    <a:bodyPr/>
+                    <a:lstStyle/>
+                    <a:p>
+                      <a:r>
+                        <a:rPr sz="900" b="0"/>
+                        <a:t>148</a:t>
+                      </a:r>
+                    </a:p>
+                  </a:txBody>
+                  <a:tcPr marT="9144" marB="9144"/>
+                </a:tc>
+                <a:tc>
+                  <a:txBody>
+                    <a:bodyPr/>
+                    <a:lstStyle/>
+                    <a:p>
+                      <a:r>
+                        <a:rPr sz="900" b="0"/>
+                        <a:t>27</a:t>
+                      </a:r>
+                    </a:p>
+                  </a:txBody>
+                  <a:tcPr marT="9144" marB="9144"/>
+                </a:tc>
+                <a:tc>
+                  <a:txBody>
+                    <a:bodyPr/>
+                    <a:lstStyle/>
+                    <a:p>
+                      <a:r>
+                        <a:rPr sz="900" b="0"/>
+                        <a:t>own rules</a:t>
+                      </a:r>
+                    </a:p>
+                  </a:txBody>
+                  <a:tcPr marT="9144" marB="9144"/>
+                </a:tc>
+                <a:tc>
+                  <a:txBody>
+                    <a:bodyPr/>
+                    <a:lstStyle/>
+                    <a:p>
+                      <a:r>
+                        <a:rPr sz="900" b="0"/>
+                        <a:t>70</a:t>
+                      </a:r>
+                    </a:p>
+                  </a:txBody>
+                  <a:tcPr marT="9144" marB="9144"/>
+                </a:tc>
+                <a:tc>
+                  <a:txBody>
+                    <a:bodyPr/>
+                    <a:lstStyle/>
+                    <a:p>
+                      <a:r>
+                        <a:rPr sz="900" b="0"/>
+                        <a:t>12</a:t>
+                      </a:r>
+                    </a:p>
+                  </a:txBody>
+                  <a:tcPr marT="9144" marB="9144"/>
+                </a:tc>
+              </a:tr>
+              <a:tr h="210312">
+                <a:tc>
+                  <a:txBody>
+                    <a:bodyPr/>
+                    <a:lstStyle/>
+                    <a:p>
+                      <a:r>
+                        <a:rPr sz="900" b="0"/>
+                        <a:t>Tennessee</a:t>
+                      </a:r>
+                    </a:p>
+                  </a:txBody>
+                  <a:tcPr marT="9144" marB="9144"/>
+                </a:tc>
+                <a:tc>
+                  <a:txBody>
+                    <a:bodyPr/>
+                    <a:lstStyle/>
+                    <a:p>
+                      <a:r>
+                        <a:rPr sz="900" b="0"/>
+                        <a:t>national</a:t>
+                      </a:r>
+                    </a:p>
+                  </a:txBody>
+                  <a:tcPr marT="9144" marB="9144"/>
+                </a:tc>
+                <a:tc>
+                  <a:txBody>
+                    <a:bodyPr/>
+                    <a:lstStyle/>
+                    <a:p>
+                      <a:r>
+                        <a:rPr sz="900" b="0"/>
+                        <a:t>143</a:t>
+                      </a:r>
+                    </a:p>
+                  </a:txBody>
+                  <a:tcPr marT="9144" marB="9144"/>
+                </a:tc>
+                <a:tc>
+                  <a:txBody>
+                    <a:bodyPr/>
+                    <a:lstStyle/>
+                    <a:p>
+                      <a:r>
+                        <a:rPr sz="900" b="0"/>
+                        <a:t>26</a:t>
+                      </a:r>
+                    </a:p>
+                  </a:txBody>
+                  <a:tcPr marT="9144" marB="9144"/>
+                </a:tc>
+                <a:tc>
+                  <a:txBody>
+                    <a:bodyPr/>
+                    <a:lstStyle/>
+                    <a:p>
+                      <a:r>
+                        <a:rPr sz="900" b="0"/>
+                        <a:t>national</a:t>
+                      </a:r>
+                    </a:p>
+                  </a:txBody>
+                  <a:tcPr marT="9144" marB="9144"/>
+                </a:tc>
+                <a:tc>
+                  <a:txBody>
+                    <a:bodyPr/>
+                    <a:lstStyle/>
+                    <a:p>
+                      <a:r>
+                        <a:rPr sz="900" b="0"/>
+                        <a:t>281</a:t>
+                      </a:r>
+                    </a:p>
+                  </a:txBody>
+                  <a:tcPr marT="9144" marB="9144"/>
+                </a:tc>
+                <a:tc>
+                  <a:txBody>
+                    <a:bodyPr/>
+                    <a:lstStyle/>
+                    <a:p>
+                      <a:r>
+                        <a:rPr sz="900" b="0"/>
+                        <a:t>49</a:t>
+                      </a:r>
+                    </a:p>
+                  </a:txBody>
+                  <a:tcPr marT="9144" marB="9144"/>
+                </a:tc>
+              </a:tr>
+              <a:tr h="210312">
+                <a:tc>
+                  <a:txBody>
+                    <a:bodyPr/>
+                    <a:lstStyle/>
+                    <a:p>
+                      <a:r>
+                        <a:rPr sz="900" b="0"/>
+                        <a:t>Texas</a:t>
+                      </a:r>
+                    </a:p>
+                  </a:txBody>
+                  <a:tcPr marT="9144" marB="9144"/>
+                </a:tc>
+                <a:tc>
+                  <a:txBody>
+                    <a:bodyPr/>
+                    <a:lstStyle/>
+                    <a:p>
+                      <a:r>
+                        <a:rPr sz="900" b="0"/>
+                        <a:t>own rules</a:t>
+                      </a:r>
+                    </a:p>
+                  </a:txBody>
+                  <a:tcPr marT="9144" marB="9144"/>
+                </a:tc>
+                <a:tc>
+                  <a:txBody>
+                    <a:bodyPr/>
+                    <a:lstStyle/>
+                    <a:p>
+                      <a:r>
+                        <a:rPr sz="900" b="0"/>
+                        <a:t>50</a:t>
+                      </a:r>
+                    </a:p>
+                  </a:txBody>
+                  <a:tcPr marT="9144" marB="9144"/>
+                </a:tc>
+                <a:tc>
+                  <a:txBody>
+                    <a:bodyPr/>
+                    <a:lstStyle/>
+                    <a:p>
+                      <a:r>
+                        <a:rPr sz="900" b="0"/>
+                        <a:t>2</a:t>
+                      </a:r>
+                    </a:p>
+                  </a:txBody>
+                  <a:tcPr marT="9144" marB="9144"/>
+                </a:tc>
+                <a:tc>
+                  <a:txBody>
+                    <a:bodyPr/>
+                    <a:lstStyle/>
+                    <a:p>
+                      <a:r>
+                        <a:rPr sz="900" b="0"/>
+                        <a:t>own rules</a:t>
+                      </a:r>
+                    </a:p>
+                  </a:txBody>
+                  <a:tcPr marT="9144" marB="9144"/>
+                </a:tc>
+                <a:tc>
+                  <a:txBody>
+                    <a:bodyPr/>
+                    <a:lstStyle/>
+                    <a:p>
+                      <a:r>
+                        <a:rPr sz="900" b="0"/>
+                        <a:t>102</a:t>
+                      </a:r>
+                    </a:p>
+                  </a:txBody>
+                  <a:tcPr marT="9144" marB="9144"/>
+                </a:tc>
+                <a:tc>
+                  <a:txBody>
+                    <a:bodyPr/>
+                    <a:lstStyle/>
+                    <a:p>
+                      <a:r>
+                        <a:rPr sz="900" b="0"/>
+                        <a:t>10</a:t>
+                      </a:r>
+                    </a:p>
+                  </a:txBody>
+                  <a:tcPr marT="9144" marB="9144"/>
+                </a:tc>
+              </a:tr>
+              <a:tr h="210312">
+                <a:tc>
+                  <a:txBody>
+                    <a:bodyPr/>
+                    <a:lstStyle/>
+                    <a:p>
+                      <a:r>
+                        <a:rPr sz="900" b="0"/>
+                        <a:t>Virginia</a:t>
+                      </a:r>
+                    </a:p>
+                  </a:txBody>
+                  <a:tcPr marT="9144" marB="9144"/>
+                </a:tc>
+                <a:tc>
+                  <a:txBody>
+                    <a:bodyPr/>
+                    <a:lstStyle/>
+                    <a:p>
+                      <a:r>
+                        <a:rPr sz="900" b="0"/>
+                        <a:t>national</a:t>
+                      </a:r>
+                    </a:p>
+                  </a:txBody>
+                  <a:tcPr marT="9144" marB="9144"/>
+                </a:tc>
+                <a:tc>
+                  <a:txBody>
+                    <a:bodyPr/>
+                    <a:lstStyle/>
+                    <a:p>
+                      <a:r>
+                        <a:rPr sz="900" b="0"/>
+                        <a:t>90</a:t>
+                      </a:r>
+                    </a:p>
+                  </a:txBody>
+                  <a:tcPr marT="9144" marB="9144"/>
+                </a:tc>
+                <a:tc>
+                  <a:txBody>
+                    <a:bodyPr/>
+                    <a:lstStyle/>
+                    <a:p>
+                      <a:r>
+                        <a:rPr sz="900" b="0"/>
+                        <a:t>23</a:t>
+                      </a:r>
+                    </a:p>
+                  </a:txBody>
+                  <a:tcPr marT="9144" marB="9144"/>
+                </a:tc>
+                <a:tc>
+                  <a:txBody>
+                    <a:bodyPr/>
+                    <a:lstStyle/>
+                    <a:p>
+                      <a:r>
+                        <a:rPr sz="900" b="0"/>
+                        <a:t>own rules</a:t>
+                      </a:r>
+                    </a:p>
+                  </a:txBody>
+                  <a:tcPr marT="9144" marB="9144"/>
+                </a:tc>
+                <a:tc>
+                  <a:txBody>
+                    <a:bodyPr/>
+                    <a:lstStyle/>
+                    <a:p>
+                      <a:r>
+                        <a:rPr sz="900" b="0"/>
+                        <a:t>50</a:t>
+                      </a:r>
+                    </a:p>
+                  </a:txBody>
+                  <a:tcPr marT="9144" marB="9144"/>
+                </a:tc>
+                <a:tc>
+                  <a:txBody>
+                    <a:bodyPr/>
+                    <a:lstStyle/>
+                    <a:p>
+                      <a:r>
+                        <a:rPr sz="900" b="0"/>
+                        <a:t>8</a:t>
+                      </a:r>
+                    </a:p>
+                  </a:txBody>
+                  <a:tcPr marT="9144" marB="9144"/>
+                </a:tc>
+              </a:tr>
+              <a:tr h="210312">
+                <a:tc>
+                  <a:txBody>
+                    <a:bodyPr/>
+                    <a:lstStyle/>
+                    <a:p>
+                      <a:r>
+                        <a:rPr sz="900" b="0"/>
+                        <a:t>Washington</a:t>
+                      </a:r>
+                    </a:p>
+                  </a:txBody>
+                  <a:tcPr marT="9144" marB="9144"/>
+                </a:tc>
+                <a:tc>
+                  <a:txBody>
+                    <a:bodyPr/>
+                    <a:lstStyle/>
+                    <a:p>
+                      <a:r>
+                        <a:rPr sz="900" b="0"/>
+                        <a:t>national</a:t>
+                      </a:r>
+                    </a:p>
+                  </a:txBody>
+                  <a:tcPr marT="9144" marB="9144"/>
+                </a:tc>
+                <a:tc>
+                  <a:txBody>
+                    <a:bodyPr/>
+                    <a:lstStyle/>
+                    <a:p>
+                      <a:r>
+                        <a:rPr sz="900" b="0"/>
+                        <a:t>127</a:t>
+                      </a:r>
+                    </a:p>
+                  </a:txBody>
+                  <a:tcPr marT="9144" marB="9144"/>
+                </a:tc>
+                <a:tc>
+                  <a:txBody>
+                    <a:bodyPr/>
+                    <a:lstStyle/>
+                    <a:p>
+                      <a:r>
+                        <a:rPr sz="900" b="0"/>
+                        <a:t>22</a:t>
+                      </a:r>
+                    </a:p>
+                  </a:txBody>
+                  <a:tcPr marT="9144" marB="9144"/>
+                </a:tc>
+                <a:tc>
+                  <a:txBody>
+                    <a:bodyPr/>
+                    <a:lstStyle/>
+                    <a:p>
+                      <a:r>
+                        <a:rPr sz="900" b="0"/>
+                        <a:t>national</a:t>
+                      </a:r>
+                    </a:p>
+                  </a:txBody>
+                  <a:tcPr marT="9144" marB="9144"/>
+                </a:tc>
+                <a:tc>
+                  <a:txBody>
+                    <a:bodyPr/>
+                    <a:lstStyle/>
+                    <a:p>
+                      <a:r>
+                        <a:rPr sz="900" b="0"/>
+                        <a:t>249</a:t>
+                      </a:r>
+                    </a:p>
+                  </a:txBody>
+                  <a:tcPr marT="9144" marB="9144"/>
+                </a:tc>
+                <a:tc>
+                  <a:txBody>
+                    <a:bodyPr/>
+                    <a:lstStyle/>
+                    <a:p>
+                      <a:r>
+                        <a:rPr sz="900" b="0"/>
+                        <a:t>49</a:t>
+                      </a:r>
+                    </a:p>
+                  </a:txBody>
+                  <a:tcPr marT="9144" marB="9144"/>
+                </a:tc>
+              </a:tr>
+            </a:tbl>
+          </a:graphicData>
+        </a:graphic>
+      </p:graphicFrame>
+    </p:spTree>
+  </p:cSld>
+  <p:clrMapOvr>
+    <a:masterClrMapping/>
+  </p:clrMapOvr>
+</p:sld>
+</file>
+
+<file path=ppt/slides/slide47.xml><?xml version="1.0" encoding="utf-8"?>
+<p:sld xmlns:a="http://schemas.openxmlformats.org/drawingml/2006/main" xmlns:p="http://schemas.openxmlformats.org/presentationml/2006/main" xmlns:r="http://schemas.openxmlformats.org/officeDocument/2006/relationships">
+  <p:cSld>
+    <p:spTree>
+      <p:nvGrpSpPr>
+        <p:cNvPr id="1" name=""/>
+        <p:cNvGrpSpPr/>
+        <p:nvPr/>
+      </p:nvGrpSpPr>
+      <p:grpSpPr/>
+      <p:sp>
+        <p:nvSpPr>
+          <p:cNvPr id="2" name="TextBox 1"/>
+          <p:cNvSpPr txBox="1"/>
+          <p:nvPr/>
+        </p:nvSpPr>
+        <p:spPr>
+          <a:xfrm>
+            <a:off x="400000" y="200000"/>
+            <a:ext cx="8344000" cy="600000"/>
+          </a:xfrm>
+          <a:prstGeom prst="rect">
+            <a:avLst/>
+          </a:prstGeom>
+          <a:noFill/>
+        </p:spPr>
+        <p:txBody>
+          <a:bodyPr wrap="none">
+            <a:spAutoFit/>
+          </a:bodyPr>
+          <a:lstStyle/>
+          <a:p>
+            <a:r>
+              <a:rPr sz="2200" b="1"/>
               <a:t>Takeaways</a:t>
             </a:r>
           </a:p>

</xml_diff>

<commit_message>
Blended state+national frozen lists on one confidence scale
- blended_frozen_lists_v2.R: merge each state's own pool into the
  national pool, rank all rules by their own-training 99% LCB, freeze +
  buffer + walk as in section 15 (98% variant immaterial)
- verdict (findings section 16): as a single no-decision recipe the
  blend beats national-only at 5% (median 0.324/15% vs 0.294/12%) and
  ties at 10%; where state rules clear the unified bar, interleaving
  beats either pool alone (AZ 0.326, DC 0.495, MS 0.374)
- blind spot: national bounds are silent about transfer, so the scale
  over-trusts national rules where the mix fits worst -- NJ's own rules
  never enter. Own-pool lists are the FALLBACK, decided by the state's
  internal validation (public files show only 43-81% of error cases)
- deck: blended-scale slide + fallback framing on the handoff slide

Co-Authored-By: Claude Fable 5 <noreply@anthropic.com>
</commit_message>
<xml_diff>
--- a/lessons_getting_more_signal_from_snap_qc_data.pptx
+++ b/lessons_getting_more_signal_from_snap_qc_data.pptx
@@ -33,6 +33,7 @@
     <p:sldId id="301" r:id="rId52"/>
     <p:sldId id="302" r:id="rId53"/>
     <p:sldId id="303" r:id="rId54"/>
+    <p:sldId id="304" r:id="rId55"/>
   </p:sldIdLst>
   <p:sldSz cx="9144000" cy="5143500" type="screen16x9"/>
   <p:notesSz cx="5143500" cy="9144000"/>
@@ -15764,6 +15765,17 @@
               <a:t>- One ranked list per state (core sized to the budget + buffer to 3x depth), from the national pool by default or the state's own mined pool where its own rules win on 2024. 'Typically run' = rules actually activated before 2024 capacity filled.</a:t>
             </a:r>
           </a:p>
+          <a:p>
+            <a:pPr>
+              <a:spcAft>
+                <a:spcPts val="400"/>
+              </a:spcAft>
+            </a:pPr>
+            <a:r>
+              <a:rPr sz="1200"/>
+              <a:t>- Own rules are the FALLBACK regime, not a co-equal choice: the public files show only 43-81% of a state's error cases, so where they disagree with the national list, only the state's own internal validation can settle which is really better.</a:t>
+            </a:r>
+          </a:p>
         </p:txBody>
       </p:sp>
       <p:sp>
@@ -15804,7 +15816,7 @@
           <p:nvPr/>
         </p:nvGraphicFramePr>
         <p:xfrm>
-          <a:off x="365760" y="1728216"/>
+          <a:off x="365760" y="2496312"/>
           <a:ext cx="8412480" cy="3995928"/>
         </p:xfrm>
         <a:graphic>
@@ -17602,6 +17614,340 @@
 </file>
 
 <file path=ppt/slides/slide47.xml><?xml version="1.0" encoding="utf-8"?>
+<p:sld xmlns:a="http://schemas.openxmlformats.org/drawingml/2006/main" xmlns:p="http://schemas.openxmlformats.org/presentationml/2006/main" xmlns:r="http://schemas.openxmlformats.org/officeDocument/2006/relationships">
+  <p:cSld>
+    <p:spTree>
+      <p:nvGrpSpPr>
+        <p:cNvPr id="1" name=""/>
+        <p:cNvGrpSpPr/>
+        <p:nvPr/>
+      </p:nvGrpSpPr>
+      <p:grpSpPr/>
+      <p:sp>
+        <p:nvSpPr>
+          <p:cNvPr id="2" name="TextBox 1"/>
+          <p:cNvSpPr txBox="1"/>
+          <p:nvPr/>
+        </p:nvSpPr>
+        <p:spPr>
+          <a:xfrm>
+            <a:off x="400000" y="200000"/>
+            <a:ext cx="8344000" cy="600000"/>
+          </a:xfrm>
+          <a:prstGeom prst="rect">
+            <a:avLst/>
+          </a:prstGeom>
+          <a:noFill/>
+        </p:spPr>
+        <p:txBody>
+          <a:bodyPr wrap="none">
+            <a:spAutoFit/>
+          </a:bodyPr>
+          <a:lstStyle/>
+          <a:p>
+            <a:r>
+              <a:rPr sz="2200" b="1"/>
+              <a:t>Blending state and national rules onto one confidence scale</a:t>
+            </a:r>
+          </a:p>
+        </p:txBody>
+      </p:sp>
+      <p:sp>
+        <p:nvSpPr>
+          <p:cNvPr id="4" name="TextBox 3"/>
+          <p:cNvSpPr txBox="1"/>
+          <p:nvPr/>
+        </p:nvSpPr>
+        <p:spPr>
+          <a:xfrm>
+            <a:off x="400000" y="760000"/>
+            <a:ext cx="8344000" cy="430000"/>
+          </a:xfrm>
+          <a:prstGeom prst="rect">
+            <a:avLst/>
+          </a:prstGeom>
+          <a:noFill/>
+        </p:spPr>
+        <p:txBody>
+          <a:bodyPr wrap="square">
+            <a:spAutoFit/>
+          </a:bodyPr>
+          <a:lstStyle/>
+          <a:p>
+            <a:pPr>
+              <a:spcAft>
+                <a:spcPts val="400"/>
+              </a:spcAft>
+            </a:pPr>
+            <a:r>
+              <a:rPr sz="1200"/>
+              <a:t>- Merge the state's own mined pool into the national pool and rank EVERY rule by its own 99% lower-bound precision - national rules bounded on national training data, state rules on the state's own. Both read 'at least this, with 99% confidence', and the bound applies the certainty discount automatically: a small-support state rule outranks national rules only when its precision overcomes the penalty.</a:t>
+            </a:r>
+          </a:p>
+          <a:p>
+            <a:pPr>
+              <a:spcAft>
+                <a:spcPts val="400"/>
+              </a:spcAft>
+            </a:pPr>
+            <a:r>
+              <a:rPr sz="1200"/>
+              <a:t>- As a single recipe with no regime decision, the blend beats the national-only frozen list at a 5% budget (median 0.324 vs 0.294 precision, 15% vs 12% of error dollars) and ties it at 10%. Where state rules clear the bar, interleaving beats either pool alone: Arizona 0.326 (vs 0.291 best single), DC 0.495 (vs 0.464), Mississippi 0.374 (vs 0.355).</a:t>
+            </a:r>
+          </a:p>
+          <a:p>
+            <a:pPr>
+              <a:spcAft>
+                <a:spcPts val="400"/>
+              </a:spcAft>
+            </a:pPr>
+            <a:r>
+              <a:rPr sz="1200"/>
+              <a:t>- The known blind spot: a national rule's bound describes its precision on the national mix and is silent about transfer, so in states where the national mix fits worst the scale over-trusts national rules - New Jersey's own rules never enter and the blend under-delivers there (0.161 vs 0.230 for its own list at 10%).</a:t>
+            </a:r>
+          </a:p>
+          <a:p>
+            <a:pPr>
+              <a:spcAft>
+                <a:spcPts val="400"/>
+              </a:spcAft>
+            </a:pPr>
+            <a:r>
+              <a:rPr sz="1200"/>
+              <a:t>- Deployment: blend as the default; the own-pool list stays available as the fallback where a state's internal validation shows the blend under-performing. In low-visibility states (New Jersey: 43% of error cases visible) the public data cannot settle the question - the state's internal check decides.</a:t>
+            </a:r>
+          </a:p>
+        </p:txBody>
+      </p:sp>
+      <p:sp>
+        <p:nvSpPr>
+          <p:cNvPr id="3" name="TextBox 2"/>
+          <p:cNvSpPr txBox="1"/>
+          <p:nvPr/>
+        </p:nvSpPr>
+        <p:spPr>
+          <a:xfrm>
+            <a:off x="400000" y="4723500"/>
+            <a:ext cx="3200000" cy="320000"/>
+          </a:xfrm>
+          <a:prstGeom prst="rect">
+            <a:avLst/>
+          </a:prstGeom>
+          <a:noFill/>
+        </p:spPr>
+        <p:txBody>
+          <a:bodyPr wrap="none">
+            <a:spAutoFit/>
+          </a:bodyPr>
+          <a:lstStyle/>
+          <a:p>
+            <a:r>
+              <a:rPr sz="1000" i="1"/>
+              <a:t>SNAP QC modeling lessons - July 2026</a:t>
+            </a:r>
+          </a:p>
+        </p:txBody>
+      </p:sp>
+      <p:graphicFrame>
+        <p:nvGraphicFramePr>
+          <p:cNvPr id="5" name="Table 4"/>
+          <p:cNvGraphicFramePr>
+            <a:graphicFrameLocks noGrp="1"/>
+          </p:cNvGraphicFramePr>
+          <p:nvPr/>
+        </p:nvGraphicFramePr>
+        <p:xfrm>
+          <a:off x="1600200" y="4800600"/>
+          <a:ext cx="5943600" cy="1170432"/>
+        </p:xfrm>
+        <a:graphic>
+          <a:graphicData uri="http://schemas.openxmlformats.org/drawingml/2006/table">
+            <a:tbl>
+              <a:tblPr firstRow="1" bandRow="1">
+                <a:tableStyleId>{5C22544A-7EE6-4342-B048-85BDC9FD1C3A}</a:tableStyleId>
+              </a:tblPr>
+              <a:tblGrid>
+                <a:gridCol w="1981200"/>
+                <a:gridCol w="1981200"/>
+                <a:gridCol w="1981200"/>
+              </a:tblGrid>
+              <a:tr h="292608">
+                <a:tc>
+                  <a:txBody>
+                    <a:bodyPr/>
+                    <a:lstStyle/>
+                    <a:p>
+                      <a:r>
+                        <a:rPr sz="1200" b="1"/>
+                        <a:t>option (single recipe)</a:t>
+                      </a:r>
+                    </a:p>
+                  </a:txBody>
+                  <a:tcPr marT="9144" marB="9144"/>
+                </a:tc>
+                <a:tc>
+                  <a:txBody>
+                    <a:bodyPr/>
+                    <a:lstStyle/>
+                    <a:p>
+                      <a:r>
+                        <a:rPr sz="1200" b="1"/>
+                        <a:t>5% budget</a:t>
+                      </a:r>
+                    </a:p>
+                  </a:txBody>
+                  <a:tcPr marT="9144" marB="9144"/>
+                </a:tc>
+                <a:tc>
+                  <a:txBody>
+                    <a:bodyPr/>
+                    <a:lstStyle/>
+                    <a:p>
+                      <a:r>
+                        <a:rPr sz="1200" b="1"/>
+                        <a:t>10% budget</a:t>
+                      </a:r>
+                    </a:p>
+                  </a:txBody>
+                  <a:tcPr marT="9144" marB="9144"/>
+                </a:tc>
+              </a:tr>
+              <a:tr h="292608">
+                <a:tc>
+                  <a:txBody>
+                    <a:bodyPr/>
+                    <a:lstStyle/>
+                    <a:p>
+                      <a:r>
+                        <a:rPr sz="1200" b="0"/>
+                        <a:t>national-only frozen list</a:t>
+                      </a:r>
+                    </a:p>
+                  </a:txBody>
+                  <a:tcPr marT="9144" marB="9144"/>
+                </a:tc>
+                <a:tc>
+                  <a:txBody>
+                    <a:bodyPr/>
+                    <a:lstStyle/>
+                    <a:p>
+                      <a:r>
+                        <a:rPr sz="1200" b="0"/>
+                        <a:t>0.294 / 12%</a:t>
+                      </a:r>
+                    </a:p>
+                  </a:txBody>
+                  <a:tcPr marT="9144" marB="9144"/>
+                </a:tc>
+                <a:tc>
+                  <a:txBody>
+                    <a:bodyPr/>
+                    <a:lstStyle/>
+                    <a:p>
+                      <a:r>
+                        <a:rPr sz="1200" b="0"/>
+                        <a:t>0.270 / 25%</a:t>
+                      </a:r>
+                    </a:p>
+                  </a:txBody>
+                  <a:tcPr marT="9144" marB="9144"/>
+                </a:tc>
+              </a:tr>
+              <a:tr h="292608">
+                <a:tc>
+                  <a:txBody>
+                    <a:bodyPr/>
+                    <a:lstStyle/>
+                    <a:p>
+                      <a:r>
+                        <a:rPr sz="1200" b="0"/>
+                        <a:t>blended frozen list (99% bound)</a:t>
+                      </a:r>
+                    </a:p>
+                  </a:txBody>
+                  <a:tcPr marT="9144" marB="9144"/>
+                </a:tc>
+                <a:tc>
+                  <a:txBody>
+                    <a:bodyPr/>
+                    <a:lstStyle/>
+                    <a:p>
+                      <a:r>
+                        <a:rPr sz="1200" b="0"/>
+                        <a:t>0.324 / 15%</a:t>
+                      </a:r>
+                    </a:p>
+                  </a:txBody>
+                  <a:tcPr marT="9144" marB="9144"/>
+                </a:tc>
+                <a:tc>
+                  <a:txBody>
+                    <a:bodyPr/>
+                    <a:lstStyle/>
+                    <a:p>
+                      <a:r>
+                        <a:rPr sz="1200" b="0"/>
+                        <a:t>0.262 / 24%</a:t>
+                      </a:r>
+                    </a:p>
+                  </a:txBody>
+                  <a:tcPr marT="9144" marB="9144"/>
+                </a:tc>
+              </a:tr>
+              <a:tr h="292608">
+                <a:tc>
+                  <a:txBody>
+                    <a:bodyPr/>
+                    <a:lstStyle/>
+                    <a:p>
+                      <a:r>
+                        <a:rPr sz="1200" b="0"/>
+                        <a:t>state's own pool only</a:t>
+                      </a:r>
+                    </a:p>
+                  </a:txBody>
+                  <a:tcPr marT="9144" marB="9144"/>
+                </a:tc>
+                <a:tc>
+                  <a:txBody>
+                    <a:bodyPr/>
+                    <a:lstStyle/>
+                    <a:p>
+                      <a:r>
+                        <a:rPr sz="1200" b="0"/>
+                        <a:t>0.256 / 13%</a:t>
+                      </a:r>
+                    </a:p>
+                  </a:txBody>
+                  <a:tcPr marT="9144" marB="9144"/>
+                </a:tc>
+                <a:tc>
+                  <a:txBody>
+                    <a:bodyPr/>
+                    <a:lstStyle/>
+                    <a:p>
+                      <a:r>
+                        <a:rPr sz="1200" b="0"/>
+                        <a:t>0.236 / 25%</a:t>
+                      </a:r>
+                    </a:p>
+                  </a:txBody>
+                  <a:tcPr marT="9144" marB="9144"/>
+                </a:tc>
+              </a:tr>
+            </a:tbl>
+          </a:graphicData>
+        </a:graphic>
+      </p:graphicFrame>
+    </p:spTree>
+  </p:cSld>
+  <p:clrMapOvr>
+    <a:masterClrMapping/>
+  </p:clrMapOvr>
+</p:sld>
+</file>
+
+<file path=ppt/slides/slide48.xml><?xml version="1.0" encoding="utf-8"?>
 <p:sld xmlns:a="http://schemas.openxmlformats.org/drawingml/2006/main" xmlns:p="http://schemas.openxmlformats.org/presentationml/2006/main" xmlns:r="http://schemas.openxmlformats.org/officeDocument/2006/relationships">
   <p:cSld>
     <p:spTree>

</xml_diff>

<commit_message>
Compact handoff table rows to fit slide
Co-Authored-By: Claude Fable 5 <noreply@anthropic.com>
</commit_message>
<xml_diff>
--- a/lessons_getting_more_signal_from_snap_qc_data.pptx
+++ b/lessons_getting_more_signal_from_snap_qc_data.pptx
@@ -15817,7 +15817,7 @@
         </p:nvGraphicFramePr>
         <p:xfrm>
           <a:off x="365760" y="2496312"/>
-          <a:ext cx="8412480" cy="3995928"/>
+          <a:ext cx="8412480" cy="3648456"/>
         </p:xfrm>
         <a:graphic>
           <a:graphicData uri="http://schemas.openxmlformats.org/drawingml/2006/table">
@@ -15834,7 +15834,7 @@
                 <a:gridCol w="1201782"/>
                 <a:gridCol w="1201788"/>
               </a:tblGrid>
-              <a:tr h="210312">
+              <a:tr h="192024">
                 <a:tc>
                   <a:txBody>
                     <a:bodyPr/>
@@ -15927,7 +15927,7 @@
                   <a:tcPr marT="9144" marB="9144"/>
                 </a:tc>
               </a:tr>
-              <a:tr h="210312">
+              <a:tr h="192024">
                 <a:tc>
                   <a:txBody>
                     <a:bodyPr/>
@@ -16020,7 +16020,7 @@
                   <a:tcPr marT="9144" marB="9144"/>
                 </a:tc>
               </a:tr>
-              <a:tr h="210312">
+              <a:tr h="192024">
                 <a:tc>
                   <a:txBody>
                     <a:bodyPr/>
@@ -16113,7 +16113,7 @@
                   <a:tcPr marT="9144" marB="9144"/>
                 </a:tc>
               </a:tr>
-              <a:tr h="210312">
+              <a:tr h="192024">
                 <a:tc>
                   <a:txBody>
                     <a:bodyPr/>
@@ -16206,7 +16206,7 @@
                   <a:tcPr marT="9144" marB="9144"/>
                 </a:tc>
               </a:tr>
-              <a:tr h="210312">
+              <a:tr h="192024">
                 <a:tc>
                   <a:txBody>
                     <a:bodyPr/>
@@ -16299,7 +16299,7 @@
                   <a:tcPr marT="9144" marB="9144"/>
                 </a:tc>
               </a:tr>
-              <a:tr h="210312">
+              <a:tr h="192024">
                 <a:tc>
                   <a:txBody>
                     <a:bodyPr/>
@@ -16392,7 +16392,7 @@
                   <a:tcPr marT="9144" marB="9144"/>
                 </a:tc>
               </a:tr>
-              <a:tr h="210312">
+              <a:tr h="192024">
                 <a:tc>
                   <a:txBody>
                     <a:bodyPr/>
@@ -16485,7 +16485,7 @@
                   <a:tcPr marT="9144" marB="9144"/>
                 </a:tc>
               </a:tr>
-              <a:tr h="210312">
+              <a:tr h="192024">
                 <a:tc>
                   <a:txBody>
                     <a:bodyPr/>
@@ -16578,7 +16578,7 @@
                   <a:tcPr marT="9144" marB="9144"/>
                 </a:tc>
               </a:tr>
-              <a:tr h="210312">
+              <a:tr h="192024">
                 <a:tc>
                   <a:txBody>
                     <a:bodyPr/>
@@ -16671,7 +16671,7 @@
                   <a:tcPr marT="9144" marB="9144"/>
                 </a:tc>
               </a:tr>
-              <a:tr h="210312">
+              <a:tr h="192024">
                 <a:tc>
                   <a:txBody>
                     <a:bodyPr/>
@@ -16764,7 +16764,7 @@
                   <a:tcPr marT="9144" marB="9144"/>
                 </a:tc>
               </a:tr>
-              <a:tr h="210312">
+              <a:tr h="192024">
                 <a:tc>
                   <a:txBody>
                     <a:bodyPr/>
@@ -16857,7 +16857,7 @@
                   <a:tcPr marT="9144" marB="9144"/>
                 </a:tc>
               </a:tr>
-              <a:tr h="210312">
+              <a:tr h="192024">
                 <a:tc>
                   <a:txBody>
                     <a:bodyPr/>
@@ -16950,7 +16950,7 @@
                   <a:tcPr marT="9144" marB="9144"/>
                 </a:tc>
               </a:tr>
-              <a:tr h="210312">
+              <a:tr h="192024">
                 <a:tc>
                   <a:txBody>
                     <a:bodyPr/>
@@ -17043,7 +17043,7 @@
                   <a:tcPr marT="9144" marB="9144"/>
                 </a:tc>
               </a:tr>
-              <a:tr h="210312">
+              <a:tr h="192024">
                 <a:tc>
                   <a:txBody>
                     <a:bodyPr/>
@@ -17136,7 +17136,7 @@
                   <a:tcPr marT="9144" marB="9144"/>
                 </a:tc>
               </a:tr>
-              <a:tr h="210312">
+              <a:tr h="192024">
                 <a:tc>
                   <a:txBody>
                     <a:bodyPr/>
@@ -17229,7 +17229,7 @@
                   <a:tcPr marT="9144" marB="9144"/>
                 </a:tc>
               </a:tr>
-              <a:tr h="210312">
+              <a:tr h="192024">
                 <a:tc>
                   <a:txBody>
                     <a:bodyPr/>
@@ -17322,7 +17322,7 @@
                   <a:tcPr marT="9144" marB="9144"/>
                 </a:tc>
               </a:tr>
-              <a:tr h="210312">
+              <a:tr h="192024">
                 <a:tc>
                   <a:txBody>
                     <a:bodyPr/>
@@ -17415,7 +17415,7 @@
                   <a:tcPr marT="9144" marB="9144"/>
                 </a:tc>
               </a:tr>
-              <a:tr h="210312">
+              <a:tr h="192024">
                 <a:tc>
                   <a:txBody>
                     <a:bodyPr/>
@@ -17508,7 +17508,7 @@
                   <a:tcPr marT="9144" marB="9144"/>
                 </a:tc>
               </a:tr>
-              <a:tr h="210312">
+              <a:tr h="192024">
                 <a:tc>
                   <a:txBody>
                     <a:bodyPr/>

</xml_diff>

<commit_message>
Slide: most widely deployed rules by household-size stratum
Top three rules per stratum by number of deploying states (10% budget),
read from contributing_rules_by_state.csv; column-width support added to
the deck builder's table helper.

Co-Authored-By: Claude Fable 5 <noreply@anthropic.com>
</commit_message>
<xml_diff>
--- a/lessons_getting_more_signal_from_snap_qc_data.pptx
+++ b/lessons_getting_more_signal_from_snap_qc_data.pptx
@@ -34,6 +34,7 @@
     <p:sldId id="302" r:id="rId53"/>
     <p:sldId id="303" r:id="rId54"/>
     <p:sldId id="304" r:id="rId55"/>
+    <p:sldId id="305" r:id="rId56"/>
   </p:sldIdLst>
   <p:sldSz cx="9144000" cy="5143500" type="screen16x9"/>
   <p:notesSz cx="5143500" cy="9144000"/>
@@ -15440,7 +15441,7 @@
           <a:p>
             <a:r>
               <a:rPr sz="2200" b="1"/>
-              <a:t>The deliverable: one ranked rule list per state, walked to capacity</a:t>
+              <a:t>The most widely deployed rules, by household size</a:t>
             </a:r>
           </a:p>
         </p:txBody>
@@ -15474,40 +15475,7 @@
             </a:pPr>
             <a:r>
               <a:rPr sz="1200"/>
-              <a:t>- Built in advance from public data alone: fill the national pool (mined on all states' 2022-23) against the state's own 2022-23 caseload, in confidence order, until the review budget is reached - then keep filling to 3x that depth. The extra rules are ranked BUFFER rules, shipped in the same list.</a:t>
-            </a:r>
-          </a:p>
-          <a:p>
-            <a:pPr>
-              <a:spcAft>
-                <a:spcPts val="400"/>
-              </a:spcAft>
-            </a:pPr>
-            <a:r>
-              <a:rPr sz="1200"/>
-              <a:t>- To use it, the state activates rules in order, checking only its own flag counts: keep adding while reviews fit capacity. No error outcomes are needed at any step.</a:t>
-            </a:r>
-          </a:p>
-          <a:p>
-            <a:pPr>
-              <a:spcAft>
-                <a:spcPts val="400"/>
-              </a:spcAft>
-            </a:pPr>
-            <a:r>
-              <a:rPr sz="1200"/>
-              <a:t>- The buffer is what makes the workload land on budget as patterns change: a state never stops reviewing because a list ran dry, and an over-firing list trims the same way. Raw core lists drifted to 2.3-12% of caseload on 2024; the walked lists land at 4.9-5.0% and 9.3-10.0% in all 18 states.</a:t>
-            </a:r>
-          </a:p>
-          <a:p>
-            <a:pPr>
-              <a:spcAft>
-                <a:spcPts val="400"/>
-              </a:spcAft>
-            </a:pPr>
-            <a:r>
-              <a:rPr sz="1200"/>
-              <a:t>- Median rules actually activated: 23 at a 5% budget, 42 at 10%. Validation recipe: we freeze on public data through the latest year; the state validates on its own newer internal data before relying on it.</a:t>
+              <a:t>- The three rules deployed by the most states (of 18) in each household-size stratum, from the 10%-budget national deployment. Each is a plain checkable condition. Benefit amounts relative to the household maximum appear in 8 of the 9 rules and deduction levels relative to household size in 7; certification timing, utilities, and shelter levels fill out the rest.</a:t>
             </a:r>
           </a:p>
         </p:txBody>
@@ -15541,6 +15509,443 @@
           </a:p>
         </p:txBody>
       </p:sp>
+      <p:graphicFrame>
+        <p:nvGraphicFramePr>
+          <p:cNvPr id="5" name="Table 4"/>
+          <p:cNvGraphicFramePr>
+            <a:graphicFrameLocks noGrp="1"/>
+          </p:cNvGraphicFramePr>
+          <p:nvPr/>
+        </p:nvGraphicFramePr>
+        <p:xfrm>
+          <a:off x="274319" y="1984248"/>
+          <a:ext cx="8595360" cy="4572000"/>
+        </p:xfrm>
+        <a:graphic>
+          <a:graphicData uri="http://schemas.openxmlformats.org/drawingml/2006/table">
+            <a:tbl>
+              <a:tblPr firstRow="1" bandRow="1">
+                <a:tableStyleId>{5C22544A-7EE6-4342-B048-85BDC9FD1C3A}</a:tableStyleId>
+              </a:tblPr>
+              <a:tblGrid>
+                <a:gridCol w="731520"/>
+                <a:gridCol w="6766560"/>
+                <a:gridCol w="1097280"/>
+              </a:tblGrid>
+              <a:tr h="457200">
+                <a:tc>
+                  <a:txBody>
+                    <a:bodyPr/>
+                    <a:lstStyle/>
+                    <a:p>
+                      <a:r>
+                        <a:rPr sz="900" b="1"/>
+                        <a:t>HH size</a:t>
+                      </a:r>
+                    </a:p>
+                  </a:txBody>
+                  <a:tcPr marT="9144" marB="9144"/>
+                </a:tc>
+                <a:tc>
+                  <a:txBody>
+                    <a:bodyPr/>
+                    <a:lstStyle/>
+                    <a:p>
+                      <a:r>
+                        <a:rPr sz="900" b="1"/>
+                        <a:t>rule</a:t>
+                      </a:r>
+                    </a:p>
+                  </a:txBody>
+                  <a:tcPr marT="9144" marB="9144"/>
+                </a:tc>
+                <a:tc>
+                  <a:txBody>
+                    <a:bodyPr/>
+                    <a:lstStyle/>
+                    <a:p>
+                      <a:r>
+                        <a:rPr sz="900" b="1"/>
+                        <a:t>states (of 18)</a:t>
+                      </a:r>
+                    </a:p>
+                  </a:txBody>
+                  <a:tcPr marT="9144" marB="9144"/>
+                </a:tc>
+              </a:tr>
+              <a:tr h="457200">
+                <a:tc>
+                  <a:txBody>
+                    <a:bodyPr/>
+                    <a:lstStyle/>
+                    <a:p>
+                      <a:r>
+                        <a:rPr sz="900" b="0"/>
+                        <a:t>1</a:t>
+                      </a:r>
+                    </a:p>
+                  </a:txBody>
+                  <a:tcPr marT="9144" marB="9144"/>
+                </a:tc>
+                <a:tc>
+                  <a:txBody>
+                    <a:bodyPr/>
+                    <a:lstStyle/>
+                    <a:p>
+                      <a:r>
+                        <a:rPr sz="900" b="0"/>
+                        <a:t>rawben_rel_max &gt;= 0.236 &amp; rawben_rel_max &lt; 1.000 &amp; total_deductions_by_hh_size &gt;= 511.000 &amp; utilities &lt; 249.000</a:t>
+                      </a:r>
+                    </a:p>
+                  </a:txBody>
+                  <a:tcPr marT="9144" marB="9144"/>
+                </a:tc>
+                <a:tc>
+                  <a:txBody>
+                    <a:bodyPr/>
+                    <a:lstStyle/>
+                    <a:p>
+                      <a:r>
+                        <a:rPr sz="900" b="0"/>
+                        <a:t>12</a:t>
+                      </a:r>
+                    </a:p>
+                  </a:txBody>
+                  <a:tcPr marT="9144" marB="9144"/>
+                </a:tc>
+              </a:tr>
+              <a:tr h="457200">
+                <a:tc>
+                  <a:txBody>
+                    <a:bodyPr/>
+                    <a:lstStyle/>
+                    <a:p>
+                      <a:r>
+                        <a:rPr sz="900" b="0"/>
+                        <a:t>1</a:t>
+                      </a:r>
+                    </a:p>
+                  </a:txBody>
+                  <a:tcPr marT="9144" marB="9144"/>
+                </a:tc>
+                <a:tc>
+                  <a:txBody>
+                    <a:bodyPr/>
+                    <a:lstStyle/>
+                    <a:p>
+                      <a:r>
+                        <a:rPr sz="900" b="0"/>
+                        <a:t>total_deductions_by_hh_size &gt; 336.000 &amp; unc_rawben_rel_max &gt; 0.891 &amp; unc_rawben_rel_max &lt;= 0.991 &amp; utilities &lt;= 29.500</a:t>
+                      </a:r>
+                    </a:p>
+                  </a:txBody>
+                  <a:tcPr marT="9144" marB="9144"/>
+                </a:tc>
+                <a:tc>
+                  <a:txBody>
+                    <a:bodyPr/>
+                    <a:lstStyle/>
+                    <a:p>
+                      <a:r>
+                        <a:rPr sz="900" b="0"/>
+                        <a:t>11</a:t>
+                      </a:r>
+                    </a:p>
+                  </a:txBody>
+                  <a:tcPr marT="9144" marB="9144"/>
+                </a:tc>
+              </a:tr>
+              <a:tr h="457200">
+                <a:tc>
+                  <a:txBody>
+                    <a:bodyPr/>
+                    <a:lstStyle/>
+                    <a:p>
+                      <a:r>
+                        <a:rPr sz="900" b="0"/>
+                        <a:t>1</a:t>
+                      </a:r>
+                    </a:p>
+                  </a:txBody>
+                  <a:tcPr marT="9144" marB="9144"/>
+                </a:tc>
+                <a:tc>
+                  <a:txBody>
+                    <a:bodyPr/>
+                    <a:lstStyle/>
+                    <a:p>
+                      <a:r>
+                        <a:rPr sz="900" b="0"/>
+                        <a:t>rawben_rel_max &lt;= 0.998 &amp; total_deductions_by_hh_size &gt; 602.000 &amp; utilities &lt;= 272.000</a:t>
+                      </a:r>
+                    </a:p>
+                  </a:txBody>
+                  <a:tcPr marT="9144" marB="9144"/>
+                </a:tc>
+                <a:tc>
+                  <a:txBody>
+                    <a:bodyPr/>
+                    <a:lstStyle/>
+                    <a:p>
+                      <a:r>
+                        <a:rPr sz="900" b="0"/>
+                        <a:t>10</a:t>
+                      </a:r>
+                    </a:p>
+                  </a:txBody>
+                  <a:tcPr marT="9144" marB="9144"/>
+                </a:tc>
+              </a:tr>
+              <a:tr h="457200">
+                <a:tc>
+                  <a:txBody>
+                    <a:bodyPr/>
+                    <a:lstStyle/>
+                    <a:p>
+                      <a:r>
+                        <a:rPr sz="900" b="0"/>
+                        <a:t>2-3</a:t>
+                      </a:r>
+                    </a:p>
+                  </a:txBody>
+                  <a:tcPr marT="9144" marB="9144"/>
+                </a:tc>
+                <a:tc>
+                  <a:txBody>
+                    <a:bodyPr/>
+                    <a:lstStyle/>
+                    <a:p>
+                      <a:r>
+                        <a:rPr sz="900" b="0"/>
+                        <a:t>months_since_cert_n &lt;= 25 &amp; shelter_expenses_by_hh_size &gt; 499 &amp; shelter_expenses_by_hh_size &lt;= 679 &amp; total_deductions_by_hh_size &gt; 644</a:t>
+                      </a:r>
+                    </a:p>
+                  </a:txBody>
+                  <a:tcPr marT="9144" marB="9144"/>
+                </a:tc>
+                <a:tc>
+                  <a:txBody>
+                    <a:bodyPr/>
+                    <a:lstStyle/>
+                    <a:p>
+                      <a:r>
+                        <a:rPr sz="900" b="0"/>
+                        <a:t>9</a:t>
+                      </a:r>
+                    </a:p>
+                  </a:txBody>
+                  <a:tcPr marT="9144" marB="9144"/>
+                </a:tc>
+              </a:tr>
+              <a:tr h="457200">
+                <a:tc>
+                  <a:txBody>
+                    <a:bodyPr/>
+                    <a:lstStyle/>
+                    <a:p>
+                      <a:r>
+                        <a:rPr sz="900" b="0"/>
+                        <a:t>2-3</a:t>
+                      </a:r>
+                    </a:p>
+                  </a:txBody>
+                  <a:tcPr marT="9144" marB="9144"/>
+                </a:tc>
+                <a:tc>
+                  <a:txBody>
+                    <a:bodyPr/>
+                    <a:lstStyle/>
+                    <a:p>
+                      <a:r>
+                        <a:rPr sz="900" b="0"/>
+                        <a:t>expedited_i &gt;= 1.000 &amp; months_since_cert_n &lt; 2.000 &amp; rawben_rel_max &gt;= 0.649 &amp; rawben_rel_max &lt; 0.901</a:t>
+                      </a:r>
+                    </a:p>
+                  </a:txBody>
+                  <a:tcPr marT="9144" marB="9144"/>
+                </a:tc>
+                <a:tc>
+                  <a:txBody>
+                    <a:bodyPr/>
+                    <a:lstStyle/>
+                    <a:p>
+                      <a:r>
+                        <a:rPr sz="900" b="0"/>
+                        <a:t>9</a:t>
+                      </a:r>
+                    </a:p>
+                  </a:txBody>
+                  <a:tcPr marT="9144" marB="9144"/>
+                </a:tc>
+              </a:tr>
+              <a:tr h="457200">
+                <a:tc>
+                  <a:txBody>
+                    <a:bodyPr/>
+                    <a:lstStyle/>
+                    <a:p>
+                      <a:r>
+                        <a:rPr sz="900" b="0"/>
+                        <a:t>2-3</a:t>
+                      </a:r>
+                    </a:p>
+                  </a:txBody>
+                  <a:tcPr marT="9144" marB="9144"/>
+                </a:tc>
+                <a:tc>
+                  <a:txBody>
+                    <a:bodyPr/>
+                    <a:lstStyle/>
+                    <a:p>
+                      <a:r>
+                        <a:rPr sz="900" b="0"/>
+                        <a:t>elderly_disabled_i &gt; 0.500 &amp; married &lt;= 0.500 &amp; rawben_rel_max &gt; 0.996 &amp; unc_rawben_rel_max &gt; 1.550</a:t>
+                      </a:r>
+                    </a:p>
+                  </a:txBody>
+                  <a:tcPr marT="9144" marB="9144"/>
+                </a:tc>
+                <a:tc>
+                  <a:txBody>
+                    <a:bodyPr/>
+                    <a:lstStyle/>
+                    <a:p>
+                      <a:r>
+                        <a:rPr sz="900" b="0"/>
+                        <a:t>8</a:t>
+                      </a:r>
+                    </a:p>
+                  </a:txBody>
+                  <a:tcPr marT="9144" marB="9144"/>
+                </a:tc>
+              </a:tr>
+              <a:tr h="457200">
+                <a:tc>
+                  <a:txBody>
+                    <a:bodyPr/>
+                    <a:lstStyle/>
+                    <a:p>
+                      <a:r>
+                        <a:rPr sz="900" b="0"/>
+                        <a:t>4+</a:t>
+                      </a:r>
+                    </a:p>
+                  </a:txBody>
+                  <a:tcPr marT="9144" marB="9144"/>
+                </a:tc>
+                <a:tc>
+                  <a:txBody>
+                    <a:bodyPr/>
+                    <a:lstStyle/>
+                    <a:p>
+                      <a:r>
+                        <a:rPr sz="900" b="0"/>
+                        <a:t>HH_size_n &gt; 4.500 &amp; rawben_rel_max &gt; 0.478 &amp; total_deductions_by_hh_size &gt; 233.000 &amp; unc_rawben_rel_max &lt;= 0.997</a:t>
+                      </a:r>
+                    </a:p>
+                  </a:txBody>
+                  <a:tcPr marT="9144" marB="9144"/>
+                </a:tc>
+                <a:tc>
+                  <a:txBody>
+                    <a:bodyPr/>
+                    <a:lstStyle/>
+                    <a:p>
+                      <a:r>
+                        <a:rPr sz="900" b="0"/>
+                        <a:t>12</a:t>
+                      </a:r>
+                    </a:p>
+                  </a:txBody>
+                  <a:tcPr marT="9144" marB="9144"/>
+                </a:tc>
+              </a:tr>
+              <a:tr h="457200">
+                <a:tc>
+                  <a:txBody>
+                    <a:bodyPr/>
+                    <a:lstStyle/>
+                    <a:p>
+                      <a:r>
+                        <a:rPr sz="900" b="0"/>
+                        <a:t>4+</a:t>
+                      </a:r>
+                    </a:p>
+                  </a:txBody>
+                  <a:tcPr marT="9144" marB="9144"/>
+                </a:tc>
+                <a:tc>
+                  <a:txBody>
+                    <a:bodyPr/>
+                    <a:lstStyle/>
+                    <a:p>
+                      <a:r>
+                        <a:rPr sz="900" b="0"/>
+                        <a:t>months_since_cert_n &gt; 5.500 &amp; rawben_rel_max &lt;= 0.997 &amp; shelter_expenses_by_hh_size &lt;= 494.000 &amp; total_deductions_by_hh_size &gt; 227.000</a:t>
+                      </a:r>
+                    </a:p>
+                  </a:txBody>
+                  <a:tcPr marT="9144" marB="9144"/>
+                </a:tc>
+                <a:tc>
+                  <a:txBody>
+                    <a:bodyPr/>
+                    <a:lstStyle/>
+                    <a:p>
+                      <a:r>
+                        <a:rPr sz="900" b="0"/>
+                        <a:t>9</a:t>
+                      </a:r>
+                    </a:p>
+                  </a:txBody>
+                  <a:tcPr marT="9144" marB="9144"/>
+                </a:tc>
+              </a:tr>
+              <a:tr h="457200">
+                <a:tc>
+                  <a:txBody>
+                    <a:bodyPr/>
+                    <a:lstStyle/>
+                    <a:p>
+                      <a:r>
+                        <a:rPr sz="900" b="0"/>
+                        <a:t>4+</a:t>
+                      </a:r>
+                    </a:p>
+                  </a:txBody>
+                  <a:tcPr marT="9144" marB="9144"/>
+                </a:tc>
+                <a:tc>
+                  <a:txBody>
+                    <a:bodyPr/>
+                    <a:lstStyle/>
+                    <a:p>
+                      <a:r>
+                        <a:rPr sz="900" b="0"/>
+                        <a:t>HH_size_n &gt; 4.500 &amp; months_since_cert_n &gt; 4.500 &amp; rawben_rel_max &lt;= 0.988 &amp; total_deductions_by_hh_size &gt; 206.000</a:t>
+                      </a:r>
+                    </a:p>
+                  </a:txBody>
+                  <a:tcPr marT="9144" marB="9144"/>
+                </a:tc>
+                <a:tc>
+                  <a:txBody>
+                    <a:bodyPr/>
+                    <a:lstStyle/>
+                    <a:p>
+                      <a:r>
+                        <a:rPr sz="900" b="0"/>
+                        <a:t>9</a:t>
+                      </a:r>
+                    </a:p>
+                  </a:txBody>
+                  <a:tcPr marT="9144" marB="9144"/>
+                </a:tc>
+              </a:tr>
+            </a:tbl>
+          </a:graphicData>
+        </a:graphic>
+      </p:graphicFrame>
     </p:spTree>
   </p:cSld>
   <p:clrMapOvr>
@@ -15583,7 +15988,7 @@
           <a:p>
             <a:r>
               <a:rPr sz="2200" b="1"/>
-              <a:t>Freeze each state's list in advance: it costs almost nothing</a:t>
+              <a:t>The deliverable: one ranked rule list per state, walked to capacity</a:t>
             </a:r>
           </a:p>
         </p:txBody>
@@ -15617,7 +16022,7 @@
             </a:pPr>
             <a:r>
               <a:rPr sz="1200"/>
-              <a:t>- The frozen list (built on 2022-23, walked to capacity on 2024) against the full national pool applied at once to the realized 2024 caseload - both at identical review volume.</a:t>
+              <a:t>- Built in advance from public data alone: fill the national pool (mined on all states' 2022-23) against the state's own 2022-23 caseload, in confidence order, until the review budget is reached - then keep filling to 3x that depth. The extra rules are ranked BUFFER rules, shipped in the same list.</a:t>
             </a:r>
           </a:p>
           <a:p>
@@ -15628,7 +16033,29 @@
             </a:pPr>
             <a:r>
               <a:rPr sz="1200"/>
-              <a:t>- Median precision 0.294 vs 0.301 (5% budget) and 0.270 vs 0.275 (10%); error dollars 12% vs 16% and 25% vs 25%. All 18 states clear their base rate.</a:t>
+              <a:t>- To use it, the state activates rules in order, checking only its own flag counts: keep adding while reviews fit capacity. No error outcomes are needed at any step.</a:t>
+            </a:r>
+          </a:p>
+          <a:p>
+            <a:pPr>
+              <a:spcAft>
+                <a:spcPts val="400"/>
+              </a:spcAft>
+            </a:pPr>
+            <a:r>
+              <a:rPr sz="1200"/>
+              <a:t>- The buffer is what makes the workload land on budget as patterns change: a state never stops reviewing because a list ran dry, and an over-firing list trims the same way. Raw core lists drifted to 2.3-12% of caseload on 2024; the walked lists land at 4.9-5.0% and 9.3-10.0% in all 18 states.</a:t>
+            </a:r>
+          </a:p>
+          <a:p>
+            <a:pPr>
+              <a:spcAft>
+                <a:spcPts val="400"/>
+              </a:spcAft>
+            </a:pPr>
+            <a:r>
+              <a:rPr sz="1200"/>
+              <a:t>- Median rules actually activated: 23 at a 5% budget, 42 at 10%. Validation recipe: we freeze on public data through the latest year; the state validates on its own newer internal data before relying on it.</a:t>
             </a:r>
           </a:p>
         </p:txBody>
@@ -15662,30 +16089,6 @@
           </a:p>
         </p:txBody>
       </p:sp>
-      <p:pic>
-        <p:nvPicPr>
-          <p:cNvPr id="5" name="Picture 4" descr="frozen_lists_panels_budget10.png"/>
-          <p:cNvPicPr>
-            <a:picLocks noChangeAspect="1"/>
-          </p:cNvPicPr>
-          <p:nvPr/>
-        </p:nvPicPr>
-        <p:blipFill>
-          <a:blip r:embed="rId2"/>
-          <a:stretch>
-            <a:fillRect/>
-          </a:stretch>
-        </p:blipFill>
-        <p:spPr>
-          <a:xfrm>
-            <a:off x="3073645" y="1984248"/>
-            <a:ext cx="2996709" cy="2633471"/>
-          </a:xfrm>
-          <a:prstGeom prst="rect">
-            <a:avLst/>
-          </a:prstGeom>
-        </p:spPr>
-      </p:pic>
     </p:spTree>
   </p:cSld>
   <p:clrMapOvr>
@@ -15728,7 +16131,7 @@
           <a:p>
             <a:r>
               <a:rPr sz="2200" b="1"/>
-              <a:t>What a state is handed under the two-regime rule</a:t>
+              <a:t>Freeze each state's list in advance: it costs almost nothing</a:t>
             </a:r>
           </a:p>
         </p:txBody>
@@ -15762,7 +16165,7 @@
             </a:pPr>
             <a:r>
               <a:rPr sz="1200"/>
-              <a:t>- One ranked list per state (core sized to the budget + buffer to 3x depth), from the national pool by default or the state's own mined pool where its own rules win on 2024. 'Typically run' = rules actually activated before 2024 capacity filled.</a:t>
+              <a:t>- The frozen list (built on 2022-23, walked to capacity on 2024) against the full national pool applied at once to the realized 2024 caseload - both at identical review volume.</a:t>
             </a:r>
           </a:p>
           <a:p>
@@ -15773,7 +16176,7 @@
             </a:pPr>
             <a:r>
               <a:rPr sz="1200"/>
-              <a:t>- Own rules are the FALLBACK regime, not a co-equal choice: the public files show only 43-81% of a state's error cases, so where they disagree with the national list, only the state's own internal validation can settle which is really better.</a:t>
+              <a:t>- Median precision 0.294 vs 0.301 (5% budget) and 0.270 vs 0.275 (10%); error dollars 12% vs 16% and 25% vs 25%. All 18 states clear their base rate.</a:t>
             </a:r>
           </a:p>
         </p:txBody>
@@ -15807,1804 +16210,30 @@
           </a:p>
         </p:txBody>
       </p:sp>
-      <p:graphicFrame>
-        <p:nvGraphicFramePr>
-          <p:cNvPr id="5" name="Table 4"/>
-          <p:cNvGraphicFramePr>
-            <a:graphicFrameLocks noGrp="1"/>
-          </p:cNvGraphicFramePr>
+      <p:pic>
+        <p:nvPicPr>
+          <p:cNvPr id="5" name="Picture 4" descr="frozen_lists_panels_budget10.png"/>
+          <p:cNvPicPr>
+            <a:picLocks noChangeAspect="1"/>
+          </p:cNvPicPr>
           <p:nvPr/>
-        </p:nvGraphicFramePr>
-        <p:xfrm>
-          <a:off x="365760" y="2496312"/>
-          <a:ext cx="8412480" cy="3648456"/>
-        </p:xfrm>
-        <a:graphic>
-          <a:graphicData uri="http://schemas.openxmlformats.org/drawingml/2006/table">
-            <a:tbl>
-              <a:tblPr firstRow="1" bandRow="1">
-                <a:tableStyleId>{5C22544A-7EE6-4342-B048-85BDC9FD1C3A}</a:tableStyleId>
-              </a:tblPr>
-              <a:tblGrid>
-                <a:gridCol w="1201782"/>
-                <a:gridCol w="1201782"/>
-                <a:gridCol w="1201782"/>
-                <a:gridCol w="1201782"/>
-                <a:gridCol w="1201782"/>
-                <a:gridCol w="1201782"/>
-                <a:gridCol w="1201788"/>
-              </a:tblGrid>
-              <a:tr h="192024">
-                <a:tc>
-                  <a:txBody>
-                    <a:bodyPr/>
-                    <a:lstStyle/>
-                    <a:p>
-                      <a:r>
-                        <a:rPr sz="900" b="1"/>
-                        <a:t>state</a:t>
-                      </a:r>
-                    </a:p>
-                  </a:txBody>
-                  <a:tcPr marT="9144" marB="9144"/>
-                </a:tc>
-                <a:tc>
-                  <a:txBody>
-                    <a:bodyPr/>
-                    <a:lstStyle/>
-                    <a:p>
-                      <a:r>
-                        <a:rPr sz="900" b="1"/>
-                        <a:t>regime (5%)</a:t>
-                      </a:r>
-                    </a:p>
-                  </a:txBody>
-                  <a:tcPr marT="9144" marB="9144"/>
-                </a:tc>
-                <a:tc>
-                  <a:txBody>
-                    <a:bodyPr/>
-                    <a:lstStyle/>
-                    <a:p>
-                      <a:r>
-                        <a:rPr sz="900" b="1"/>
-                        <a:t>rules handed (5%)</a:t>
-                      </a:r>
-                    </a:p>
-                  </a:txBody>
-                  <a:tcPr marT="9144" marB="9144"/>
-                </a:tc>
-                <a:tc>
-                  <a:txBody>
-                    <a:bodyPr/>
-                    <a:lstStyle/>
-                    <a:p>
-                      <a:r>
-                        <a:rPr sz="900" b="1"/>
-                        <a:t>typically run (5%)</a:t>
-                      </a:r>
-                    </a:p>
-                  </a:txBody>
-                  <a:tcPr marT="9144" marB="9144"/>
-                </a:tc>
-                <a:tc>
-                  <a:txBody>
-                    <a:bodyPr/>
-                    <a:lstStyle/>
-                    <a:p>
-                      <a:r>
-                        <a:rPr sz="900" b="1"/>
-                        <a:t>regime (10%)</a:t>
-                      </a:r>
-                    </a:p>
-                  </a:txBody>
-                  <a:tcPr marT="9144" marB="9144"/>
-                </a:tc>
-                <a:tc>
-                  <a:txBody>
-                    <a:bodyPr/>
-                    <a:lstStyle/>
-                    <a:p>
-                      <a:r>
-                        <a:rPr sz="900" b="1"/>
-                        <a:t>rules handed (10%)</a:t>
-                      </a:r>
-                    </a:p>
-                  </a:txBody>
-                  <a:tcPr marT="9144" marB="9144"/>
-                </a:tc>
-                <a:tc>
-                  <a:txBody>
-                    <a:bodyPr/>
-                    <a:lstStyle/>
-                    <a:p>
-                      <a:r>
-                        <a:rPr sz="900" b="1"/>
-                        <a:t>typically run (10%)</a:t>
-                      </a:r>
-                    </a:p>
-                  </a:txBody>
-                  <a:tcPr marT="9144" marB="9144"/>
-                </a:tc>
-              </a:tr>
-              <a:tr h="192024">
-                <a:tc>
-                  <a:txBody>
-                    <a:bodyPr/>
-                    <a:lstStyle/>
-                    <a:p>
-                      <a:r>
-                        <a:rPr sz="900" b="0"/>
-                        <a:t>Arizona</a:t>
-                      </a:r>
-                    </a:p>
-                  </a:txBody>
-                  <a:tcPr marT="9144" marB="9144"/>
-                </a:tc>
-                <a:tc>
-                  <a:txBody>
-                    <a:bodyPr/>
-                    <a:lstStyle/>
-                    <a:p>
-                      <a:r>
-                        <a:rPr sz="900" b="0"/>
-                        <a:t>national</a:t>
-                      </a:r>
-                    </a:p>
-                  </a:txBody>
-                  <a:tcPr marT="9144" marB="9144"/>
-                </a:tc>
-                <a:tc>
-                  <a:txBody>
-                    <a:bodyPr/>
-                    <a:lstStyle/>
-                    <a:p>
-                      <a:r>
-                        <a:rPr sz="900" b="0"/>
-                        <a:t>99</a:t>
-                      </a:r>
-                    </a:p>
-                  </a:txBody>
-                  <a:tcPr marT="9144" marB="9144"/>
-                </a:tc>
-                <a:tc>
-                  <a:txBody>
-                    <a:bodyPr/>
-                    <a:lstStyle/>
-                    <a:p>
-                      <a:r>
-                        <a:rPr sz="900" b="0"/>
-                        <a:t>18</a:t>
-                      </a:r>
-                    </a:p>
-                  </a:txBody>
-                  <a:tcPr marT="9144" marB="9144"/>
-                </a:tc>
-                <a:tc>
-                  <a:txBody>
-                    <a:bodyPr/>
-                    <a:lstStyle/>
-                    <a:p>
-                      <a:r>
-                        <a:rPr sz="900" b="0"/>
-                        <a:t>own rules</a:t>
-                      </a:r>
-                    </a:p>
-                  </a:txBody>
-                  <a:tcPr marT="9144" marB="9144"/>
-                </a:tc>
-                <a:tc>
-                  <a:txBody>
-                    <a:bodyPr/>
-                    <a:lstStyle/>
-                    <a:p>
-                      <a:r>
-                        <a:rPr sz="900" b="0"/>
-                        <a:t>147</a:t>
-                      </a:r>
-                    </a:p>
-                  </a:txBody>
-                  <a:tcPr marT="9144" marB="9144"/>
-                </a:tc>
-                <a:tc>
-                  <a:txBody>
-                    <a:bodyPr/>
-                    <a:lstStyle/>
-                    <a:p>
-                      <a:r>
-                        <a:rPr sz="900" b="0"/>
-                        <a:t>29</a:t>
-                      </a:r>
-                    </a:p>
-                  </a:txBody>
-                  <a:tcPr marT="9144" marB="9144"/>
-                </a:tc>
-              </a:tr>
-              <a:tr h="192024">
-                <a:tc>
-                  <a:txBody>
-                    <a:bodyPr/>
-                    <a:lstStyle/>
-                    <a:p>
-                      <a:r>
-                        <a:rPr sz="900" b="0"/>
-                        <a:t>California</a:t>
-                      </a:r>
-                    </a:p>
-                  </a:txBody>
-                  <a:tcPr marT="9144" marB="9144"/>
-                </a:tc>
-                <a:tc>
-                  <a:txBody>
-                    <a:bodyPr/>
-                    <a:lstStyle/>
-                    <a:p>
-                      <a:r>
-                        <a:rPr sz="900" b="0"/>
-                        <a:t>national</a:t>
-                      </a:r>
-                    </a:p>
-                  </a:txBody>
-                  <a:tcPr marT="9144" marB="9144"/>
-                </a:tc>
-                <a:tc>
-                  <a:txBody>
-                    <a:bodyPr/>
-                    <a:lstStyle/>
-                    <a:p>
-                      <a:r>
-                        <a:rPr sz="900" b="0"/>
-                        <a:t>93</a:t>
-                      </a:r>
-                    </a:p>
-                  </a:txBody>
-                  <a:tcPr marT="9144" marB="9144"/>
-                </a:tc>
-                <a:tc>
-                  <a:txBody>
-                    <a:bodyPr/>
-                    <a:lstStyle/>
-                    <a:p>
-                      <a:r>
-                        <a:rPr sz="900" b="0"/>
-                        <a:t>20</a:t>
-                      </a:r>
-                    </a:p>
-                  </a:txBody>
-                  <a:tcPr marT="9144" marB="9144"/>
-                </a:tc>
-                <a:tc>
-                  <a:txBody>
-                    <a:bodyPr/>
-                    <a:lstStyle/>
-                    <a:p>
-                      <a:r>
-                        <a:rPr sz="900" b="0"/>
-                        <a:t>own rules</a:t>
-                      </a:r>
-                    </a:p>
-                  </a:txBody>
-                  <a:tcPr marT="9144" marB="9144"/>
-                </a:tc>
-                <a:tc>
-                  <a:txBody>
-                    <a:bodyPr/>
-                    <a:lstStyle/>
-                    <a:p>
-                      <a:r>
-                        <a:rPr sz="900" b="0"/>
-                        <a:t>81</a:t>
-                      </a:r>
-                    </a:p>
-                  </a:txBody>
-                  <a:tcPr marT="9144" marB="9144"/>
-                </a:tc>
-                <a:tc>
-                  <a:txBody>
-                    <a:bodyPr/>
-                    <a:lstStyle/>
-                    <a:p>
-                      <a:r>
-                        <a:rPr sz="900" b="0"/>
-                        <a:t>14</a:t>
-                      </a:r>
-                    </a:p>
-                  </a:txBody>
-                  <a:tcPr marT="9144" marB="9144"/>
-                </a:tc>
-              </a:tr>
-              <a:tr h="192024">
-                <a:tc>
-                  <a:txBody>
-                    <a:bodyPr/>
-                    <a:lstStyle/>
-                    <a:p>
-                      <a:r>
-                        <a:rPr sz="900" b="0"/>
-                        <a:t>Colorado</a:t>
-                      </a:r>
-                    </a:p>
-                  </a:txBody>
-                  <a:tcPr marT="9144" marB="9144"/>
-                </a:tc>
-                <a:tc>
-                  <a:txBody>
-                    <a:bodyPr/>
-                    <a:lstStyle/>
-                    <a:p>
-                      <a:r>
-                        <a:rPr sz="900" b="0"/>
-                        <a:t>national</a:t>
-                      </a:r>
-                    </a:p>
-                  </a:txBody>
-                  <a:tcPr marT="9144" marB="9144"/>
-                </a:tc>
-                <a:tc>
-                  <a:txBody>
-                    <a:bodyPr/>
-                    <a:lstStyle/>
-                    <a:p>
-                      <a:r>
-                        <a:rPr sz="900" b="0"/>
-                        <a:t>136</a:t>
-                      </a:r>
-                    </a:p>
-                  </a:txBody>
-                  <a:tcPr marT="9144" marB="9144"/>
-                </a:tc>
-                <a:tc>
-                  <a:txBody>
-                    <a:bodyPr/>
-                    <a:lstStyle/>
-                    <a:p>
-                      <a:r>
-                        <a:rPr sz="900" b="0"/>
-                        <a:t>26</a:t>
-                      </a:r>
-                    </a:p>
-                  </a:txBody>
-                  <a:tcPr marT="9144" marB="9144"/>
-                </a:tc>
-                <a:tc>
-                  <a:txBody>
-                    <a:bodyPr/>
-                    <a:lstStyle/>
-                    <a:p>
-                      <a:r>
-                        <a:rPr sz="900" b="0"/>
-                        <a:t>national</a:t>
-                      </a:r>
-                    </a:p>
-                  </a:txBody>
-                  <a:tcPr marT="9144" marB="9144"/>
-                </a:tc>
-                <a:tc>
-                  <a:txBody>
-                    <a:bodyPr/>
-                    <a:lstStyle/>
-                    <a:p>
-                      <a:r>
-                        <a:rPr sz="900" b="0"/>
-                        <a:t>264</a:t>
-                      </a:r>
-                    </a:p>
-                  </a:txBody>
-                  <a:tcPr marT="9144" marB="9144"/>
-                </a:tc>
-                <a:tc>
-                  <a:txBody>
-                    <a:bodyPr/>
-                    <a:lstStyle/>
-                    <a:p>
-                      <a:r>
-                        <a:rPr sz="900" b="0"/>
-                        <a:t>44</a:t>
-                      </a:r>
-                    </a:p>
-                  </a:txBody>
-                  <a:tcPr marT="9144" marB="9144"/>
-                </a:tc>
-              </a:tr>
-              <a:tr h="192024">
-                <a:tc>
-                  <a:txBody>
-                    <a:bodyPr/>
-                    <a:lstStyle/>
-                    <a:p>
-                      <a:r>
-                        <a:rPr sz="900" b="0"/>
-                        <a:t>Connecticut</a:t>
-                      </a:r>
-                    </a:p>
-                  </a:txBody>
-                  <a:tcPr marT="9144" marB="9144"/>
-                </a:tc>
-                <a:tc>
-                  <a:txBody>
-                    <a:bodyPr/>
-                    <a:lstStyle/>
-                    <a:p>
-                      <a:r>
-                        <a:rPr sz="900" b="0"/>
-                        <a:t>own rules</a:t>
-                      </a:r>
-                    </a:p>
-                  </a:txBody>
-                  <a:tcPr marT="9144" marB="9144"/>
-                </a:tc>
-                <a:tc>
-                  <a:txBody>
-                    <a:bodyPr/>
-                    <a:lstStyle/>
-                    <a:p>
-                      <a:r>
-                        <a:rPr sz="900" b="0"/>
-                        <a:t>45</a:t>
-                      </a:r>
-                    </a:p>
-                  </a:txBody>
-                  <a:tcPr marT="9144" marB="9144"/>
-                </a:tc>
-                <a:tc>
-                  <a:txBody>
-                    <a:bodyPr/>
-                    <a:lstStyle/>
-                    <a:p>
-                      <a:r>
-                        <a:rPr sz="900" b="0"/>
-                        <a:t>8</a:t>
-                      </a:r>
-                    </a:p>
-                  </a:txBody>
-                  <a:tcPr marT="9144" marB="9144"/>
-                </a:tc>
-                <a:tc>
-                  <a:txBody>
-                    <a:bodyPr/>
-                    <a:lstStyle/>
-                    <a:p>
-                      <a:r>
-                        <a:rPr sz="900" b="0"/>
-                        <a:t>own rules</a:t>
-                      </a:r>
-                    </a:p>
-                  </a:txBody>
-                  <a:tcPr marT="9144" marB="9144"/>
-                </a:tc>
-                <a:tc>
-                  <a:txBody>
-                    <a:bodyPr/>
-                    <a:lstStyle/>
-                    <a:p>
-                      <a:r>
-                        <a:rPr sz="900" b="0"/>
-                        <a:t>107</a:t>
-                      </a:r>
-                    </a:p>
-                  </a:txBody>
-                  <a:tcPr marT="9144" marB="9144"/>
-                </a:tc>
-                <a:tc>
-                  <a:txBody>
-                    <a:bodyPr/>
-                    <a:lstStyle/>
-                    <a:p>
-                      <a:r>
-                        <a:rPr sz="900" b="0"/>
-                        <a:t>17</a:t>
-                      </a:r>
-                    </a:p>
-                  </a:txBody>
-                  <a:tcPr marT="9144" marB="9144"/>
-                </a:tc>
-              </a:tr>
-              <a:tr h="192024">
-                <a:tc>
-                  <a:txBody>
-                    <a:bodyPr/>
-                    <a:lstStyle/>
-                    <a:p>
-                      <a:r>
-                        <a:rPr sz="900" b="0"/>
-                        <a:t>District of Columbia</a:t>
-                      </a:r>
-                    </a:p>
-                  </a:txBody>
-                  <a:tcPr marT="9144" marB="9144"/>
-                </a:tc>
-                <a:tc>
-                  <a:txBody>
-                    <a:bodyPr/>
-                    <a:lstStyle/>
-                    <a:p>
-                      <a:r>
-                        <a:rPr sz="900" b="0"/>
-                        <a:t>own rules</a:t>
-                      </a:r>
-                    </a:p>
-                  </a:txBody>
-                  <a:tcPr marT="9144" marB="9144"/>
-                </a:tc>
-                <a:tc>
-                  <a:txBody>
-                    <a:bodyPr/>
-                    <a:lstStyle/>
-                    <a:p>
-                      <a:r>
-                        <a:rPr sz="900" b="0"/>
-                        <a:t>31</a:t>
-                      </a:r>
-                    </a:p>
-                  </a:txBody>
-                  <a:tcPr marT="9144" marB="9144"/>
-                </a:tc>
-                <a:tc>
-                  <a:txBody>
-                    <a:bodyPr/>
-                    <a:lstStyle/>
-                    <a:p>
-                      <a:r>
-                        <a:rPr sz="900" b="0"/>
-                        <a:t>5</a:t>
-                      </a:r>
-                    </a:p>
-                  </a:txBody>
-                  <a:tcPr marT="9144" marB="9144"/>
-                </a:tc>
-                <a:tc>
-                  <a:txBody>
-                    <a:bodyPr/>
-                    <a:lstStyle/>
-                    <a:p>
-                      <a:r>
-                        <a:rPr sz="900" b="0"/>
-                        <a:t>own rules</a:t>
-                      </a:r>
-                    </a:p>
-                  </a:txBody>
-                  <a:tcPr marT="9144" marB="9144"/>
-                </a:tc>
-                <a:tc>
-                  <a:txBody>
-                    <a:bodyPr/>
-                    <a:lstStyle/>
-                    <a:p>
-                      <a:r>
-                        <a:rPr sz="900" b="0"/>
-                        <a:t>66</a:t>
-                      </a:r>
-                    </a:p>
-                  </a:txBody>
-                  <a:tcPr marT="9144" marB="9144"/>
-                </a:tc>
-                <a:tc>
-                  <a:txBody>
-                    <a:bodyPr/>
-                    <a:lstStyle/>
-                    <a:p>
-                      <a:r>
-                        <a:rPr sz="900" b="0"/>
-                        <a:t>19</a:t>
-                      </a:r>
-                    </a:p>
-                  </a:txBody>
-                  <a:tcPr marT="9144" marB="9144"/>
-                </a:tc>
-              </a:tr>
-              <a:tr h="192024">
-                <a:tc>
-                  <a:txBody>
-                    <a:bodyPr/>
-                    <a:lstStyle/>
-                    <a:p>
-                      <a:r>
-                        <a:rPr sz="900" b="0"/>
-                        <a:t>Louisiana</a:t>
-                      </a:r>
-                    </a:p>
-                  </a:txBody>
-                  <a:tcPr marT="9144" marB="9144"/>
-                </a:tc>
-                <a:tc>
-                  <a:txBody>
-                    <a:bodyPr/>
-                    <a:lstStyle/>
-                    <a:p>
-                      <a:r>
-                        <a:rPr sz="900" b="0"/>
-                        <a:t>national</a:t>
-                      </a:r>
-                    </a:p>
-                  </a:txBody>
-                  <a:tcPr marT="9144" marB="9144"/>
-                </a:tc>
-                <a:tc>
-                  <a:txBody>
-                    <a:bodyPr/>
-                    <a:lstStyle/>
-                    <a:p>
-                      <a:r>
-                        <a:rPr sz="900" b="0"/>
-                        <a:t>112</a:t>
-                      </a:r>
-                    </a:p>
-                  </a:txBody>
-                  <a:tcPr marT="9144" marB="9144"/>
-                </a:tc>
-                <a:tc>
-                  <a:txBody>
-                    <a:bodyPr/>
-                    <a:lstStyle/>
-                    <a:p>
-                      <a:r>
-                        <a:rPr sz="900" b="0"/>
-                        <a:t>23</a:t>
-                      </a:r>
-                    </a:p>
-                  </a:txBody>
-                  <a:tcPr marT="9144" marB="9144"/>
-                </a:tc>
-                <a:tc>
-                  <a:txBody>
-                    <a:bodyPr/>
-                    <a:lstStyle/>
-                    <a:p>
-                      <a:r>
-                        <a:rPr sz="900" b="0"/>
-                        <a:t>national</a:t>
-                      </a:r>
-                    </a:p>
-                  </a:txBody>
-                  <a:tcPr marT="9144" marB="9144"/>
-                </a:tc>
-                <a:tc>
-                  <a:txBody>
-                    <a:bodyPr/>
-                    <a:lstStyle/>
-                    <a:p>
-                      <a:r>
-                        <a:rPr sz="900" b="0"/>
-                        <a:t>223</a:t>
-                      </a:r>
-                    </a:p>
-                  </a:txBody>
-                  <a:tcPr marT="9144" marB="9144"/>
-                </a:tc>
-                <a:tc>
-                  <a:txBody>
-                    <a:bodyPr/>
-                    <a:lstStyle/>
-                    <a:p>
-                      <a:r>
-                        <a:rPr sz="900" b="0"/>
-                        <a:t>42</a:t>
-                      </a:r>
-                    </a:p>
-                  </a:txBody>
-                  <a:tcPr marT="9144" marB="9144"/>
-                </a:tc>
-              </a:tr>
-              <a:tr h="192024">
-                <a:tc>
-                  <a:txBody>
-                    <a:bodyPr/>
-                    <a:lstStyle/>
-                    <a:p>
-                      <a:r>
-                        <a:rPr sz="900" b="0"/>
-                        <a:t>Maine</a:t>
-                      </a:r>
-                    </a:p>
-                  </a:txBody>
-                  <a:tcPr marT="9144" marB="9144"/>
-                </a:tc>
-                <a:tc>
-                  <a:txBody>
-                    <a:bodyPr/>
-                    <a:lstStyle/>
-                    <a:p>
-                      <a:r>
-                        <a:rPr sz="900" b="0"/>
-                        <a:t>own rules</a:t>
-                      </a:r>
-                    </a:p>
-                  </a:txBody>
-                  <a:tcPr marT="9144" marB="9144"/>
-                </a:tc>
-                <a:tc>
-                  <a:txBody>
-                    <a:bodyPr/>
-                    <a:lstStyle/>
-                    <a:p>
-                      <a:r>
-                        <a:rPr sz="900" b="0"/>
-                        <a:t>58</a:t>
-                      </a:r>
-                    </a:p>
-                  </a:txBody>
-                  <a:tcPr marT="9144" marB="9144"/>
-                </a:tc>
-                <a:tc>
-                  <a:txBody>
-                    <a:bodyPr/>
-                    <a:lstStyle/>
-                    <a:p>
-                      <a:r>
-                        <a:rPr sz="900" b="0"/>
-                        <a:t>7</a:t>
-                      </a:r>
-                    </a:p>
-                  </a:txBody>
-                  <a:tcPr marT="9144" marB="9144"/>
-                </a:tc>
-                <a:tc>
-                  <a:txBody>
-                    <a:bodyPr/>
-                    <a:lstStyle/>
-                    <a:p>
-                      <a:r>
-                        <a:rPr sz="900" b="0"/>
-                        <a:t>national</a:t>
-                      </a:r>
-                    </a:p>
-                  </a:txBody>
-                  <a:tcPr marT="9144" marB="9144"/>
-                </a:tc>
-                <a:tc>
-                  <a:txBody>
-                    <a:bodyPr/>
-                    <a:lstStyle/>
-                    <a:p>
-                      <a:r>
-                        <a:rPr sz="900" b="0"/>
-                        <a:t>276</a:t>
-                      </a:r>
-                    </a:p>
-                  </a:txBody>
-                  <a:tcPr marT="9144" marB="9144"/>
-                </a:tc>
-                <a:tc>
-                  <a:txBody>
-                    <a:bodyPr/>
-                    <a:lstStyle/>
-                    <a:p>
-                      <a:r>
-                        <a:rPr sz="900" b="0"/>
-                        <a:t>42</a:t>
-                      </a:r>
-                    </a:p>
-                  </a:txBody>
-                  <a:tcPr marT="9144" marB="9144"/>
-                </a:tc>
-              </a:tr>
-              <a:tr h="192024">
-                <a:tc>
-                  <a:txBody>
-                    <a:bodyPr/>
-                    <a:lstStyle/>
-                    <a:p>
-                      <a:r>
-                        <a:rPr sz="900" b="0"/>
-                        <a:t>Maryland</a:t>
-                      </a:r>
-                    </a:p>
-                  </a:txBody>
-                  <a:tcPr marT="9144" marB="9144"/>
-                </a:tc>
-                <a:tc>
-                  <a:txBody>
-                    <a:bodyPr/>
-                    <a:lstStyle/>
-                    <a:p>
-                      <a:r>
-                        <a:rPr sz="900" b="0"/>
-                        <a:t>own rules</a:t>
-                      </a:r>
-                    </a:p>
-                  </a:txBody>
-                  <a:tcPr marT="9144" marB="9144"/>
-                </a:tc>
-                <a:tc>
-                  <a:txBody>
-                    <a:bodyPr/>
-                    <a:lstStyle/>
-                    <a:p>
-                      <a:r>
-                        <a:rPr sz="900" b="0"/>
-                        <a:t>13</a:t>
-                      </a:r>
-                    </a:p>
-                  </a:txBody>
-                  <a:tcPr marT="9144" marB="9144"/>
-                </a:tc>
-                <a:tc>
-                  <a:txBody>
-                    <a:bodyPr/>
-                    <a:lstStyle/>
-                    <a:p>
-                      <a:r>
-                        <a:rPr sz="900" b="0"/>
-                        <a:t>4</a:t>
-                      </a:r>
-                    </a:p>
-                  </a:txBody>
-                  <a:tcPr marT="9144" marB="9144"/>
-                </a:tc>
-                <a:tc>
-                  <a:txBody>
-                    <a:bodyPr/>
-                    <a:lstStyle/>
-                    <a:p>
-                      <a:r>
-                        <a:rPr sz="900" b="0"/>
-                        <a:t>own rules</a:t>
-                      </a:r>
-                    </a:p>
-                  </a:txBody>
-                  <a:tcPr marT="9144" marB="9144"/>
-                </a:tc>
-                <a:tc>
-                  <a:txBody>
-                    <a:bodyPr/>
-                    <a:lstStyle/>
-                    <a:p>
-                      <a:r>
-                        <a:rPr sz="900" b="0"/>
-                        <a:t>72</a:t>
-                      </a:r>
-                    </a:p>
-                  </a:txBody>
-                  <a:tcPr marT="9144" marB="9144"/>
-                </a:tc>
-                <a:tc>
-                  <a:txBody>
-                    <a:bodyPr/>
-                    <a:lstStyle/>
-                    <a:p>
-                      <a:r>
-                        <a:rPr sz="900" b="0"/>
-                        <a:t>8</a:t>
-                      </a:r>
-                    </a:p>
-                  </a:txBody>
-                  <a:tcPr marT="9144" marB="9144"/>
-                </a:tc>
-              </a:tr>
-              <a:tr h="192024">
-                <a:tc>
-                  <a:txBody>
-                    <a:bodyPr/>
-                    <a:lstStyle/>
-                    <a:p>
-                      <a:r>
-                        <a:rPr sz="900" b="0"/>
-                        <a:t>Massachusetts</a:t>
-                      </a:r>
-                    </a:p>
-                  </a:txBody>
-                  <a:tcPr marT="9144" marB="9144"/>
-                </a:tc>
-                <a:tc>
-                  <a:txBody>
-                    <a:bodyPr/>
-                    <a:lstStyle/>
-                    <a:p>
-                      <a:r>
-                        <a:rPr sz="900" b="0"/>
-                        <a:t>national</a:t>
-                      </a:r>
-                    </a:p>
-                  </a:txBody>
-                  <a:tcPr marT="9144" marB="9144"/>
-                </a:tc>
-                <a:tc>
-                  <a:txBody>
-                    <a:bodyPr/>
-                    <a:lstStyle/>
-                    <a:p>
-                      <a:r>
-                        <a:rPr sz="900" b="0"/>
-                        <a:t>137</a:t>
-                      </a:r>
-                    </a:p>
-                  </a:txBody>
-                  <a:tcPr marT="9144" marB="9144"/>
-                </a:tc>
-                <a:tc>
-                  <a:txBody>
-                    <a:bodyPr/>
-                    <a:lstStyle/>
-                    <a:p>
-                      <a:r>
-                        <a:rPr sz="900" b="0"/>
-                        <a:t>20</a:t>
-                      </a:r>
-                    </a:p>
-                  </a:txBody>
-                  <a:tcPr marT="9144" marB="9144"/>
-                </a:tc>
-                <a:tc>
-                  <a:txBody>
-                    <a:bodyPr/>
-                    <a:lstStyle/>
-                    <a:p>
-                      <a:r>
-                        <a:rPr sz="900" b="0"/>
-                        <a:t>national</a:t>
-                      </a:r>
-                    </a:p>
-                  </a:txBody>
-                  <a:tcPr marT="9144" marB="9144"/>
-                </a:tc>
-                <a:tc>
-                  <a:txBody>
-                    <a:bodyPr/>
-                    <a:lstStyle/>
-                    <a:p>
-                      <a:r>
-                        <a:rPr sz="900" b="0"/>
-                        <a:t>262</a:t>
-                      </a:r>
-                    </a:p>
-                  </a:txBody>
-                  <a:tcPr marT="9144" marB="9144"/>
-                </a:tc>
-                <a:tc>
-                  <a:txBody>
-                    <a:bodyPr/>
-                    <a:lstStyle/>
-                    <a:p>
-                      <a:r>
-                        <a:rPr sz="900" b="0"/>
-                        <a:t>38</a:t>
-                      </a:r>
-                    </a:p>
-                  </a:txBody>
-                  <a:tcPr marT="9144" marB="9144"/>
-                </a:tc>
-              </a:tr>
-              <a:tr h="192024">
-                <a:tc>
-                  <a:txBody>
-                    <a:bodyPr/>
-                    <a:lstStyle/>
-                    <a:p>
-                      <a:r>
-                        <a:rPr sz="900" b="0"/>
-                        <a:t>Michigan</a:t>
-                      </a:r>
-                    </a:p>
-                  </a:txBody>
-                  <a:tcPr marT="9144" marB="9144"/>
-                </a:tc>
-                <a:tc>
-                  <a:txBody>
-                    <a:bodyPr/>
-                    <a:lstStyle/>
-                    <a:p>
-                      <a:r>
-                        <a:rPr sz="900" b="0"/>
-                        <a:t>national</a:t>
-                      </a:r>
-                    </a:p>
-                  </a:txBody>
-                  <a:tcPr marT="9144" marB="9144"/>
-                </a:tc>
-                <a:tc>
-                  <a:txBody>
-                    <a:bodyPr/>
-                    <a:lstStyle/>
-                    <a:p>
-                      <a:r>
-                        <a:rPr sz="900" b="0"/>
-                        <a:t>125</a:t>
-                      </a:r>
-                    </a:p>
-                  </a:txBody>
-                  <a:tcPr marT="9144" marB="9144"/>
-                </a:tc>
-                <a:tc>
-                  <a:txBody>
-                    <a:bodyPr/>
-                    <a:lstStyle/>
-                    <a:p>
-                      <a:r>
-                        <a:rPr sz="900" b="0"/>
-                        <a:t>25</a:t>
-                      </a:r>
-                    </a:p>
-                  </a:txBody>
-                  <a:tcPr marT="9144" marB="9144"/>
-                </a:tc>
-                <a:tc>
-                  <a:txBody>
-                    <a:bodyPr/>
-                    <a:lstStyle/>
-                    <a:p>
-                      <a:r>
-                        <a:rPr sz="900" b="0"/>
-                        <a:t>national</a:t>
-                      </a:r>
-                    </a:p>
-                  </a:txBody>
-                  <a:tcPr marT="9144" marB="9144"/>
-                </a:tc>
-                <a:tc>
-                  <a:txBody>
-                    <a:bodyPr/>
-                    <a:lstStyle/>
-                    <a:p>
-                      <a:r>
-                        <a:rPr sz="900" b="0"/>
-                        <a:t>238</a:t>
-                      </a:r>
-                    </a:p>
-                  </a:txBody>
-                  <a:tcPr marT="9144" marB="9144"/>
-                </a:tc>
-                <a:tc>
-                  <a:txBody>
-                    <a:bodyPr/>
-                    <a:lstStyle/>
-                    <a:p>
-                      <a:r>
-                        <a:rPr sz="900" b="0"/>
-                        <a:t>42</a:t>
-                      </a:r>
-                    </a:p>
-                  </a:txBody>
-                  <a:tcPr marT="9144" marB="9144"/>
-                </a:tc>
-              </a:tr>
-              <a:tr h="192024">
-                <a:tc>
-                  <a:txBody>
-                    <a:bodyPr/>
-                    <a:lstStyle/>
-                    <a:p>
-                      <a:r>
-                        <a:rPr sz="900" b="0"/>
-                        <a:t>Mississippi</a:t>
-                      </a:r>
-                    </a:p>
-                  </a:txBody>
-                  <a:tcPr marT="9144" marB="9144"/>
-                </a:tc>
-                <a:tc>
-                  <a:txBody>
-                    <a:bodyPr/>
-                    <a:lstStyle/>
-                    <a:p>
-                      <a:r>
-                        <a:rPr sz="900" b="0"/>
-                        <a:t>own rules</a:t>
-                      </a:r>
-                    </a:p>
-                  </a:txBody>
-                  <a:tcPr marT="9144" marB="9144"/>
-                </a:tc>
-                <a:tc>
-                  <a:txBody>
-                    <a:bodyPr/>
-                    <a:lstStyle/>
-                    <a:p>
-                      <a:r>
-                        <a:rPr sz="900" b="0"/>
-                        <a:t>43</a:t>
-                      </a:r>
-                    </a:p>
-                  </a:txBody>
-                  <a:tcPr marT="9144" marB="9144"/>
-                </a:tc>
-                <a:tc>
-                  <a:txBody>
-                    <a:bodyPr/>
-                    <a:lstStyle/>
-                    <a:p>
-                      <a:r>
-                        <a:rPr sz="900" b="0"/>
-                        <a:t>6</a:t>
-                      </a:r>
-                    </a:p>
-                  </a:txBody>
-                  <a:tcPr marT="9144" marB="9144"/>
-                </a:tc>
-                <a:tc>
-                  <a:txBody>
-                    <a:bodyPr/>
-                    <a:lstStyle/>
-                    <a:p>
-                      <a:r>
-                        <a:rPr sz="900" b="0"/>
-                        <a:t>own rules</a:t>
-                      </a:r>
-                    </a:p>
-                  </a:txBody>
-                  <a:tcPr marT="9144" marB="9144"/>
-                </a:tc>
-                <a:tc>
-                  <a:txBody>
-                    <a:bodyPr/>
-                    <a:lstStyle/>
-                    <a:p>
-                      <a:r>
-                        <a:rPr sz="900" b="0"/>
-                        <a:t>107</a:t>
-                      </a:r>
-                    </a:p>
-                  </a:txBody>
-                  <a:tcPr marT="9144" marB="9144"/>
-                </a:tc>
-                <a:tc>
-                  <a:txBody>
-                    <a:bodyPr/>
-                    <a:lstStyle/>
-                    <a:p>
-                      <a:r>
-                        <a:rPr sz="900" b="0"/>
-                        <a:t>20</a:t>
-                      </a:r>
-                    </a:p>
-                  </a:txBody>
-                  <a:tcPr marT="9144" marB="9144"/>
-                </a:tc>
-              </a:tr>
-              <a:tr h="192024">
-                <a:tc>
-                  <a:txBody>
-                    <a:bodyPr/>
-                    <a:lstStyle/>
-                    <a:p>
-                      <a:r>
-                        <a:rPr sz="900" b="0"/>
-                        <a:t>Missouri</a:t>
-                      </a:r>
-                    </a:p>
-                  </a:txBody>
-                  <a:tcPr marT="9144" marB="9144"/>
-                </a:tc>
-                <a:tc>
-                  <a:txBody>
-                    <a:bodyPr/>
-                    <a:lstStyle/>
-                    <a:p>
-                      <a:r>
-                        <a:rPr sz="900" b="0"/>
-                        <a:t>national</a:t>
-                      </a:r>
-                    </a:p>
-                  </a:txBody>
-                  <a:tcPr marT="9144" marB="9144"/>
-                </a:tc>
-                <a:tc>
-                  <a:txBody>
-                    <a:bodyPr/>
-                    <a:lstStyle/>
-                    <a:p>
-                      <a:r>
-                        <a:rPr sz="900" b="0"/>
-                        <a:t>107</a:t>
-                      </a:r>
-                    </a:p>
-                  </a:txBody>
-                  <a:tcPr marT="9144" marB="9144"/>
-                </a:tc>
-                <a:tc>
-                  <a:txBody>
-                    <a:bodyPr/>
-                    <a:lstStyle/>
-                    <a:p>
-                      <a:r>
-                        <a:rPr sz="900" b="0"/>
-                        <a:t>23</a:t>
-                      </a:r>
-                    </a:p>
-                  </a:txBody>
-                  <a:tcPr marT="9144" marB="9144"/>
-                </a:tc>
-                <a:tc>
-                  <a:txBody>
-                    <a:bodyPr/>
-                    <a:lstStyle/>
-                    <a:p>
-                      <a:r>
-                        <a:rPr sz="900" b="0"/>
-                        <a:t>national</a:t>
-                      </a:r>
-                    </a:p>
-                  </a:txBody>
-                  <a:tcPr marT="9144" marB="9144"/>
-                </a:tc>
-                <a:tc>
-                  <a:txBody>
-                    <a:bodyPr/>
-                    <a:lstStyle/>
-                    <a:p>
-                      <a:r>
-                        <a:rPr sz="900" b="0"/>
-                        <a:t>203</a:t>
-                      </a:r>
-                    </a:p>
-                  </a:txBody>
-                  <a:tcPr marT="9144" marB="9144"/>
-                </a:tc>
-                <a:tc>
-                  <a:txBody>
-                    <a:bodyPr/>
-                    <a:lstStyle/>
-                    <a:p>
-                      <a:r>
-                        <a:rPr sz="900" b="0"/>
-                        <a:t>44</a:t>
-                      </a:r>
-                    </a:p>
-                  </a:txBody>
-                  <a:tcPr marT="9144" marB="9144"/>
-                </a:tc>
-              </a:tr>
-              <a:tr h="192024">
-                <a:tc>
-                  <a:txBody>
-                    <a:bodyPr/>
-                    <a:lstStyle/>
-                    <a:p>
-                      <a:r>
-                        <a:rPr sz="900" b="0"/>
-                        <a:t>New Jersey</a:t>
-                      </a:r>
-                    </a:p>
-                  </a:txBody>
-                  <a:tcPr marT="9144" marB="9144"/>
-                </a:tc>
-                <a:tc>
-                  <a:txBody>
-                    <a:bodyPr/>
-                    <a:lstStyle/>
-                    <a:p>
-                      <a:r>
-                        <a:rPr sz="900" b="0"/>
-                        <a:t>own rules</a:t>
-                      </a:r>
-                    </a:p>
-                  </a:txBody>
-                  <a:tcPr marT="9144" marB="9144"/>
-                </a:tc>
-                <a:tc>
-                  <a:txBody>
-                    <a:bodyPr/>
-                    <a:lstStyle/>
-                    <a:p>
-                      <a:r>
-                        <a:rPr sz="900" b="0"/>
-                        <a:t>20</a:t>
-                      </a:r>
-                    </a:p>
-                  </a:txBody>
-                  <a:tcPr marT="9144" marB="9144"/>
-                </a:tc>
-                <a:tc>
-                  <a:txBody>
-                    <a:bodyPr/>
-                    <a:lstStyle/>
-                    <a:p>
-                      <a:r>
-                        <a:rPr sz="900" b="0"/>
-                        <a:t>2</a:t>
-                      </a:r>
-                    </a:p>
-                  </a:txBody>
-                  <a:tcPr marT="9144" marB="9144"/>
-                </a:tc>
-                <a:tc>
-                  <a:txBody>
-                    <a:bodyPr/>
-                    <a:lstStyle/>
-                    <a:p>
-                      <a:r>
-                        <a:rPr sz="900" b="0"/>
-                        <a:t>own rules</a:t>
-                      </a:r>
-                    </a:p>
-                  </a:txBody>
-                  <a:tcPr marT="9144" marB="9144"/>
-                </a:tc>
-                <a:tc>
-                  <a:txBody>
-                    <a:bodyPr/>
-                    <a:lstStyle/>
-                    <a:p>
-                      <a:r>
-                        <a:rPr sz="900" b="0"/>
-                        <a:t>72</a:t>
-                      </a:r>
-                    </a:p>
-                  </a:txBody>
-                  <a:tcPr marT="9144" marB="9144"/>
-                </a:tc>
-                <a:tc>
-                  <a:txBody>
-                    <a:bodyPr/>
-                    <a:lstStyle/>
-                    <a:p>
-                      <a:r>
-                        <a:rPr sz="900" b="0"/>
-                        <a:t>4</a:t>
-                      </a:r>
-                    </a:p>
-                  </a:txBody>
-                  <a:tcPr marT="9144" marB="9144"/>
-                </a:tc>
-              </a:tr>
-              <a:tr h="192024">
-                <a:tc>
-                  <a:txBody>
-                    <a:bodyPr/>
-                    <a:lstStyle/>
-                    <a:p>
-                      <a:r>
-                        <a:rPr sz="900" b="0"/>
-                        <a:t>North Carolina</a:t>
-                      </a:r>
-                    </a:p>
-                  </a:txBody>
-                  <a:tcPr marT="9144" marB="9144"/>
-                </a:tc>
-                <a:tc>
-                  <a:txBody>
-                    <a:bodyPr/>
-                    <a:lstStyle/>
-                    <a:p>
-                      <a:r>
-                        <a:rPr sz="900" b="0"/>
-                        <a:t>national</a:t>
-                      </a:r>
-                    </a:p>
-                  </a:txBody>
-                  <a:tcPr marT="9144" marB="9144"/>
-                </a:tc>
-                <a:tc>
-                  <a:txBody>
-                    <a:bodyPr/>
-                    <a:lstStyle/>
-                    <a:p>
-                      <a:r>
-                        <a:rPr sz="900" b="0"/>
-                        <a:t>148</a:t>
-                      </a:r>
-                    </a:p>
-                  </a:txBody>
-                  <a:tcPr marT="9144" marB="9144"/>
-                </a:tc>
-                <a:tc>
-                  <a:txBody>
-                    <a:bodyPr/>
-                    <a:lstStyle/>
-                    <a:p>
-                      <a:r>
-                        <a:rPr sz="900" b="0"/>
-                        <a:t>27</a:t>
-                      </a:r>
-                    </a:p>
-                  </a:txBody>
-                  <a:tcPr marT="9144" marB="9144"/>
-                </a:tc>
-                <a:tc>
-                  <a:txBody>
-                    <a:bodyPr/>
-                    <a:lstStyle/>
-                    <a:p>
-                      <a:r>
-                        <a:rPr sz="900" b="0"/>
-                        <a:t>own rules</a:t>
-                      </a:r>
-                    </a:p>
-                  </a:txBody>
-                  <a:tcPr marT="9144" marB="9144"/>
-                </a:tc>
-                <a:tc>
-                  <a:txBody>
-                    <a:bodyPr/>
-                    <a:lstStyle/>
-                    <a:p>
-                      <a:r>
-                        <a:rPr sz="900" b="0"/>
-                        <a:t>70</a:t>
-                      </a:r>
-                    </a:p>
-                  </a:txBody>
-                  <a:tcPr marT="9144" marB="9144"/>
-                </a:tc>
-                <a:tc>
-                  <a:txBody>
-                    <a:bodyPr/>
-                    <a:lstStyle/>
-                    <a:p>
-                      <a:r>
-                        <a:rPr sz="900" b="0"/>
-                        <a:t>12</a:t>
-                      </a:r>
-                    </a:p>
-                  </a:txBody>
-                  <a:tcPr marT="9144" marB="9144"/>
-                </a:tc>
-              </a:tr>
-              <a:tr h="192024">
-                <a:tc>
-                  <a:txBody>
-                    <a:bodyPr/>
-                    <a:lstStyle/>
-                    <a:p>
-                      <a:r>
-                        <a:rPr sz="900" b="0"/>
-                        <a:t>Tennessee</a:t>
-                      </a:r>
-                    </a:p>
-                  </a:txBody>
-                  <a:tcPr marT="9144" marB="9144"/>
-                </a:tc>
-                <a:tc>
-                  <a:txBody>
-                    <a:bodyPr/>
-                    <a:lstStyle/>
-                    <a:p>
-                      <a:r>
-                        <a:rPr sz="900" b="0"/>
-                        <a:t>national</a:t>
-                      </a:r>
-                    </a:p>
-                  </a:txBody>
-                  <a:tcPr marT="9144" marB="9144"/>
-                </a:tc>
-                <a:tc>
-                  <a:txBody>
-                    <a:bodyPr/>
-                    <a:lstStyle/>
-                    <a:p>
-                      <a:r>
-                        <a:rPr sz="900" b="0"/>
-                        <a:t>143</a:t>
-                      </a:r>
-                    </a:p>
-                  </a:txBody>
-                  <a:tcPr marT="9144" marB="9144"/>
-                </a:tc>
-                <a:tc>
-                  <a:txBody>
-                    <a:bodyPr/>
-                    <a:lstStyle/>
-                    <a:p>
-                      <a:r>
-                        <a:rPr sz="900" b="0"/>
-                        <a:t>26</a:t>
-                      </a:r>
-                    </a:p>
-                  </a:txBody>
-                  <a:tcPr marT="9144" marB="9144"/>
-                </a:tc>
-                <a:tc>
-                  <a:txBody>
-                    <a:bodyPr/>
-                    <a:lstStyle/>
-                    <a:p>
-                      <a:r>
-                        <a:rPr sz="900" b="0"/>
-                        <a:t>national</a:t>
-                      </a:r>
-                    </a:p>
-                  </a:txBody>
-                  <a:tcPr marT="9144" marB="9144"/>
-                </a:tc>
-                <a:tc>
-                  <a:txBody>
-                    <a:bodyPr/>
-                    <a:lstStyle/>
-                    <a:p>
-                      <a:r>
-                        <a:rPr sz="900" b="0"/>
-                        <a:t>281</a:t>
-                      </a:r>
-                    </a:p>
-                  </a:txBody>
-                  <a:tcPr marT="9144" marB="9144"/>
-                </a:tc>
-                <a:tc>
-                  <a:txBody>
-                    <a:bodyPr/>
-                    <a:lstStyle/>
-                    <a:p>
-                      <a:r>
-                        <a:rPr sz="900" b="0"/>
-                        <a:t>49</a:t>
-                      </a:r>
-                    </a:p>
-                  </a:txBody>
-                  <a:tcPr marT="9144" marB="9144"/>
-                </a:tc>
-              </a:tr>
-              <a:tr h="192024">
-                <a:tc>
-                  <a:txBody>
-                    <a:bodyPr/>
-                    <a:lstStyle/>
-                    <a:p>
-                      <a:r>
-                        <a:rPr sz="900" b="0"/>
-                        <a:t>Texas</a:t>
-                      </a:r>
-                    </a:p>
-                  </a:txBody>
-                  <a:tcPr marT="9144" marB="9144"/>
-                </a:tc>
-                <a:tc>
-                  <a:txBody>
-                    <a:bodyPr/>
-                    <a:lstStyle/>
-                    <a:p>
-                      <a:r>
-                        <a:rPr sz="900" b="0"/>
-                        <a:t>own rules</a:t>
-                      </a:r>
-                    </a:p>
-                  </a:txBody>
-                  <a:tcPr marT="9144" marB="9144"/>
-                </a:tc>
-                <a:tc>
-                  <a:txBody>
-                    <a:bodyPr/>
-                    <a:lstStyle/>
-                    <a:p>
-                      <a:r>
-                        <a:rPr sz="900" b="0"/>
-                        <a:t>50</a:t>
-                      </a:r>
-                    </a:p>
-                  </a:txBody>
-                  <a:tcPr marT="9144" marB="9144"/>
-                </a:tc>
-                <a:tc>
-                  <a:txBody>
-                    <a:bodyPr/>
-                    <a:lstStyle/>
-                    <a:p>
-                      <a:r>
-                        <a:rPr sz="900" b="0"/>
-                        <a:t>2</a:t>
-                      </a:r>
-                    </a:p>
-                  </a:txBody>
-                  <a:tcPr marT="9144" marB="9144"/>
-                </a:tc>
-                <a:tc>
-                  <a:txBody>
-                    <a:bodyPr/>
-                    <a:lstStyle/>
-                    <a:p>
-                      <a:r>
-                        <a:rPr sz="900" b="0"/>
-                        <a:t>own rules</a:t>
-                      </a:r>
-                    </a:p>
-                  </a:txBody>
-                  <a:tcPr marT="9144" marB="9144"/>
-                </a:tc>
-                <a:tc>
-                  <a:txBody>
-                    <a:bodyPr/>
-                    <a:lstStyle/>
-                    <a:p>
-                      <a:r>
-                        <a:rPr sz="900" b="0"/>
-                        <a:t>102</a:t>
-                      </a:r>
-                    </a:p>
-                  </a:txBody>
-                  <a:tcPr marT="9144" marB="9144"/>
-                </a:tc>
-                <a:tc>
-                  <a:txBody>
-                    <a:bodyPr/>
-                    <a:lstStyle/>
-                    <a:p>
-                      <a:r>
-                        <a:rPr sz="900" b="0"/>
-                        <a:t>10</a:t>
-                      </a:r>
-                    </a:p>
-                  </a:txBody>
-                  <a:tcPr marT="9144" marB="9144"/>
-                </a:tc>
-              </a:tr>
-              <a:tr h="192024">
-                <a:tc>
-                  <a:txBody>
-                    <a:bodyPr/>
-                    <a:lstStyle/>
-                    <a:p>
-                      <a:r>
-                        <a:rPr sz="900" b="0"/>
-                        <a:t>Virginia</a:t>
-                      </a:r>
-                    </a:p>
-                  </a:txBody>
-                  <a:tcPr marT="9144" marB="9144"/>
-                </a:tc>
-                <a:tc>
-                  <a:txBody>
-                    <a:bodyPr/>
-                    <a:lstStyle/>
-                    <a:p>
-                      <a:r>
-                        <a:rPr sz="900" b="0"/>
-                        <a:t>national</a:t>
-                      </a:r>
-                    </a:p>
-                  </a:txBody>
-                  <a:tcPr marT="9144" marB="9144"/>
-                </a:tc>
-                <a:tc>
-                  <a:txBody>
-                    <a:bodyPr/>
-                    <a:lstStyle/>
-                    <a:p>
-                      <a:r>
-                        <a:rPr sz="900" b="0"/>
-                        <a:t>90</a:t>
-                      </a:r>
-                    </a:p>
-                  </a:txBody>
-                  <a:tcPr marT="9144" marB="9144"/>
-                </a:tc>
-                <a:tc>
-                  <a:txBody>
-                    <a:bodyPr/>
-                    <a:lstStyle/>
-                    <a:p>
-                      <a:r>
-                        <a:rPr sz="900" b="0"/>
-                        <a:t>23</a:t>
-                      </a:r>
-                    </a:p>
-                  </a:txBody>
-                  <a:tcPr marT="9144" marB="9144"/>
-                </a:tc>
-                <a:tc>
-                  <a:txBody>
-                    <a:bodyPr/>
-                    <a:lstStyle/>
-                    <a:p>
-                      <a:r>
-                        <a:rPr sz="900" b="0"/>
-                        <a:t>own rules</a:t>
-                      </a:r>
-                    </a:p>
-                  </a:txBody>
-                  <a:tcPr marT="9144" marB="9144"/>
-                </a:tc>
-                <a:tc>
-                  <a:txBody>
-                    <a:bodyPr/>
-                    <a:lstStyle/>
-                    <a:p>
-                      <a:r>
-                        <a:rPr sz="900" b="0"/>
-                        <a:t>50</a:t>
-                      </a:r>
-                    </a:p>
-                  </a:txBody>
-                  <a:tcPr marT="9144" marB="9144"/>
-                </a:tc>
-                <a:tc>
-                  <a:txBody>
-                    <a:bodyPr/>
-                    <a:lstStyle/>
-                    <a:p>
-                      <a:r>
-                        <a:rPr sz="900" b="0"/>
-                        <a:t>8</a:t>
-                      </a:r>
-                    </a:p>
-                  </a:txBody>
-                  <a:tcPr marT="9144" marB="9144"/>
-                </a:tc>
-              </a:tr>
-              <a:tr h="192024">
-                <a:tc>
-                  <a:txBody>
-                    <a:bodyPr/>
-                    <a:lstStyle/>
-                    <a:p>
-                      <a:r>
-                        <a:rPr sz="900" b="0"/>
-                        <a:t>Washington</a:t>
-                      </a:r>
-                    </a:p>
-                  </a:txBody>
-                  <a:tcPr marT="9144" marB="9144"/>
-                </a:tc>
-                <a:tc>
-                  <a:txBody>
-                    <a:bodyPr/>
-                    <a:lstStyle/>
-                    <a:p>
-                      <a:r>
-                        <a:rPr sz="900" b="0"/>
-                        <a:t>national</a:t>
-                      </a:r>
-                    </a:p>
-                  </a:txBody>
-                  <a:tcPr marT="9144" marB="9144"/>
-                </a:tc>
-                <a:tc>
-                  <a:txBody>
-                    <a:bodyPr/>
-                    <a:lstStyle/>
-                    <a:p>
-                      <a:r>
-                        <a:rPr sz="900" b="0"/>
-                        <a:t>127</a:t>
-                      </a:r>
-                    </a:p>
-                  </a:txBody>
-                  <a:tcPr marT="9144" marB="9144"/>
-                </a:tc>
-                <a:tc>
-                  <a:txBody>
-                    <a:bodyPr/>
-                    <a:lstStyle/>
-                    <a:p>
-                      <a:r>
-                        <a:rPr sz="900" b="0"/>
-                        <a:t>22</a:t>
-                      </a:r>
-                    </a:p>
-                  </a:txBody>
-                  <a:tcPr marT="9144" marB="9144"/>
-                </a:tc>
-                <a:tc>
-                  <a:txBody>
-                    <a:bodyPr/>
-                    <a:lstStyle/>
-                    <a:p>
-                      <a:r>
-                        <a:rPr sz="900" b="0"/>
-                        <a:t>national</a:t>
-                      </a:r>
-                    </a:p>
-                  </a:txBody>
-                  <a:tcPr marT="9144" marB="9144"/>
-                </a:tc>
-                <a:tc>
-                  <a:txBody>
-                    <a:bodyPr/>
-                    <a:lstStyle/>
-                    <a:p>
-                      <a:r>
-                        <a:rPr sz="900" b="0"/>
-                        <a:t>249</a:t>
-                      </a:r>
-                    </a:p>
-                  </a:txBody>
-                  <a:tcPr marT="9144" marB="9144"/>
-                </a:tc>
-                <a:tc>
-                  <a:txBody>
-                    <a:bodyPr/>
-                    <a:lstStyle/>
-                    <a:p>
-                      <a:r>
-                        <a:rPr sz="900" b="0"/>
-                        <a:t>49</a:t>
-                      </a:r>
-                    </a:p>
-                  </a:txBody>
-                  <a:tcPr marT="9144" marB="9144"/>
-                </a:tc>
-              </a:tr>
-            </a:tbl>
-          </a:graphicData>
-        </a:graphic>
-      </p:graphicFrame>
+        </p:nvPicPr>
+        <p:blipFill>
+          <a:blip r:embed="rId2"/>
+          <a:stretch>
+            <a:fillRect/>
+          </a:stretch>
+        </p:blipFill>
+        <p:spPr>
+          <a:xfrm>
+            <a:off x="3073645" y="1984248"/>
+            <a:ext cx="2996709" cy="2633471"/>
+          </a:xfrm>
+          <a:prstGeom prst="rect">
+            <a:avLst/>
+          </a:prstGeom>
+        </p:spPr>
+      </p:pic>
     </p:spTree>
   </p:cSld>
   <p:clrMapOvr>
@@ -17647,6 +16276,1925 @@
           <a:p>
             <a:r>
               <a:rPr sz="2200" b="1"/>
+              <a:t>What a state is handed under the two-regime rule</a:t>
+            </a:r>
+          </a:p>
+        </p:txBody>
+      </p:sp>
+      <p:sp>
+        <p:nvSpPr>
+          <p:cNvPr id="4" name="TextBox 3"/>
+          <p:cNvSpPr txBox="1"/>
+          <p:nvPr/>
+        </p:nvSpPr>
+        <p:spPr>
+          <a:xfrm>
+            <a:off x="400000" y="760000"/>
+            <a:ext cx="8344000" cy="430000"/>
+          </a:xfrm>
+          <a:prstGeom prst="rect">
+            <a:avLst/>
+          </a:prstGeom>
+          <a:noFill/>
+        </p:spPr>
+        <p:txBody>
+          <a:bodyPr wrap="square">
+            <a:spAutoFit/>
+          </a:bodyPr>
+          <a:lstStyle/>
+          <a:p>
+            <a:pPr>
+              <a:spcAft>
+                <a:spcPts val="400"/>
+              </a:spcAft>
+            </a:pPr>
+            <a:r>
+              <a:rPr sz="1200"/>
+              <a:t>- One ranked list per state (core sized to the budget + buffer to 3x depth), from the national pool by default or the state's own mined pool where its own rules win on 2024. 'Typically run' = rules actually activated before 2024 capacity filled.</a:t>
+            </a:r>
+          </a:p>
+          <a:p>
+            <a:pPr>
+              <a:spcAft>
+                <a:spcPts val="400"/>
+              </a:spcAft>
+            </a:pPr>
+            <a:r>
+              <a:rPr sz="1200"/>
+              <a:t>- Own rules are the FALLBACK regime, not a co-equal choice: the public files show only 43-81% of a state's error cases, so where they disagree with the national list, only the state's own internal validation can settle which is really better.</a:t>
+            </a:r>
+          </a:p>
+        </p:txBody>
+      </p:sp>
+      <p:sp>
+        <p:nvSpPr>
+          <p:cNvPr id="3" name="TextBox 2"/>
+          <p:cNvSpPr txBox="1"/>
+          <p:nvPr/>
+        </p:nvSpPr>
+        <p:spPr>
+          <a:xfrm>
+            <a:off x="400000" y="4723500"/>
+            <a:ext cx="3200000" cy="320000"/>
+          </a:xfrm>
+          <a:prstGeom prst="rect">
+            <a:avLst/>
+          </a:prstGeom>
+          <a:noFill/>
+        </p:spPr>
+        <p:txBody>
+          <a:bodyPr wrap="none">
+            <a:spAutoFit/>
+          </a:bodyPr>
+          <a:lstStyle/>
+          <a:p>
+            <a:r>
+              <a:rPr sz="1000" i="1"/>
+              <a:t>SNAP QC modeling lessons - July 2026</a:t>
+            </a:r>
+          </a:p>
+        </p:txBody>
+      </p:sp>
+      <p:graphicFrame>
+        <p:nvGraphicFramePr>
+          <p:cNvPr id="5" name="Table 4"/>
+          <p:cNvGraphicFramePr>
+            <a:graphicFrameLocks noGrp="1"/>
+          </p:cNvGraphicFramePr>
+          <p:nvPr/>
+        </p:nvGraphicFramePr>
+        <p:xfrm>
+          <a:off x="365760" y="2496312"/>
+          <a:ext cx="8412480" cy="3648456"/>
+        </p:xfrm>
+        <a:graphic>
+          <a:graphicData uri="http://schemas.openxmlformats.org/drawingml/2006/table">
+            <a:tbl>
+              <a:tblPr firstRow="1" bandRow="1">
+                <a:tableStyleId>{5C22544A-7EE6-4342-B048-85BDC9FD1C3A}</a:tableStyleId>
+              </a:tblPr>
+              <a:tblGrid>
+                <a:gridCol w="1201782"/>
+                <a:gridCol w="1201782"/>
+                <a:gridCol w="1201782"/>
+                <a:gridCol w="1201782"/>
+                <a:gridCol w="1201782"/>
+                <a:gridCol w="1201782"/>
+                <a:gridCol w="1201788"/>
+              </a:tblGrid>
+              <a:tr h="192024">
+                <a:tc>
+                  <a:txBody>
+                    <a:bodyPr/>
+                    <a:lstStyle/>
+                    <a:p>
+                      <a:r>
+                        <a:rPr sz="900" b="1"/>
+                        <a:t>state</a:t>
+                      </a:r>
+                    </a:p>
+                  </a:txBody>
+                  <a:tcPr marT="9144" marB="9144"/>
+                </a:tc>
+                <a:tc>
+                  <a:txBody>
+                    <a:bodyPr/>
+                    <a:lstStyle/>
+                    <a:p>
+                      <a:r>
+                        <a:rPr sz="900" b="1"/>
+                        <a:t>regime (5%)</a:t>
+                      </a:r>
+                    </a:p>
+                  </a:txBody>
+                  <a:tcPr marT="9144" marB="9144"/>
+                </a:tc>
+                <a:tc>
+                  <a:txBody>
+                    <a:bodyPr/>
+                    <a:lstStyle/>
+                    <a:p>
+                      <a:r>
+                        <a:rPr sz="900" b="1"/>
+                        <a:t>rules handed (5%)</a:t>
+                      </a:r>
+                    </a:p>
+                  </a:txBody>
+                  <a:tcPr marT="9144" marB="9144"/>
+                </a:tc>
+                <a:tc>
+                  <a:txBody>
+                    <a:bodyPr/>
+                    <a:lstStyle/>
+                    <a:p>
+                      <a:r>
+                        <a:rPr sz="900" b="1"/>
+                        <a:t>typically run (5%)</a:t>
+                      </a:r>
+                    </a:p>
+                  </a:txBody>
+                  <a:tcPr marT="9144" marB="9144"/>
+                </a:tc>
+                <a:tc>
+                  <a:txBody>
+                    <a:bodyPr/>
+                    <a:lstStyle/>
+                    <a:p>
+                      <a:r>
+                        <a:rPr sz="900" b="1"/>
+                        <a:t>regime (10%)</a:t>
+                      </a:r>
+                    </a:p>
+                  </a:txBody>
+                  <a:tcPr marT="9144" marB="9144"/>
+                </a:tc>
+                <a:tc>
+                  <a:txBody>
+                    <a:bodyPr/>
+                    <a:lstStyle/>
+                    <a:p>
+                      <a:r>
+                        <a:rPr sz="900" b="1"/>
+                        <a:t>rules handed (10%)</a:t>
+                      </a:r>
+                    </a:p>
+                  </a:txBody>
+                  <a:tcPr marT="9144" marB="9144"/>
+                </a:tc>
+                <a:tc>
+                  <a:txBody>
+                    <a:bodyPr/>
+                    <a:lstStyle/>
+                    <a:p>
+                      <a:r>
+                        <a:rPr sz="900" b="1"/>
+                        <a:t>typically run (10%)</a:t>
+                      </a:r>
+                    </a:p>
+                  </a:txBody>
+                  <a:tcPr marT="9144" marB="9144"/>
+                </a:tc>
+              </a:tr>
+              <a:tr h="192024">
+                <a:tc>
+                  <a:txBody>
+                    <a:bodyPr/>
+                    <a:lstStyle/>
+                    <a:p>
+                      <a:r>
+                        <a:rPr sz="900" b="0"/>
+                        <a:t>Arizona</a:t>
+                      </a:r>
+                    </a:p>
+                  </a:txBody>
+                  <a:tcPr marT="9144" marB="9144"/>
+                </a:tc>
+                <a:tc>
+                  <a:txBody>
+                    <a:bodyPr/>
+                    <a:lstStyle/>
+                    <a:p>
+                      <a:r>
+                        <a:rPr sz="900" b="0"/>
+                        <a:t>national</a:t>
+                      </a:r>
+                    </a:p>
+                  </a:txBody>
+                  <a:tcPr marT="9144" marB="9144"/>
+                </a:tc>
+                <a:tc>
+                  <a:txBody>
+                    <a:bodyPr/>
+                    <a:lstStyle/>
+                    <a:p>
+                      <a:r>
+                        <a:rPr sz="900" b="0"/>
+                        <a:t>99</a:t>
+                      </a:r>
+                    </a:p>
+                  </a:txBody>
+                  <a:tcPr marT="9144" marB="9144"/>
+                </a:tc>
+                <a:tc>
+                  <a:txBody>
+                    <a:bodyPr/>
+                    <a:lstStyle/>
+                    <a:p>
+                      <a:r>
+                        <a:rPr sz="900" b="0"/>
+                        <a:t>18</a:t>
+                      </a:r>
+                    </a:p>
+                  </a:txBody>
+                  <a:tcPr marT="9144" marB="9144"/>
+                </a:tc>
+                <a:tc>
+                  <a:txBody>
+                    <a:bodyPr/>
+                    <a:lstStyle/>
+                    <a:p>
+                      <a:r>
+                        <a:rPr sz="900" b="0"/>
+                        <a:t>own rules</a:t>
+                      </a:r>
+                    </a:p>
+                  </a:txBody>
+                  <a:tcPr marT="9144" marB="9144"/>
+                </a:tc>
+                <a:tc>
+                  <a:txBody>
+                    <a:bodyPr/>
+                    <a:lstStyle/>
+                    <a:p>
+                      <a:r>
+                        <a:rPr sz="900" b="0"/>
+                        <a:t>147</a:t>
+                      </a:r>
+                    </a:p>
+                  </a:txBody>
+                  <a:tcPr marT="9144" marB="9144"/>
+                </a:tc>
+                <a:tc>
+                  <a:txBody>
+                    <a:bodyPr/>
+                    <a:lstStyle/>
+                    <a:p>
+                      <a:r>
+                        <a:rPr sz="900" b="0"/>
+                        <a:t>29</a:t>
+                      </a:r>
+                    </a:p>
+                  </a:txBody>
+                  <a:tcPr marT="9144" marB="9144"/>
+                </a:tc>
+              </a:tr>
+              <a:tr h="192024">
+                <a:tc>
+                  <a:txBody>
+                    <a:bodyPr/>
+                    <a:lstStyle/>
+                    <a:p>
+                      <a:r>
+                        <a:rPr sz="900" b="0"/>
+                        <a:t>California</a:t>
+                      </a:r>
+                    </a:p>
+                  </a:txBody>
+                  <a:tcPr marT="9144" marB="9144"/>
+                </a:tc>
+                <a:tc>
+                  <a:txBody>
+                    <a:bodyPr/>
+                    <a:lstStyle/>
+                    <a:p>
+                      <a:r>
+                        <a:rPr sz="900" b="0"/>
+                        <a:t>national</a:t>
+                      </a:r>
+                    </a:p>
+                  </a:txBody>
+                  <a:tcPr marT="9144" marB="9144"/>
+                </a:tc>
+                <a:tc>
+                  <a:txBody>
+                    <a:bodyPr/>
+                    <a:lstStyle/>
+                    <a:p>
+                      <a:r>
+                        <a:rPr sz="900" b="0"/>
+                        <a:t>93</a:t>
+                      </a:r>
+                    </a:p>
+                  </a:txBody>
+                  <a:tcPr marT="9144" marB="9144"/>
+                </a:tc>
+                <a:tc>
+                  <a:txBody>
+                    <a:bodyPr/>
+                    <a:lstStyle/>
+                    <a:p>
+                      <a:r>
+                        <a:rPr sz="900" b="0"/>
+                        <a:t>20</a:t>
+                      </a:r>
+                    </a:p>
+                  </a:txBody>
+                  <a:tcPr marT="9144" marB="9144"/>
+                </a:tc>
+                <a:tc>
+                  <a:txBody>
+                    <a:bodyPr/>
+                    <a:lstStyle/>
+                    <a:p>
+                      <a:r>
+                        <a:rPr sz="900" b="0"/>
+                        <a:t>own rules</a:t>
+                      </a:r>
+                    </a:p>
+                  </a:txBody>
+                  <a:tcPr marT="9144" marB="9144"/>
+                </a:tc>
+                <a:tc>
+                  <a:txBody>
+                    <a:bodyPr/>
+                    <a:lstStyle/>
+                    <a:p>
+                      <a:r>
+                        <a:rPr sz="900" b="0"/>
+                        <a:t>81</a:t>
+                      </a:r>
+                    </a:p>
+                  </a:txBody>
+                  <a:tcPr marT="9144" marB="9144"/>
+                </a:tc>
+                <a:tc>
+                  <a:txBody>
+                    <a:bodyPr/>
+                    <a:lstStyle/>
+                    <a:p>
+                      <a:r>
+                        <a:rPr sz="900" b="0"/>
+                        <a:t>14</a:t>
+                      </a:r>
+                    </a:p>
+                  </a:txBody>
+                  <a:tcPr marT="9144" marB="9144"/>
+                </a:tc>
+              </a:tr>
+              <a:tr h="192024">
+                <a:tc>
+                  <a:txBody>
+                    <a:bodyPr/>
+                    <a:lstStyle/>
+                    <a:p>
+                      <a:r>
+                        <a:rPr sz="900" b="0"/>
+                        <a:t>Colorado</a:t>
+                      </a:r>
+                    </a:p>
+                  </a:txBody>
+                  <a:tcPr marT="9144" marB="9144"/>
+                </a:tc>
+                <a:tc>
+                  <a:txBody>
+                    <a:bodyPr/>
+                    <a:lstStyle/>
+                    <a:p>
+                      <a:r>
+                        <a:rPr sz="900" b="0"/>
+                        <a:t>national</a:t>
+                      </a:r>
+                    </a:p>
+                  </a:txBody>
+                  <a:tcPr marT="9144" marB="9144"/>
+                </a:tc>
+                <a:tc>
+                  <a:txBody>
+                    <a:bodyPr/>
+                    <a:lstStyle/>
+                    <a:p>
+                      <a:r>
+                        <a:rPr sz="900" b="0"/>
+                        <a:t>136</a:t>
+                      </a:r>
+                    </a:p>
+                  </a:txBody>
+                  <a:tcPr marT="9144" marB="9144"/>
+                </a:tc>
+                <a:tc>
+                  <a:txBody>
+                    <a:bodyPr/>
+                    <a:lstStyle/>
+                    <a:p>
+                      <a:r>
+                        <a:rPr sz="900" b="0"/>
+                        <a:t>26</a:t>
+                      </a:r>
+                    </a:p>
+                  </a:txBody>
+                  <a:tcPr marT="9144" marB="9144"/>
+                </a:tc>
+                <a:tc>
+                  <a:txBody>
+                    <a:bodyPr/>
+                    <a:lstStyle/>
+                    <a:p>
+                      <a:r>
+                        <a:rPr sz="900" b="0"/>
+                        <a:t>national</a:t>
+                      </a:r>
+                    </a:p>
+                  </a:txBody>
+                  <a:tcPr marT="9144" marB="9144"/>
+                </a:tc>
+                <a:tc>
+                  <a:txBody>
+                    <a:bodyPr/>
+                    <a:lstStyle/>
+                    <a:p>
+                      <a:r>
+                        <a:rPr sz="900" b="0"/>
+                        <a:t>264</a:t>
+                      </a:r>
+                    </a:p>
+                  </a:txBody>
+                  <a:tcPr marT="9144" marB="9144"/>
+                </a:tc>
+                <a:tc>
+                  <a:txBody>
+                    <a:bodyPr/>
+                    <a:lstStyle/>
+                    <a:p>
+                      <a:r>
+                        <a:rPr sz="900" b="0"/>
+                        <a:t>44</a:t>
+                      </a:r>
+                    </a:p>
+                  </a:txBody>
+                  <a:tcPr marT="9144" marB="9144"/>
+                </a:tc>
+              </a:tr>
+              <a:tr h="192024">
+                <a:tc>
+                  <a:txBody>
+                    <a:bodyPr/>
+                    <a:lstStyle/>
+                    <a:p>
+                      <a:r>
+                        <a:rPr sz="900" b="0"/>
+                        <a:t>Connecticut</a:t>
+                      </a:r>
+                    </a:p>
+                  </a:txBody>
+                  <a:tcPr marT="9144" marB="9144"/>
+                </a:tc>
+                <a:tc>
+                  <a:txBody>
+                    <a:bodyPr/>
+                    <a:lstStyle/>
+                    <a:p>
+                      <a:r>
+                        <a:rPr sz="900" b="0"/>
+                        <a:t>own rules</a:t>
+                      </a:r>
+                    </a:p>
+                  </a:txBody>
+                  <a:tcPr marT="9144" marB="9144"/>
+                </a:tc>
+                <a:tc>
+                  <a:txBody>
+                    <a:bodyPr/>
+                    <a:lstStyle/>
+                    <a:p>
+                      <a:r>
+                        <a:rPr sz="900" b="0"/>
+                        <a:t>45</a:t>
+                      </a:r>
+                    </a:p>
+                  </a:txBody>
+                  <a:tcPr marT="9144" marB="9144"/>
+                </a:tc>
+                <a:tc>
+                  <a:txBody>
+                    <a:bodyPr/>
+                    <a:lstStyle/>
+                    <a:p>
+                      <a:r>
+                        <a:rPr sz="900" b="0"/>
+                        <a:t>8</a:t>
+                      </a:r>
+                    </a:p>
+                  </a:txBody>
+                  <a:tcPr marT="9144" marB="9144"/>
+                </a:tc>
+                <a:tc>
+                  <a:txBody>
+                    <a:bodyPr/>
+                    <a:lstStyle/>
+                    <a:p>
+                      <a:r>
+                        <a:rPr sz="900" b="0"/>
+                        <a:t>own rules</a:t>
+                      </a:r>
+                    </a:p>
+                  </a:txBody>
+                  <a:tcPr marT="9144" marB="9144"/>
+                </a:tc>
+                <a:tc>
+                  <a:txBody>
+                    <a:bodyPr/>
+                    <a:lstStyle/>
+                    <a:p>
+                      <a:r>
+                        <a:rPr sz="900" b="0"/>
+                        <a:t>107</a:t>
+                      </a:r>
+                    </a:p>
+                  </a:txBody>
+                  <a:tcPr marT="9144" marB="9144"/>
+                </a:tc>
+                <a:tc>
+                  <a:txBody>
+                    <a:bodyPr/>
+                    <a:lstStyle/>
+                    <a:p>
+                      <a:r>
+                        <a:rPr sz="900" b="0"/>
+                        <a:t>17</a:t>
+                      </a:r>
+                    </a:p>
+                  </a:txBody>
+                  <a:tcPr marT="9144" marB="9144"/>
+                </a:tc>
+              </a:tr>
+              <a:tr h="192024">
+                <a:tc>
+                  <a:txBody>
+                    <a:bodyPr/>
+                    <a:lstStyle/>
+                    <a:p>
+                      <a:r>
+                        <a:rPr sz="900" b="0"/>
+                        <a:t>District of Columbia</a:t>
+                      </a:r>
+                    </a:p>
+                  </a:txBody>
+                  <a:tcPr marT="9144" marB="9144"/>
+                </a:tc>
+                <a:tc>
+                  <a:txBody>
+                    <a:bodyPr/>
+                    <a:lstStyle/>
+                    <a:p>
+                      <a:r>
+                        <a:rPr sz="900" b="0"/>
+                        <a:t>own rules</a:t>
+                      </a:r>
+                    </a:p>
+                  </a:txBody>
+                  <a:tcPr marT="9144" marB="9144"/>
+                </a:tc>
+                <a:tc>
+                  <a:txBody>
+                    <a:bodyPr/>
+                    <a:lstStyle/>
+                    <a:p>
+                      <a:r>
+                        <a:rPr sz="900" b="0"/>
+                        <a:t>31</a:t>
+                      </a:r>
+                    </a:p>
+                  </a:txBody>
+                  <a:tcPr marT="9144" marB="9144"/>
+                </a:tc>
+                <a:tc>
+                  <a:txBody>
+                    <a:bodyPr/>
+                    <a:lstStyle/>
+                    <a:p>
+                      <a:r>
+                        <a:rPr sz="900" b="0"/>
+                        <a:t>5</a:t>
+                      </a:r>
+                    </a:p>
+                  </a:txBody>
+                  <a:tcPr marT="9144" marB="9144"/>
+                </a:tc>
+                <a:tc>
+                  <a:txBody>
+                    <a:bodyPr/>
+                    <a:lstStyle/>
+                    <a:p>
+                      <a:r>
+                        <a:rPr sz="900" b="0"/>
+                        <a:t>own rules</a:t>
+                      </a:r>
+                    </a:p>
+                  </a:txBody>
+                  <a:tcPr marT="9144" marB="9144"/>
+                </a:tc>
+                <a:tc>
+                  <a:txBody>
+                    <a:bodyPr/>
+                    <a:lstStyle/>
+                    <a:p>
+                      <a:r>
+                        <a:rPr sz="900" b="0"/>
+                        <a:t>66</a:t>
+                      </a:r>
+                    </a:p>
+                  </a:txBody>
+                  <a:tcPr marT="9144" marB="9144"/>
+                </a:tc>
+                <a:tc>
+                  <a:txBody>
+                    <a:bodyPr/>
+                    <a:lstStyle/>
+                    <a:p>
+                      <a:r>
+                        <a:rPr sz="900" b="0"/>
+                        <a:t>19</a:t>
+                      </a:r>
+                    </a:p>
+                  </a:txBody>
+                  <a:tcPr marT="9144" marB="9144"/>
+                </a:tc>
+              </a:tr>
+              <a:tr h="192024">
+                <a:tc>
+                  <a:txBody>
+                    <a:bodyPr/>
+                    <a:lstStyle/>
+                    <a:p>
+                      <a:r>
+                        <a:rPr sz="900" b="0"/>
+                        <a:t>Louisiana</a:t>
+                      </a:r>
+                    </a:p>
+                  </a:txBody>
+                  <a:tcPr marT="9144" marB="9144"/>
+                </a:tc>
+                <a:tc>
+                  <a:txBody>
+                    <a:bodyPr/>
+                    <a:lstStyle/>
+                    <a:p>
+                      <a:r>
+                        <a:rPr sz="900" b="0"/>
+                        <a:t>national</a:t>
+                      </a:r>
+                    </a:p>
+                  </a:txBody>
+                  <a:tcPr marT="9144" marB="9144"/>
+                </a:tc>
+                <a:tc>
+                  <a:txBody>
+                    <a:bodyPr/>
+                    <a:lstStyle/>
+                    <a:p>
+                      <a:r>
+                        <a:rPr sz="900" b="0"/>
+                        <a:t>112</a:t>
+                      </a:r>
+                    </a:p>
+                  </a:txBody>
+                  <a:tcPr marT="9144" marB="9144"/>
+                </a:tc>
+                <a:tc>
+                  <a:txBody>
+                    <a:bodyPr/>
+                    <a:lstStyle/>
+                    <a:p>
+                      <a:r>
+                        <a:rPr sz="900" b="0"/>
+                        <a:t>23</a:t>
+                      </a:r>
+                    </a:p>
+                  </a:txBody>
+                  <a:tcPr marT="9144" marB="9144"/>
+                </a:tc>
+                <a:tc>
+                  <a:txBody>
+                    <a:bodyPr/>
+                    <a:lstStyle/>
+                    <a:p>
+                      <a:r>
+                        <a:rPr sz="900" b="0"/>
+                        <a:t>national</a:t>
+                      </a:r>
+                    </a:p>
+                  </a:txBody>
+                  <a:tcPr marT="9144" marB="9144"/>
+                </a:tc>
+                <a:tc>
+                  <a:txBody>
+                    <a:bodyPr/>
+                    <a:lstStyle/>
+                    <a:p>
+                      <a:r>
+                        <a:rPr sz="900" b="0"/>
+                        <a:t>223</a:t>
+                      </a:r>
+                    </a:p>
+                  </a:txBody>
+                  <a:tcPr marT="9144" marB="9144"/>
+                </a:tc>
+                <a:tc>
+                  <a:txBody>
+                    <a:bodyPr/>
+                    <a:lstStyle/>
+                    <a:p>
+                      <a:r>
+                        <a:rPr sz="900" b="0"/>
+                        <a:t>42</a:t>
+                      </a:r>
+                    </a:p>
+                  </a:txBody>
+                  <a:tcPr marT="9144" marB="9144"/>
+                </a:tc>
+              </a:tr>
+              <a:tr h="192024">
+                <a:tc>
+                  <a:txBody>
+                    <a:bodyPr/>
+                    <a:lstStyle/>
+                    <a:p>
+                      <a:r>
+                        <a:rPr sz="900" b="0"/>
+                        <a:t>Maine</a:t>
+                      </a:r>
+                    </a:p>
+                  </a:txBody>
+                  <a:tcPr marT="9144" marB="9144"/>
+                </a:tc>
+                <a:tc>
+                  <a:txBody>
+                    <a:bodyPr/>
+                    <a:lstStyle/>
+                    <a:p>
+                      <a:r>
+                        <a:rPr sz="900" b="0"/>
+                        <a:t>own rules</a:t>
+                      </a:r>
+                    </a:p>
+                  </a:txBody>
+                  <a:tcPr marT="9144" marB="9144"/>
+                </a:tc>
+                <a:tc>
+                  <a:txBody>
+                    <a:bodyPr/>
+                    <a:lstStyle/>
+                    <a:p>
+                      <a:r>
+                        <a:rPr sz="900" b="0"/>
+                        <a:t>58</a:t>
+                      </a:r>
+                    </a:p>
+                  </a:txBody>
+                  <a:tcPr marT="9144" marB="9144"/>
+                </a:tc>
+                <a:tc>
+                  <a:txBody>
+                    <a:bodyPr/>
+                    <a:lstStyle/>
+                    <a:p>
+                      <a:r>
+                        <a:rPr sz="900" b="0"/>
+                        <a:t>7</a:t>
+                      </a:r>
+                    </a:p>
+                  </a:txBody>
+                  <a:tcPr marT="9144" marB="9144"/>
+                </a:tc>
+                <a:tc>
+                  <a:txBody>
+                    <a:bodyPr/>
+                    <a:lstStyle/>
+                    <a:p>
+                      <a:r>
+                        <a:rPr sz="900" b="0"/>
+                        <a:t>national</a:t>
+                      </a:r>
+                    </a:p>
+                  </a:txBody>
+                  <a:tcPr marT="9144" marB="9144"/>
+                </a:tc>
+                <a:tc>
+                  <a:txBody>
+                    <a:bodyPr/>
+                    <a:lstStyle/>
+                    <a:p>
+                      <a:r>
+                        <a:rPr sz="900" b="0"/>
+                        <a:t>276</a:t>
+                      </a:r>
+                    </a:p>
+                  </a:txBody>
+                  <a:tcPr marT="9144" marB="9144"/>
+                </a:tc>
+                <a:tc>
+                  <a:txBody>
+                    <a:bodyPr/>
+                    <a:lstStyle/>
+                    <a:p>
+                      <a:r>
+                        <a:rPr sz="900" b="0"/>
+                        <a:t>42</a:t>
+                      </a:r>
+                    </a:p>
+                  </a:txBody>
+                  <a:tcPr marT="9144" marB="9144"/>
+                </a:tc>
+              </a:tr>
+              <a:tr h="192024">
+                <a:tc>
+                  <a:txBody>
+                    <a:bodyPr/>
+                    <a:lstStyle/>
+                    <a:p>
+                      <a:r>
+                        <a:rPr sz="900" b="0"/>
+                        <a:t>Maryland</a:t>
+                      </a:r>
+                    </a:p>
+                  </a:txBody>
+                  <a:tcPr marT="9144" marB="9144"/>
+                </a:tc>
+                <a:tc>
+                  <a:txBody>
+                    <a:bodyPr/>
+                    <a:lstStyle/>
+                    <a:p>
+                      <a:r>
+                        <a:rPr sz="900" b="0"/>
+                        <a:t>own rules</a:t>
+                      </a:r>
+                    </a:p>
+                  </a:txBody>
+                  <a:tcPr marT="9144" marB="9144"/>
+                </a:tc>
+                <a:tc>
+                  <a:txBody>
+                    <a:bodyPr/>
+                    <a:lstStyle/>
+                    <a:p>
+                      <a:r>
+                        <a:rPr sz="900" b="0"/>
+                        <a:t>13</a:t>
+                      </a:r>
+                    </a:p>
+                  </a:txBody>
+                  <a:tcPr marT="9144" marB="9144"/>
+                </a:tc>
+                <a:tc>
+                  <a:txBody>
+                    <a:bodyPr/>
+                    <a:lstStyle/>
+                    <a:p>
+                      <a:r>
+                        <a:rPr sz="900" b="0"/>
+                        <a:t>4</a:t>
+                      </a:r>
+                    </a:p>
+                  </a:txBody>
+                  <a:tcPr marT="9144" marB="9144"/>
+                </a:tc>
+                <a:tc>
+                  <a:txBody>
+                    <a:bodyPr/>
+                    <a:lstStyle/>
+                    <a:p>
+                      <a:r>
+                        <a:rPr sz="900" b="0"/>
+                        <a:t>own rules</a:t>
+                      </a:r>
+                    </a:p>
+                  </a:txBody>
+                  <a:tcPr marT="9144" marB="9144"/>
+                </a:tc>
+                <a:tc>
+                  <a:txBody>
+                    <a:bodyPr/>
+                    <a:lstStyle/>
+                    <a:p>
+                      <a:r>
+                        <a:rPr sz="900" b="0"/>
+                        <a:t>72</a:t>
+                      </a:r>
+                    </a:p>
+                  </a:txBody>
+                  <a:tcPr marT="9144" marB="9144"/>
+                </a:tc>
+                <a:tc>
+                  <a:txBody>
+                    <a:bodyPr/>
+                    <a:lstStyle/>
+                    <a:p>
+                      <a:r>
+                        <a:rPr sz="900" b="0"/>
+                        <a:t>8</a:t>
+                      </a:r>
+                    </a:p>
+                  </a:txBody>
+                  <a:tcPr marT="9144" marB="9144"/>
+                </a:tc>
+              </a:tr>
+              <a:tr h="192024">
+                <a:tc>
+                  <a:txBody>
+                    <a:bodyPr/>
+                    <a:lstStyle/>
+                    <a:p>
+                      <a:r>
+                        <a:rPr sz="900" b="0"/>
+                        <a:t>Massachusetts</a:t>
+                      </a:r>
+                    </a:p>
+                  </a:txBody>
+                  <a:tcPr marT="9144" marB="9144"/>
+                </a:tc>
+                <a:tc>
+                  <a:txBody>
+                    <a:bodyPr/>
+                    <a:lstStyle/>
+                    <a:p>
+                      <a:r>
+                        <a:rPr sz="900" b="0"/>
+                        <a:t>national</a:t>
+                      </a:r>
+                    </a:p>
+                  </a:txBody>
+                  <a:tcPr marT="9144" marB="9144"/>
+                </a:tc>
+                <a:tc>
+                  <a:txBody>
+                    <a:bodyPr/>
+                    <a:lstStyle/>
+                    <a:p>
+                      <a:r>
+                        <a:rPr sz="900" b="0"/>
+                        <a:t>137</a:t>
+                      </a:r>
+                    </a:p>
+                  </a:txBody>
+                  <a:tcPr marT="9144" marB="9144"/>
+                </a:tc>
+                <a:tc>
+                  <a:txBody>
+                    <a:bodyPr/>
+                    <a:lstStyle/>
+                    <a:p>
+                      <a:r>
+                        <a:rPr sz="900" b="0"/>
+                        <a:t>20</a:t>
+                      </a:r>
+                    </a:p>
+                  </a:txBody>
+                  <a:tcPr marT="9144" marB="9144"/>
+                </a:tc>
+                <a:tc>
+                  <a:txBody>
+                    <a:bodyPr/>
+                    <a:lstStyle/>
+                    <a:p>
+                      <a:r>
+                        <a:rPr sz="900" b="0"/>
+                        <a:t>national</a:t>
+                      </a:r>
+                    </a:p>
+                  </a:txBody>
+                  <a:tcPr marT="9144" marB="9144"/>
+                </a:tc>
+                <a:tc>
+                  <a:txBody>
+                    <a:bodyPr/>
+                    <a:lstStyle/>
+                    <a:p>
+                      <a:r>
+                        <a:rPr sz="900" b="0"/>
+                        <a:t>262</a:t>
+                      </a:r>
+                    </a:p>
+                  </a:txBody>
+                  <a:tcPr marT="9144" marB="9144"/>
+                </a:tc>
+                <a:tc>
+                  <a:txBody>
+                    <a:bodyPr/>
+                    <a:lstStyle/>
+                    <a:p>
+                      <a:r>
+                        <a:rPr sz="900" b="0"/>
+                        <a:t>38</a:t>
+                      </a:r>
+                    </a:p>
+                  </a:txBody>
+                  <a:tcPr marT="9144" marB="9144"/>
+                </a:tc>
+              </a:tr>
+              <a:tr h="192024">
+                <a:tc>
+                  <a:txBody>
+                    <a:bodyPr/>
+                    <a:lstStyle/>
+                    <a:p>
+                      <a:r>
+                        <a:rPr sz="900" b="0"/>
+                        <a:t>Michigan</a:t>
+                      </a:r>
+                    </a:p>
+                  </a:txBody>
+                  <a:tcPr marT="9144" marB="9144"/>
+                </a:tc>
+                <a:tc>
+                  <a:txBody>
+                    <a:bodyPr/>
+                    <a:lstStyle/>
+                    <a:p>
+                      <a:r>
+                        <a:rPr sz="900" b="0"/>
+                        <a:t>national</a:t>
+                      </a:r>
+                    </a:p>
+                  </a:txBody>
+                  <a:tcPr marT="9144" marB="9144"/>
+                </a:tc>
+                <a:tc>
+                  <a:txBody>
+                    <a:bodyPr/>
+                    <a:lstStyle/>
+                    <a:p>
+                      <a:r>
+                        <a:rPr sz="900" b="0"/>
+                        <a:t>125</a:t>
+                      </a:r>
+                    </a:p>
+                  </a:txBody>
+                  <a:tcPr marT="9144" marB="9144"/>
+                </a:tc>
+                <a:tc>
+                  <a:txBody>
+                    <a:bodyPr/>
+                    <a:lstStyle/>
+                    <a:p>
+                      <a:r>
+                        <a:rPr sz="900" b="0"/>
+                        <a:t>25</a:t>
+                      </a:r>
+                    </a:p>
+                  </a:txBody>
+                  <a:tcPr marT="9144" marB="9144"/>
+                </a:tc>
+                <a:tc>
+                  <a:txBody>
+                    <a:bodyPr/>
+                    <a:lstStyle/>
+                    <a:p>
+                      <a:r>
+                        <a:rPr sz="900" b="0"/>
+                        <a:t>national</a:t>
+                      </a:r>
+                    </a:p>
+                  </a:txBody>
+                  <a:tcPr marT="9144" marB="9144"/>
+                </a:tc>
+                <a:tc>
+                  <a:txBody>
+                    <a:bodyPr/>
+                    <a:lstStyle/>
+                    <a:p>
+                      <a:r>
+                        <a:rPr sz="900" b="0"/>
+                        <a:t>238</a:t>
+                      </a:r>
+                    </a:p>
+                  </a:txBody>
+                  <a:tcPr marT="9144" marB="9144"/>
+                </a:tc>
+                <a:tc>
+                  <a:txBody>
+                    <a:bodyPr/>
+                    <a:lstStyle/>
+                    <a:p>
+                      <a:r>
+                        <a:rPr sz="900" b="0"/>
+                        <a:t>42</a:t>
+                      </a:r>
+                    </a:p>
+                  </a:txBody>
+                  <a:tcPr marT="9144" marB="9144"/>
+                </a:tc>
+              </a:tr>
+              <a:tr h="192024">
+                <a:tc>
+                  <a:txBody>
+                    <a:bodyPr/>
+                    <a:lstStyle/>
+                    <a:p>
+                      <a:r>
+                        <a:rPr sz="900" b="0"/>
+                        <a:t>Mississippi</a:t>
+                      </a:r>
+                    </a:p>
+                  </a:txBody>
+                  <a:tcPr marT="9144" marB="9144"/>
+                </a:tc>
+                <a:tc>
+                  <a:txBody>
+                    <a:bodyPr/>
+                    <a:lstStyle/>
+                    <a:p>
+                      <a:r>
+                        <a:rPr sz="900" b="0"/>
+                        <a:t>own rules</a:t>
+                      </a:r>
+                    </a:p>
+                  </a:txBody>
+                  <a:tcPr marT="9144" marB="9144"/>
+                </a:tc>
+                <a:tc>
+                  <a:txBody>
+                    <a:bodyPr/>
+                    <a:lstStyle/>
+                    <a:p>
+                      <a:r>
+                        <a:rPr sz="900" b="0"/>
+                        <a:t>43</a:t>
+                      </a:r>
+                    </a:p>
+                  </a:txBody>
+                  <a:tcPr marT="9144" marB="9144"/>
+                </a:tc>
+                <a:tc>
+                  <a:txBody>
+                    <a:bodyPr/>
+                    <a:lstStyle/>
+                    <a:p>
+                      <a:r>
+                        <a:rPr sz="900" b="0"/>
+                        <a:t>6</a:t>
+                      </a:r>
+                    </a:p>
+                  </a:txBody>
+                  <a:tcPr marT="9144" marB="9144"/>
+                </a:tc>
+                <a:tc>
+                  <a:txBody>
+                    <a:bodyPr/>
+                    <a:lstStyle/>
+                    <a:p>
+                      <a:r>
+                        <a:rPr sz="900" b="0"/>
+                        <a:t>own rules</a:t>
+                      </a:r>
+                    </a:p>
+                  </a:txBody>
+                  <a:tcPr marT="9144" marB="9144"/>
+                </a:tc>
+                <a:tc>
+                  <a:txBody>
+                    <a:bodyPr/>
+                    <a:lstStyle/>
+                    <a:p>
+                      <a:r>
+                        <a:rPr sz="900" b="0"/>
+                        <a:t>107</a:t>
+                      </a:r>
+                    </a:p>
+                  </a:txBody>
+                  <a:tcPr marT="9144" marB="9144"/>
+                </a:tc>
+                <a:tc>
+                  <a:txBody>
+                    <a:bodyPr/>
+                    <a:lstStyle/>
+                    <a:p>
+                      <a:r>
+                        <a:rPr sz="900" b="0"/>
+                        <a:t>20</a:t>
+                      </a:r>
+                    </a:p>
+                  </a:txBody>
+                  <a:tcPr marT="9144" marB="9144"/>
+                </a:tc>
+              </a:tr>
+              <a:tr h="192024">
+                <a:tc>
+                  <a:txBody>
+                    <a:bodyPr/>
+                    <a:lstStyle/>
+                    <a:p>
+                      <a:r>
+                        <a:rPr sz="900" b="0"/>
+                        <a:t>Missouri</a:t>
+                      </a:r>
+                    </a:p>
+                  </a:txBody>
+                  <a:tcPr marT="9144" marB="9144"/>
+                </a:tc>
+                <a:tc>
+                  <a:txBody>
+                    <a:bodyPr/>
+                    <a:lstStyle/>
+                    <a:p>
+                      <a:r>
+                        <a:rPr sz="900" b="0"/>
+                        <a:t>national</a:t>
+                      </a:r>
+                    </a:p>
+                  </a:txBody>
+                  <a:tcPr marT="9144" marB="9144"/>
+                </a:tc>
+                <a:tc>
+                  <a:txBody>
+                    <a:bodyPr/>
+                    <a:lstStyle/>
+                    <a:p>
+                      <a:r>
+                        <a:rPr sz="900" b="0"/>
+                        <a:t>107</a:t>
+                      </a:r>
+                    </a:p>
+                  </a:txBody>
+                  <a:tcPr marT="9144" marB="9144"/>
+                </a:tc>
+                <a:tc>
+                  <a:txBody>
+                    <a:bodyPr/>
+                    <a:lstStyle/>
+                    <a:p>
+                      <a:r>
+                        <a:rPr sz="900" b="0"/>
+                        <a:t>23</a:t>
+                      </a:r>
+                    </a:p>
+                  </a:txBody>
+                  <a:tcPr marT="9144" marB="9144"/>
+                </a:tc>
+                <a:tc>
+                  <a:txBody>
+                    <a:bodyPr/>
+                    <a:lstStyle/>
+                    <a:p>
+                      <a:r>
+                        <a:rPr sz="900" b="0"/>
+                        <a:t>national</a:t>
+                      </a:r>
+                    </a:p>
+                  </a:txBody>
+                  <a:tcPr marT="9144" marB="9144"/>
+                </a:tc>
+                <a:tc>
+                  <a:txBody>
+                    <a:bodyPr/>
+                    <a:lstStyle/>
+                    <a:p>
+                      <a:r>
+                        <a:rPr sz="900" b="0"/>
+                        <a:t>203</a:t>
+                      </a:r>
+                    </a:p>
+                  </a:txBody>
+                  <a:tcPr marT="9144" marB="9144"/>
+                </a:tc>
+                <a:tc>
+                  <a:txBody>
+                    <a:bodyPr/>
+                    <a:lstStyle/>
+                    <a:p>
+                      <a:r>
+                        <a:rPr sz="900" b="0"/>
+                        <a:t>44</a:t>
+                      </a:r>
+                    </a:p>
+                  </a:txBody>
+                  <a:tcPr marT="9144" marB="9144"/>
+                </a:tc>
+              </a:tr>
+              <a:tr h="192024">
+                <a:tc>
+                  <a:txBody>
+                    <a:bodyPr/>
+                    <a:lstStyle/>
+                    <a:p>
+                      <a:r>
+                        <a:rPr sz="900" b="0"/>
+                        <a:t>New Jersey</a:t>
+                      </a:r>
+                    </a:p>
+                  </a:txBody>
+                  <a:tcPr marT="9144" marB="9144"/>
+                </a:tc>
+                <a:tc>
+                  <a:txBody>
+                    <a:bodyPr/>
+                    <a:lstStyle/>
+                    <a:p>
+                      <a:r>
+                        <a:rPr sz="900" b="0"/>
+                        <a:t>own rules</a:t>
+                      </a:r>
+                    </a:p>
+                  </a:txBody>
+                  <a:tcPr marT="9144" marB="9144"/>
+                </a:tc>
+                <a:tc>
+                  <a:txBody>
+                    <a:bodyPr/>
+                    <a:lstStyle/>
+                    <a:p>
+                      <a:r>
+                        <a:rPr sz="900" b="0"/>
+                        <a:t>20</a:t>
+                      </a:r>
+                    </a:p>
+                  </a:txBody>
+                  <a:tcPr marT="9144" marB="9144"/>
+                </a:tc>
+                <a:tc>
+                  <a:txBody>
+                    <a:bodyPr/>
+                    <a:lstStyle/>
+                    <a:p>
+                      <a:r>
+                        <a:rPr sz="900" b="0"/>
+                        <a:t>2</a:t>
+                      </a:r>
+                    </a:p>
+                  </a:txBody>
+                  <a:tcPr marT="9144" marB="9144"/>
+                </a:tc>
+                <a:tc>
+                  <a:txBody>
+                    <a:bodyPr/>
+                    <a:lstStyle/>
+                    <a:p>
+                      <a:r>
+                        <a:rPr sz="900" b="0"/>
+                        <a:t>own rules</a:t>
+                      </a:r>
+                    </a:p>
+                  </a:txBody>
+                  <a:tcPr marT="9144" marB="9144"/>
+                </a:tc>
+                <a:tc>
+                  <a:txBody>
+                    <a:bodyPr/>
+                    <a:lstStyle/>
+                    <a:p>
+                      <a:r>
+                        <a:rPr sz="900" b="0"/>
+                        <a:t>72</a:t>
+                      </a:r>
+                    </a:p>
+                  </a:txBody>
+                  <a:tcPr marT="9144" marB="9144"/>
+                </a:tc>
+                <a:tc>
+                  <a:txBody>
+                    <a:bodyPr/>
+                    <a:lstStyle/>
+                    <a:p>
+                      <a:r>
+                        <a:rPr sz="900" b="0"/>
+                        <a:t>4</a:t>
+                      </a:r>
+                    </a:p>
+                  </a:txBody>
+                  <a:tcPr marT="9144" marB="9144"/>
+                </a:tc>
+              </a:tr>
+              <a:tr h="192024">
+                <a:tc>
+                  <a:txBody>
+                    <a:bodyPr/>
+                    <a:lstStyle/>
+                    <a:p>
+                      <a:r>
+                        <a:rPr sz="900" b="0"/>
+                        <a:t>North Carolina</a:t>
+                      </a:r>
+                    </a:p>
+                  </a:txBody>
+                  <a:tcPr marT="9144" marB="9144"/>
+                </a:tc>
+                <a:tc>
+                  <a:txBody>
+                    <a:bodyPr/>
+                    <a:lstStyle/>
+                    <a:p>
+                      <a:r>
+                        <a:rPr sz="900" b="0"/>
+                        <a:t>national</a:t>
+                      </a:r>
+                    </a:p>
+                  </a:txBody>
+                  <a:tcPr marT="9144" marB="9144"/>
+                </a:tc>
+                <a:tc>
+                  <a:txBody>
+                    <a:bodyPr/>
+                    <a:lstStyle/>
+                    <a:p>
+                      <a:r>
+                        <a:rPr sz="900" b="0"/>
+                        <a:t>148</a:t>
+                      </a:r>
+                    </a:p>
+                  </a:txBody>
+                  <a:tcPr marT="9144" marB="9144"/>
+                </a:tc>
+                <a:tc>
+                  <a:txBody>
+                    <a:bodyPr/>
+                    <a:lstStyle/>
+                    <a:p>
+                      <a:r>
+                        <a:rPr sz="900" b="0"/>
+                        <a:t>27</a:t>
+                      </a:r>
+                    </a:p>
+                  </a:txBody>
+                  <a:tcPr marT="9144" marB="9144"/>
+                </a:tc>
+                <a:tc>
+                  <a:txBody>
+                    <a:bodyPr/>
+                    <a:lstStyle/>
+                    <a:p>
+                      <a:r>
+                        <a:rPr sz="900" b="0"/>
+                        <a:t>own rules</a:t>
+                      </a:r>
+                    </a:p>
+                  </a:txBody>
+                  <a:tcPr marT="9144" marB="9144"/>
+                </a:tc>
+                <a:tc>
+                  <a:txBody>
+                    <a:bodyPr/>
+                    <a:lstStyle/>
+                    <a:p>
+                      <a:r>
+                        <a:rPr sz="900" b="0"/>
+                        <a:t>70</a:t>
+                      </a:r>
+                    </a:p>
+                  </a:txBody>
+                  <a:tcPr marT="9144" marB="9144"/>
+                </a:tc>
+                <a:tc>
+                  <a:txBody>
+                    <a:bodyPr/>
+                    <a:lstStyle/>
+                    <a:p>
+                      <a:r>
+                        <a:rPr sz="900" b="0"/>
+                        <a:t>12</a:t>
+                      </a:r>
+                    </a:p>
+                  </a:txBody>
+                  <a:tcPr marT="9144" marB="9144"/>
+                </a:tc>
+              </a:tr>
+              <a:tr h="192024">
+                <a:tc>
+                  <a:txBody>
+                    <a:bodyPr/>
+                    <a:lstStyle/>
+                    <a:p>
+                      <a:r>
+                        <a:rPr sz="900" b="0"/>
+                        <a:t>Tennessee</a:t>
+                      </a:r>
+                    </a:p>
+                  </a:txBody>
+                  <a:tcPr marT="9144" marB="9144"/>
+                </a:tc>
+                <a:tc>
+                  <a:txBody>
+                    <a:bodyPr/>
+                    <a:lstStyle/>
+                    <a:p>
+                      <a:r>
+                        <a:rPr sz="900" b="0"/>
+                        <a:t>national</a:t>
+                      </a:r>
+                    </a:p>
+                  </a:txBody>
+                  <a:tcPr marT="9144" marB="9144"/>
+                </a:tc>
+                <a:tc>
+                  <a:txBody>
+                    <a:bodyPr/>
+                    <a:lstStyle/>
+                    <a:p>
+                      <a:r>
+                        <a:rPr sz="900" b="0"/>
+                        <a:t>143</a:t>
+                      </a:r>
+                    </a:p>
+                  </a:txBody>
+                  <a:tcPr marT="9144" marB="9144"/>
+                </a:tc>
+                <a:tc>
+                  <a:txBody>
+                    <a:bodyPr/>
+                    <a:lstStyle/>
+                    <a:p>
+                      <a:r>
+                        <a:rPr sz="900" b="0"/>
+                        <a:t>26</a:t>
+                      </a:r>
+                    </a:p>
+                  </a:txBody>
+                  <a:tcPr marT="9144" marB="9144"/>
+                </a:tc>
+                <a:tc>
+                  <a:txBody>
+                    <a:bodyPr/>
+                    <a:lstStyle/>
+                    <a:p>
+                      <a:r>
+                        <a:rPr sz="900" b="0"/>
+                        <a:t>national</a:t>
+                      </a:r>
+                    </a:p>
+                  </a:txBody>
+                  <a:tcPr marT="9144" marB="9144"/>
+                </a:tc>
+                <a:tc>
+                  <a:txBody>
+                    <a:bodyPr/>
+                    <a:lstStyle/>
+                    <a:p>
+                      <a:r>
+                        <a:rPr sz="900" b="0"/>
+                        <a:t>281</a:t>
+                      </a:r>
+                    </a:p>
+                  </a:txBody>
+                  <a:tcPr marT="9144" marB="9144"/>
+                </a:tc>
+                <a:tc>
+                  <a:txBody>
+                    <a:bodyPr/>
+                    <a:lstStyle/>
+                    <a:p>
+                      <a:r>
+                        <a:rPr sz="900" b="0"/>
+                        <a:t>49</a:t>
+                      </a:r>
+                    </a:p>
+                  </a:txBody>
+                  <a:tcPr marT="9144" marB="9144"/>
+                </a:tc>
+              </a:tr>
+              <a:tr h="192024">
+                <a:tc>
+                  <a:txBody>
+                    <a:bodyPr/>
+                    <a:lstStyle/>
+                    <a:p>
+                      <a:r>
+                        <a:rPr sz="900" b="0"/>
+                        <a:t>Texas</a:t>
+                      </a:r>
+                    </a:p>
+                  </a:txBody>
+                  <a:tcPr marT="9144" marB="9144"/>
+                </a:tc>
+                <a:tc>
+                  <a:txBody>
+                    <a:bodyPr/>
+                    <a:lstStyle/>
+                    <a:p>
+                      <a:r>
+                        <a:rPr sz="900" b="0"/>
+                        <a:t>own rules</a:t>
+                      </a:r>
+                    </a:p>
+                  </a:txBody>
+                  <a:tcPr marT="9144" marB="9144"/>
+                </a:tc>
+                <a:tc>
+                  <a:txBody>
+                    <a:bodyPr/>
+                    <a:lstStyle/>
+                    <a:p>
+                      <a:r>
+                        <a:rPr sz="900" b="0"/>
+                        <a:t>50</a:t>
+                      </a:r>
+                    </a:p>
+                  </a:txBody>
+                  <a:tcPr marT="9144" marB="9144"/>
+                </a:tc>
+                <a:tc>
+                  <a:txBody>
+                    <a:bodyPr/>
+                    <a:lstStyle/>
+                    <a:p>
+                      <a:r>
+                        <a:rPr sz="900" b="0"/>
+                        <a:t>2</a:t>
+                      </a:r>
+                    </a:p>
+                  </a:txBody>
+                  <a:tcPr marT="9144" marB="9144"/>
+                </a:tc>
+                <a:tc>
+                  <a:txBody>
+                    <a:bodyPr/>
+                    <a:lstStyle/>
+                    <a:p>
+                      <a:r>
+                        <a:rPr sz="900" b="0"/>
+                        <a:t>own rules</a:t>
+                      </a:r>
+                    </a:p>
+                  </a:txBody>
+                  <a:tcPr marT="9144" marB="9144"/>
+                </a:tc>
+                <a:tc>
+                  <a:txBody>
+                    <a:bodyPr/>
+                    <a:lstStyle/>
+                    <a:p>
+                      <a:r>
+                        <a:rPr sz="900" b="0"/>
+                        <a:t>102</a:t>
+                      </a:r>
+                    </a:p>
+                  </a:txBody>
+                  <a:tcPr marT="9144" marB="9144"/>
+                </a:tc>
+                <a:tc>
+                  <a:txBody>
+                    <a:bodyPr/>
+                    <a:lstStyle/>
+                    <a:p>
+                      <a:r>
+                        <a:rPr sz="900" b="0"/>
+                        <a:t>10</a:t>
+                      </a:r>
+                    </a:p>
+                  </a:txBody>
+                  <a:tcPr marT="9144" marB="9144"/>
+                </a:tc>
+              </a:tr>
+              <a:tr h="192024">
+                <a:tc>
+                  <a:txBody>
+                    <a:bodyPr/>
+                    <a:lstStyle/>
+                    <a:p>
+                      <a:r>
+                        <a:rPr sz="900" b="0"/>
+                        <a:t>Virginia</a:t>
+                      </a:r>
+                    </a:p>
+                  </a:txBody>
+                  <a:tcPr marT="9144" marB="9144"/>
+                </a:tc>
+                <a:tc>
+                  <a:txBody>
+                    <a:bodyPr/>
+                    <a:lstStyle/>
+                    <a:p>
+                      <a:r>
+                        <a:rPr sz="900" b="0"/>
+                        <a:t>national</a:t>
+                      </a:r>
+                    </a:p>
+                  </a:txBody>
+                  <a:tcPr marT="9144" marB="9144"/>
+                </a:tc>
+                <a:tc>
+                  <a:txBody>
+                    <a:bodyPr/>
+                    <a:lstStyle/>
+                    <a:p>
+                      <a:r>
+                        <a:rPr sz="900" b="0"/>
+                        <a:t>90</a:t>
+                      </a:r>
+                    </a:p>
+                  </a:txBody>
+                  <a:tcPr marT="9144" marB="9144"/>
+                </a:tc>
+                <a:tc>
+                  <a:txBody>
+                    <a:bodyPr/>
+                    <a:lstStyle/>
+                    <a:p>
+                      <a:r>
+                        <a:rPr sz="900" b="0"/>
+                        <a:t>23</a:t>
+                      </a:r>
+                    </a:p>
+                  </a:txBody>
+                  <a:tcPr marT="9144" marB="9144"/>
+                </a:tc>
+                <a:tc>
+                  <a:txBody>
+                    <a:bodyPr/>
+                    <a:lstStyle/>
+                    <a:p>
+                      <a:r>
+                        <a:rPr sz="900" b="0"/>
+                        <a:t>own rules</a:t>
+                      </a:r>
+                    </a:p>
+                  </a:txBody>
+                  <a:tcPr marT="9144" marB="9144"/>
+                </a:tc>
+                <a:tc>
+                  <a:txBody>
+                    <a:bodyPr/>
+                    <a:lstStyle/>
+                    <a:p>
+                      <a:r>
+                        <a:rPr sz="900" b="0"/>
+                        <a:t>50</a:t>
+                      </a:r>
+                    </a:p>
+                  </a:txBody>
+                  <a:tcPr marT="9144" marB="9144"/>
+                </a:tc>
+                <a:tc>
+                  <a:txBody>
+                    <a:bodyPr/>
+                    <a:lstStyle/>
+                    <a:p>
+                      <a:r>
+                        <a:rPr sz="900" b="0"/>
+                        <a:t>8</a:t>
+                      </a:r>
+                    </a:p>
+                  </a:txBody>
+                  <a:tcPr marT="9144" marB="9144"/>
+                </a:tc>
+              </a:tr>
+              <a:tr h="192024">
+                <a:tc>
+                  <a:txBody>
+                    <a:bodyPr/>
+                    <a:lstStyle/>
+                    <a:p>
+                      <a:r>
+                        <a:rPr sz="900" b="0"/>
+                        <a:t>Washington</a:t>
+                      </a:r>
+                    </a:p>
+                  </a:txBody>
+                  <a:tcPr marT="9144" marB="9144"/>
+                </a:tc>
+                <a:tc>
+                  <a:txBody>
+                    <a:bodyPr/>
+                    <a:lstStyle/>
+                    <a:p>
+                      <a:r>
+                        <a:rPr sz="900" b="0"/>
+                        <a:t>national</a:t>
+                      </a:r>
+                    </a:p>
+                  </a:txBody>
+                  <a:tcPr marT="9144" marB="9144"/>
+                </a:tc>
+                <a:tc>
+                  <a:txBody>
+                    <a:bodyPr/>
+                    <a:lstStyle/>
+                    <a:p>
+                      <a:r>
+                        <a:rPr sz="900" b="0"/>
+                        <a:t>127</a:t>
+                      </a:r>
+                    </a:p>
+                  </a:txBody>
+                  <a:tcPr marT="9144" marB="9144"/>
+                </a:tc>
+                <a:tc>
+                  <a:txBody>
+                    <a:bodyPr/>
+                    <a:lstStyle/>
+                    <a:p>
+                      <a:r>
+                        <a:rPr sz="900" b="0"/>
+                        <a:t>22</a:t>
+                      </a:r>
+                    </a:p>
+                  </a:txBody>
+                  <a:tcPr marT="9144" marB="9144"/>
+                </a:tc>
+                <a:tc>
+                  <a:txBody>
+                    <a:bodyPr/>
+                    <a:lstStyle/>
+                    <a:p>
+                      <a:r>
+                        <a:rPr sz="900" b="0"/>
+                        <a:t>national</a:t>
+                      </a:r>
+                    </a:p>
+                  </a:txBody>
+                  <a:tcPr marT="9144" marB="9144"/>
+                </a:tc>
+                <a:tc>
+                  <a:txBody>
+                    <a:bodyPr/>
+                    <a:lstStyle/>
+                    <a:p>
+                      <a:r>
+                        <a:rPr sz="900" b="0"/>
+                        <a:t>249</a:t>
+                      </a:r>
+                    </a:p>
+                  </a:txBody>
+                  <a:tcPr marT="9144" marB="9144"/>
+                </a:tc>
+                <a:tc>
+                  <a:txBody>
+                    <a:bodyPr/>
+                    <a:lstStyle/>
+                    <a:p>
+                      <a:r>
+                        <a:rPr sz="900" b="0"/>
+                        <a:t>49</a:t>
+                      </a:r>
+                    </a:p>
+                  </a:txBody>
+                  <a:tcPr marT="9144" marB="9144"/>
+                </a:tc>
+              </a:tr>
+            </a:tbl>
+          </a:graphicData>
+        </a:graphic>
+      </p:graphicFrame>
+    </p:spTree>
+  </p:cSld>
+  <p:clrMapOvr>
+    <a:masterClrMapping/>
+  </p:clrMapOvr>
+</p:sld>
+</file>
+
+<file path=ppt/slides/slide48.xml><?xml version="1.0" encoding="utf-8"?>
+<p:sld xmlns:a="http://schemas.openxmlformats.org/drawingml/2006/main" xmlns:p="http://schemas.openxmlformats.org/presentationml/2006/main" xmlns:r="http://schemas.openxmlformats.org/officeDocument/2006/relationships">
+  <p:cSld>
+    <p:spTree>
+      <p:nvGrpSpPr>
+        <p:cNvPr id="1" name=""/>
+        <p:cNvGrpSpPr/>
+        <p:nvPr/>
+      </p:nvGrpSpPr>
+      <p:grpSpPr/>
+      <p:sp>
+        <p:nvSpPr>
+          <p:cNvPr id="2" name="TextBox 1"/>
+          <p:cNvSpPr txBox="1"/>
+          <p:nvPr/>
+        </p:nvSpPr>
+        <p:spPr>
+          <a:xfrm>
+            <a:off x="400000" y="200000"/>
+            <a:ext cx="8344000" cy="600000"/>
+          </a:xfrm>
+          <a:prstGeom prst="rect">
+            <a:avLst/>
+          </a:prstGeom>
+          <a:noFill/>
+        </p:spPr>
+        <p:txBody>
+          <a:bodyPr wrap="none">
+            <a:spAutoFit/>
+          </a:bodyPr>
+          <a:lstStyle/>
+          <a:p>
+            <a:r>
+              <a:rPr sz="2200" b="1"/>
               <a:t>Blending state and national rules onto one confidence scale</a:t>
             </a:r>
           </a:p>
@@ -17947,7 +18495,7 @@
 </p:sld>
 </file>
 
-<file path=ppt/slides/slide48.xml><?xml version="1.0" encoding="utf-8"?>
+<file path=ppt/slides/slide49.xml><?xml version="1.0" encoding="utf-8"?>
 <p:sld xmlns:a="http://schemas.openxmlformats.org/drawingml/2006/main" xmlns:p="http://schemas.openxmlformats.org/presentationml/2006/main" xmlns:r="http://schemas.openxmlformats.org/officeDocument/2006/relationships">
   <p:cSld>
     <p:spTree>

</xml_diff>

<commit_message>
Compact top-rules table to fit slide
Co-Authored-By: Claude Fable 5 <noreply@anthropic.com>
</commit_message>
<xml_diff>
--- a/lessons_getting_more_signal_from_snap_qc_data.pptx
+++ b/lessons_getting_more_signal_from_snap_qc_data.pptx
@@ -15519,7 +15519,7 @@
         </p:nvGraphicFramePr>
         <p:xfrm>
           <a:off x="274319" y="1984248"/>
-          <a:ext cx="8595360" cy="4572000"/>
+          <a:ext cx="8595360" cy="3840480"/>
         </p:xfrm>
         <a:graphic>
           <a:graphicData uri="http://schemas.openxmlformats.org/drawingml/2006/table">
@@ -15532,7 +15532,7 @@
                 <a:gridCol w="6766560"/>
                 <a:gridCol w="1097280"/>
               </a:tblGrid>
-              <a:tr h="457200">
+              <a:tr h="384048">
                 <a:tc>
                   <a:txBody>
                     <a:bodyPr/>
@@ -15573,7 +15573,7 @@
                   <a:tcPr marT="9144" marB="9144"/>
                 </a:tc>
               </a:tr>
-              <a:tr h="457200">
+              <a:tr h="384048">
                 <a:tc>
                   <a:txBody>
                     <a:bodyPr/>
@@ -15614,7 +15614,7 @@
                   <a:tcPr marT="9144" marB="9144"/>
                 </a:tc>
               </a:tr>
-              <a:tr h="457200">
+              <a:tr h="384048">
                 <a:tc>
                   <a:txBody>
                     <a:bodyPr/>
@@ -15655,7 +15655,7 @@
                   <a:tcPr marT="9144" marB="9144"/>
                 </a:tc>
               </a:tr>
-              <a:tr h="457200">
+              <a:tr h="384048">
                 <a:tc>
                   <a:txBody>
                     <a:bodyPr/>
@@ -15696,7 +15696,7 @@
                   <a:tcPr marT="9144" marB="9144"/>
                 </a:tc>
               </a:tr>
-              <a:tr h="457200">
+              <a:tr h="384048">
                 <a:tc>
                   <a:txBody>
                     <a:bodyPr/>
@@ -15737,7 +15737,7 @@
                   <a:tcPr marT="9144" marB="9144"/>
                 </a:tc>
               </a:tr>
-              <a:tr h="457200">
+              <a:tr h="384048">
                 <a:tc>
                   <a:txBody>
                     <a:bodyPr/>
@@ -15778,7 +15778,7 @@
                   <a:tcPr marT="9144" marB="9144"/>
                 </a:tc>
               </a:tr>
-              <a:tr h="457200">
+              <a:tr h="384048">
                 <a:tc>
                   <a:txBody>
                     <a:bodyPr/>
@@ -15819,7 +15819,7 @@
                   <a:tcPr marT="9144" marB="9144"/>
                 </a:tc>
               </a:tr>
-              <a:tr h="457200">
+              <a:tr h="384048">
                 <a:tc>
                   <a:txBody>
                     <a:bodyPr/>
@@ -15860,7 +15860,7 @@
                   <a:tcPr marT="9144" marB="9144"/>
                 </a:tc>
               </a:tr>
-              <a:tr h="457200">
+              <a:tr h="384048">
                 <a:tc>
                   <a:txBody>
                     <a:bodyPr/>
@@ -15901,7 +15901,7 @@
                   <a:tcPr marT="9144" marB="9144"/>
                 </a:tc>
               </a:tr>
-              <a:tr h="457200">
+              <a:tr h="384048">
                 <a:tc>
                   <a:txBody>
                     <a:bodyPr/>

</xml_diff>

<commit_message>
Reorganize v1 artifacts: outputs to archive/, studies to methods/
- archive/: exclusion_rules, inclusion_rules_by_hh_size,
  inclusion_rules_combined_hh_sizes, code_for_single_model_combined_HH_sizes
  (v1 outputs and the single-model variant; content unchanged)
- methods/: compare_models_by_HHsize_vs_pooled, parameter_tuning
  (v1-era studies join the other study outputs)
- All script out_dirs, findings artifact pointers, and README/CLAUDE.md
  paths updated. Three CSVs in inclusion_rules_by_hh_size are locked by
  another process and follow in the next commit.

Co-Authored-By: Claude Fable 5 <noreply@anthropic.com>
</commit_message>
<xml_diff>
--- a/lessons_getting_more_signal_from_snap_qc_data.pptx
+++ b/lessons_getting_more_signal_from_snap_qc_data.pptx
@@ -289,7 +289,7 @@
       <p15:sldGuideLst xmlns:p15="http://schemas.microsoft.com/office/powerpoint/2012/main"/>
     </p:ext>
     <p:ext uri="GoogleSlidesCustomDataVersion2">
-      <go:slidesCustomData xmlns="" xmlns:mc="http://schemas.openxmlformats.org/markup-compatibility/2006" xmlns:mv="urn:schemas-microsoft-com:mac:vml" xmlns:c="http://schemas.openxmlformats.org/drawingml/2006/chart" xmlns:dgm="http://schemas.openxmlformats.org/drawingml/2006/diagram" xmlns:o="urn:schemas-microsoft-com:office:office" xmlns:v="urn:schemas-microsoft-com:vml" xmlns:pvml="urn:schemas-microsoft-com:office:powerpoint" xmlns:com="http://schemas.openxmlformats.org/drawingml/2006/compatibility" xmlns:p14="http://schemas.microsoft.com/office/powerpoint/2010/main" xmlns:p15="http://schemas.microsoft.com/office/powerpoint/2012/main" xmlns:ahyp="http://schemas.microsoft.com/office/drawing/2018/hyperlinkcolor" xmlns:go="http://customooxmlschemas.google.com/" r:id="rId50" roundtripDataSignature="AMtx7miHiQSzGui/N0IV2pULBjiL6ibjVA=="/>
+      <go:slidesCustomData xmlns:go="http://customooxmlschemas.google.com/" xmlns:ahyp="http://schemas.microsoft.com/office/drawing/2018/hyperlinkcolor" xmlns:p15="http://schemas.microsoft.com/office/powerpoint/2012/main" xmlns:p14="http://schemas.microsoft.com/office/powerpoint/2010/main" xmlns:com="http://schemas.openxmlformats.org/drawingml/2006/compatibility" xmlns:pvml="urn:schemas-microsoft-com:office:powerpoint" xmlns:v="urn:schemas-microsoft-com:vml" xmlns:o="urn:schemas-microsoft-com:office:office" xmlns:dgm="http://schemas.openxmlformats.org/drawingml/2006/diagram" xmlns:c="http://schemas.openxmlformats.org/drawingml/2006/chart" xmlns:mv="urn:schemas-microsoft-com:mac:vml" xmlns:mc="http://schemas.openxmlformats.org/markup-compatibility/2006" xmlns="" r:id="rId50" roundtripDataSignature="AMtx7miHiQSzGui/N0IV2pULBjiL6ibjVA=="/>
     </p:ext>
   </p:extLst>
 </p:presentation>
@@ -5979,10 +5979,22 @@
               <a:buNone/>
             </a:pPr>
             <a:r>
+              <a:rPr lang="en-US" sz="1100" dirty="0"/>
+              <a:t>- The fix did not rewrite the rules' content: 93% of the previous rule set survived the rebuild - 63% as the same variables and directions with shifted </a:t>
+            </a:r>
+            <a:r>
+              <a:rPr lang="en-US" sz="1100" dirty="0" err="1"/>
+              <a:t>cutpoints</a:t>
+            </a:r>
+            <a:r>
+              <a:rPr lang="en-US" sz="1100" dirty="0"/>
+              <a:t>, 29% matched by a new rule flagging a highly overlapping case set (Jaccard &gt;= 0.5 on the test year), 1% exact; only 7% dropped with no counterpart. | - Nor did the restored cases add a new pattern type: brand-new rules' catches were 34% restored-case vs a 32</a:t>
+            </a:r>
+            <a:r>
               <a:rPr lang="en-US" sz="1100"/>
-              <a:t>- The fix did not rewrite the rules' content: 93% of the previous rule set survived the rebuild - 63% as the same variables and directions with shifted cutpoints, 29% matched by a new rule flagging a highly overlapping case set (Jaccard &gt;= 0.5 on the test year), 1% exact; only 7% dropped with no counterpart. | - Nor did the restored cases add a new pattern type: brand-new rules' catches were 34% restored-case vs a 32% base - the gain was statistical power, not different signal. </a:t>
-            </a:r>
-            <a:endParaRPr/>
+              <a:t>% base. </a:t>
+            </a:r>
+            <a:endParaRPr dirty="0"/>
           </a:p>
         </p:txBody>
       </p:sp>
@@ -18194,7 +18206,7 @@
               <a:buAutoNum type="arabicParenR"/>
             </a:pPr>
             <a:r>
-              <a:rPr lang="en-US" sz="1400" b="0" i="0" u="none" strike="noStrike" cap="none">
+              <a:rPr lang="en-US" sz="1400" b="0" i="0" u="none" strike="noStrike" cap="none" dirty="0">
                 <a:solidFill>
                   <a:srgbClr val="000000"/>
                 </a:solidFill>
@@ -18205,7 +18217,7 @@
               </a:rPr>
               <a:t>Apply a frozen, ranked rule list to your FY25/26 cases and tell us the hit rate. No modeling, no re-training. The list was mined on all states' 2022-24 public QC data. </a:t>
             </a:r>
-            <a:endParaRPr/>
+            <a:endParaRPr dirty="0"/>
           </a:p>
           <a:p>
             <a:pPr marL="914400" marR="0" lvl="1" indent="-317500" algn="l" rtl="0">
@@ -18226,7 +18238,7 @@
               <a:buAutoNum type="alphaLcParenR"/>
             </a:pPr>
             <a:r>
-              <a:rPr lang="en-US" sz="1400" b="0" i="0" u="none" strike="noStrike" cap="none">
+              <a:rPr lang="en-US" sz="1400" b="0" i="0" u="none" strike="noStrike" cap="none" dirty="0">
                 <a:solidFill>
                   <a:srgbClr val="000000"/>
                 </a:solidFill>
@@ -18237,7 +18249,7 @@
               </a:rPr>
               <a:t>The approach has been tested by mining rules from 2022-23 and testing on 2024: </a:t>
             </a:r>
-            <a:endParaRPr/>
+            <a:endParaRPr dirty="0"/>
           </a:p>
           <a:p>
             <a:pPr marL="1371600" marR="0" lvl="2" indent="-317500" algn="l" rtl="0">
@@ -18258,11 +18270,11 @@
               <a:buAutoNum type="romanLcParenR"/>
             </a:pPr>
             <a:r>
-              <a:rPr lang="en-US"/>
+              <a:rPr lang="en-US" dirty="0"/>
               <a:t>M</a:t>
             </a:r>
             <a:r>
-              <a:rPr lang="en-US" sz="1400" b="0" i="0" u="none" strike="noStrike" cap="none">
+              <a:rPr lang="en-US" sz="1400" b="0" i="0" u="none" strike="noStrike" cap="none" dirty="0">
                 <a:solidFill>
                   <a:srgbClr val="000000"/>
                 </a:solidFill>
@@ -18273,7 +18285,7 @@
               </a:rPr>
               <a:t>edian precision 0.27-0.30 at 5-10% review budgets, against state base error rates of 8-17%.</a:t>
             </a:r>
-            <a:endParaRPr/>
+            <a:endParaRPr dirty="0"/>
           </a:p>
           <a:p>
             <a:pPr marL="1371600" marR="0" lvl="2" indent="-317500" algn="l" rtl="0">
@@ -18294,7 +18306,7 @@
               <a:buAutoNum type="romanLcParenR"/>
             </a:pPr>
             <a:r>
-              <a:rPr lang="en-US" sz="1400" b="0" i="0" u="none" strike="noStrike" cap="none">
+              <a:rPr lang="en-US" sz="1400" b="0" i="0" u="none" strike="noStrike" cap="none" dirty="0">
                 <a:solidFill>
                   <a:srgbClr val="000000"/>
                 </a:solidFill>
@@ -18305,7 +18317,7 @@
               </a:rPr>
               <a:t>Recall of 15-24% error dollars at 5-10% caseload review budgets. </a:t>
             </a:r>
-            <a:endParaRPr/>
+            <a:endParaRPr dirty="0"/>
           </a:p>
           <a:p>
             <a:pPr marL="1371600" marR="0" lvl="2" indent="-317500" algn="l" rtl="0">
@@ -18326,7 +18338,7 @@
               <a:buAutoNum type="romanLcParenR"/>
             </a:pPr>
             <a:r>
-              <a:rPr lang="en-US" sz="1400" b="0" i="0" u="none" strike="noStrike" cap="none">
+              <a:rPr lang="en-US" sz="1400" b="0" i="0" u="none" strike="noStrike" cap="none" dirty="0">
                 <a:solidFill>
                   <a:srgbClr val="000000"/>
                 </a:solidFill>
@@ -18337,7 +18349,7 @@
               </a:rPr>
               <a:t>All 18 states tested cleared their base rate: the rules found 1.5-3.4x the errors that unaided review of the same volume finds.</a:t>
             </a:r>
-            <a:endParaRPr sz="1400" b="0" i="0" u="none" strike="noStrike" cap="none">
+            <a:endParaRPr sz="1400" b="0" i="0" u="none" strike="noStrike" cap="none" dirty="0">
               <a:solidFill>
                 <a:srgbClr val="000000"/>
               </a:solidFill>
@@ -18362,10 +18374,10 @@
               <a:buAutoNum type="arabicParenR"/>
             </a:pPr>
             <a:r>
-              <a:rPr lang="en-US"/>
+              <a:rPr lang="en-US" dirty="0"/>
               <a:t>Use the code yourself! Could combine your state’s data with national qc data (also in the repo). </a:t>
             </a:r>
-            <a:endParaRPr/>
+            <a:endParaRPr dirty="0"/>
           </a:p>
           <a:p>
             <a:pPr marL="0" marR="0" lvl="0" indent="0" algn="l" rtl="0">
@@ -18380,7 +18392,7 @@
               </a:spcAft>
               <a:buNone/>
             </a:pPr>
-            <a:endParaRPr/>
+            <a:endParaRPr dirty="0"/>
           </a:p>
           <a:p>
             <a:pPr marL="0" marR="0" lvl="0" indent="0" algn="l" rtl="0">
@@ -18395,7 +18407,7 @@
               </a:spcAft>
               <a:buNone/>
             </a:pPr>
-            <a:endParaRPr/>
+            <a:endParaRPr dirty="0"/>
           </a:p>
           <a:p>
             <a:pPr marL="0" marR="0" lvl="0" indent="0" algn="l" rtl="0">
@@ -18410,7 +18422,7 @@
               </a:spcAft>
               <a:buNone/>
             </a:pPr>
-            <a:endParaRPr/>
+            <a:endParaRPr dirty="0"/>
           </a:p>
           <a:p>
             <a:pPr marL="0" marR="0" lvl="0" indent="0" algn="l" rtl="0">
@@ -18426,7 +18438,7 @@
               <a:buNone/>
             </a:pPr>
             <a:r>
-              <a:rPr lang="en-US" sz="1200" b="0" i="0" u="none" strike="noStrike" cap="none">
+              <a:rPr lang="en-US" sz="1200" b="0" i="0" u="none" strike="noStrike" cap="none" dirty="0">
                 <a:solidFill>
                   <a:srgbClr val="000000"/>
                 </a:solidFill>
@@ -18435,9 +18447,57 @@
                 <a:cs typeface="Arial"/>
                 <a:sym typeface="Arial"/>
               </a:rPr>
-              <a:t>Code and findings: github.com/giannella/snap_qc (methods/modeling_findings.md)</a:t>
-            </a:r>
-            <a:endParaRPr/>
+              <a:t>Code and findings: github.com/</a:t>
+            </a:r>
+            <a:r>
+              <a:rPr lang="en-US" sz="1200" b="0" i="0" u="none" strike="noStrike" cap="none" dirty="0" err="1">
+                <a:solidFill>
+                  <a:srgbClr val="000000"/>
+                </a:solidFill>
+                <a:latin typeface="Arial"/>
+                <a:ea typeface="Arial"/>
+                <a:cs typeface="Arial"/>
+                <a:sym typeface="Arial"/>
+              </a:rPr>
+              <a:t>giannella</a:t>
+            </a:r>
+            <a:r>
+              <a:rPr lang="en-US" sz="1200" b="0" i="0" u="none" strike="noStrike" cap="none" dirty="0">
+                <a:solidFill>
+                  <a:srgbClr val="000000"/>
+                </a:solidFill>
+                <a:latin typeface="Arial"/>
+                <a:ea typeface="Arial"/>
+                <a:cs typeface="Arial"/>
+                <a:sym typeface="Arial"/>
+              </a:rPr>
+              <a:t>/</a:t>
+            </a:r>
+            <a:r>
+              <a:rPr lang="en-US" sz="1200" b="0" i="0" u="none" strike="noStrike" cap="none" dirty="0" err="1">
+                <a:solidFill>
+                  <a:srgbClr val="000000"/>
+                </a:solidFill>
+                <a:latin typeface="Arial"/>
+                <a:ea typeface="Arial"/>
+                <a:cs typeface="Arial"/>
+                <a:sym typeface="Arial"/>
+              </a:rPr>
+              <a:t>snap_qc</a:t>
+            </a:r>
+            <a:r>
+              <a:rPr lang="en-US" sz="1200" b="0" i="0" u="none" strike="noStrike" cap="none" dirty="0">
+                <a:solidFill>
+                  <a:srgbClr val="000000"/>
+                </a:solidFill>
+                <a:latin typeface="Arial"/>
+                <a:ea typeface="Arial"/>
+                <a:cs typeface="Arial"/>
+                <a:sym typeface="Arial"/>
+              </a:rPr>
+              <a:t> (methods/modeling_findings.md)</a:t>
+            </a:r>
+            <a:endParaRPr dirty="0"/>
           </a:p>
         </p:txBody>
       </p:sp>

</xml_diff>